<commit_message>
Add transcript clustering experiment
</commit_message>
<xml_diff>
--- a/interview-assignment/deliverables/Transcript_Intelligence_Leadership_Deck.pptx
+++ b/interview-assignment/deliverables/Transcript_Intelligence_Leadership_Deck.pptx
@@ -14,9 +14,10 @@
     <p:sldId id="262" r:id="rId8"/>
     <p:sldId id="263" r:id="rId9"/>
     <p:sldId id="264" r:id="rId10"/>
+    <p:sldId id="265" r:id="rId11"/>
   </p:sldIdLst>
   <p:notesMasterIdLst>
-    <p:notesMasterId r:id="rId11"/>
+    <p:notesMasterId r:id="rId12"/>
   </p:notesMasterIdLst>
   <p:sldSz cx="12191695" cy="6858000"/>
   <p:notesSz cx="6858000" cy="12191695"/>
@@ -534,6 +535,94 @@
             <a:fld id="{F7021451-1387-4CA6-816F-3879F97B5CBC}" type="slidenum">
               <a:rPr lang="en-US"/>
               <a:t>1</a:t>
+            </a:fld>
+            <a:endParaRPr lang="en-US"/>
+          </a:p>
+        </p:txBody>
+      </p:sp>
+    </p:spTree>
+    <p:extLst>
+      <p:ext uri="{BB962C8B-B14F-4D97-AF65-F5344CB8AC3E}">
+        <p14:creationId xmlns:p14="http://schemas.microsoft.com/office/powerpoint/2010/main" val="1024086991"/>
+      </p:ext>
+    </p:extLst>
+  </p:cSld>
+  <p:clrMapOvr>
+    <a:masterClrMapping/>
+  </p:clrMapOvr>
+</p:notes>
+</file>
+
+<file path=ppt/notesSlides/notesSlide10.xml><?xml version="1.0" encoding="utf-8"?>
+<p:notes xmlns:a="http://schemas.openxmlformats.org/drawingml/2006/main" xmlns:r="http://schemas.openxmlformats.org/officeDocument/2006/relationships" xmlns:p="http://schemas.openxmlformats.org/presentationml/2006/main">
+  <p:cSld>
+    <p:spTree>
+      <p:nvGrpSpPr>
+        <p:cNvPr id="1" name=""/>
+        <p:cNvGrpSpPr/>
+        <p:nvPr/>
+      </p:nvGrpSpPr>
+      <p:grpSpPr>
+        <a:xfrm>
+          <a:off x="0" y="0"/>
+          <a:ext cx="0" cy="0"/>
+          <a:chOff x="0" y="0"/>
+          <a:chExt cx="0" cy="0"/>
+        </a:xfrm>
+      </p:grpSpPr>
+      <p:sp>
+        <p:nvSpPr>
+          <p:cNvPr id="2" name="Slide Image Placeholder 1"/>
+          <p:cNvSpPr>
+            <a:spLocks noGrp="1" noRot="1" noChangeAspect="1"/>
+          </p:cNvSpPr>
+          <p:nvPr>
+            <p:ph type="sldImg"/>
+          </p:nvPr>
+        </p:nvSpPr>
+        <p:spPr/>
+      </p:sp>
+      <p:sp>
+        <p:nvSpPr>
+          <p:cNvPr id="3" name="Notes Placeholder 2"/>
+          <p:cNvSpPr>
+            <a:spLocks noGrp="1"/>
+          </p:cNvSpPr>
+          <p:nvPr>
+            <p:ph type="body" idx="1"/>
+          </p:nvPr>
+        </p:nvSpPr>
+        <p:spPr/>
+        <p:txBody>
+          <a:bodyPr/>
+          <a:lstStyle/>
+          <a:p>
+            <a:r>
+              <a:rPr lang="en-US" dirty="0"/>
+              <a:t/>
+            </a:r>
+            <a:endParaRPr lang="en-US" dirty="0"/>
+          </a:p>
+        </p:txBody>
+      </p:sp>
+      <p:sp>
+        <p:nvSpPr>
+          <p:cNvPr id="4" name="Slide Number Placeholder 3"/>
+          <p:cNvSpPr>
+            <a:spLocks noGrp="1"/>
+          </p:cNvSpPr>
+          <p:nvPr>
+            <p:ph type="sldNum" sz="quarter" idx="10"/>
+          </p:nvPr>
+        </p:nvSpPr>
+        <p:spPr/>
+        <p:txBody>
+          <a:bodyPr/>
+          <a:lstStyle/>
+          <a:p>
+            <a:fld id="{F7021451-1387-4CA6-816F-3879F97B5CBC}" type="slidenum">
+              <a:rPr lang="en-US"/>
+              <a:t>10</a:t>
             </a:fld>
             <a:endParaRPr lang="en-US"/>
           </a:p>
@@ -2296,6 +2385,379 @@
 </p:sld>
 </file>
 
+<file path=ppt/slides/slide10.xml><?xml version="1.0" encoding="utf-8"?>
+<p:sld xmlns:a="http://schemas.openxmlformats.org/drawingml/2006/main" xmlns:r="http://schemas.openxmlformats.org/officeDocument/2006/relationships" xmlns:p="http://schemas.openxmlformats.org/presentationml/2006/main">
+  <p:cSld name="Slide 10">
+    <p:bg>
+      <p:bgPr>
+        <a:solidFill>
+          <a:srgbClr val="F7F4ED"/>
+        </a:solidFill>
+      </p:bgPr>
+    </p:bg>
+    <p:spTree>
+      <p:nvGrpSpPr>
+        <p:cNvPr id="1" name=""/>
+        <p:cNvGrpSpPr/>
+        <p:nvPr/>
+      </p:nvGrpSpPr>
+      <p:grpSpPr>
+        <a:xfrm>
+          <a:off x="0" y="0"/>
+          <a:ext cx="0" cy="0"/>
+          <a:chOff x="0" y="0"/>
+          <a:chExt cx="0" cy="0"/>
+        </a:xfrm>
+      </p:grpSpPr>
+      <p:sp>
+        <p:nvSpPr>
+          <p:cNvPr id="2" name="Text 0"/>
+          <p:cNvSpPr/>
+          <p:nvPr/>
+        </p:nvSpPr>
+        <p:spPr>
+          <a:xfrm>
+            <a:off x="502920" y="292608"/>
+            <a:ext cx="4114800" cy="256032"/>
+          </a:xfrm>
+          <a:prstGeom prst="rect">
+            <a:avLst/>
+          </a:prstGeom>
+          <a:noFill/>
+          <a:ln/>
+        </p:spPr>
+        <p:txBody>
+          <a:bodyPr wrap="square" rtlCol="0" anchor="ctr"/>
+          <a:lstStyle/>
+          <a:p>
+            <a:pPr indent="0" marL="0">
+              <a:buNone/>
+            </a:pPr>
+            <a:r>
+              <a:rPr lang="en-US" sz="900" b="1" dirty="0">
+                <a:solidFill>
+                  <a:srgbClr val="2F6F73"/>
+                </a:solidFill>
+                <a:latin typeface="Aptos" pitchFamily="34" charset="0"/>
+                <a:ea typeface="Aptos" pitchFamily="34" charset="-122"/>
+                <a:cs typeface="Aptos" pitchFamily="34" charset="-120"/>
+              </a:rPr>
+              <a:t>TRANSCRIPT INTELLIGENCE</a:t>
+            </a:r>
+            <a:endParaRPr lang="en-US" sz="900" dirty="0"/>
+          </a:p>
+        </p:txBody>
+      </p:sp>
+      <p:sp>
+        <p:nvSpPr>
+          <p:cNvPr id="3" name="Text 1"/>
+          <p:cNvSpPr/>
+          <p:nvPr/>
+        </p:nvSpPr>
+        <p:spPr>
+          <a:xfrm>
+            <a:off x="502920" y="640080"/>
+            <a:ext cx="10789920" cy="685800"/>
+          </a:xfrm>
+          <a:prstGeom prst="rect">
+            <a:avLst/>
+          </a:prstGeom>
+          <a:noFill/>
+          <a:ln/>
+        </p:spPr>
+        <p:txBody>
+          <a:bodyPr wrap="square" lIns="0" tIns="0" rIns="0" bIns="0" rtlCol="0" anchor="ctr">
+            <a:normAutofit/>
+          </a:bodyPr>
+          <a:lstStyle/>
+          <a:p>
+            <a:pPr indent="0" marL="0">
+              <a:buNone/>
+            </a:pPr>
+            <a:r>
+              <a:rPr lang="en-US" sz="2800" b="1" dirty="0">
+                <a:solidFill>
+                  <a:srgbClr val="172322"/>
+                </a:solidFill>
+                <a:latin typeface="Aptos Display" pitchFamily="34" charset="0"/>
+                <a:ea typeface="Aptos Display" pitchFamily="34" charset="-122"/>
+                <a:cs typeface="Aptos Display" pitchFamily="34" charset="-120"/>
+              </a:rPr>
+              <a:t>Recommended next build</a:t>
+            </a:r>
+            <a:endParaRPr lang="en-US" sz="2800" dirty="0"/>
+          </a:p>
+        </p:txBody>
+      </p:sp>
+      <p:sp>
+        <p:nvSpPr>
+          <p:cNvPr id="4" name="Text 2"/>
+          <p:cNvSpPr/>
+          <p:nvPr/>
+        </p:nvSpPr>
+        <p:spPr>
+          <a:xfrm>
+            <a:off x="822960" y="1691640"/>
+            <a:ext cx="5852160" cy="2194560"/>
+          </a:xfrm>
+          <a:prstGeom prst="rect">
+            <a:avLst/>
+          </a:prstGeom>
+          <a:noFill/>
+          <a:ln/>
+        </p:spPr>
+        <p:txBody>
+          <a:bodyPr wrap="square" lIns="508" tIns="508" rIns="508" bIns="508" rtlCol="0" anchor="ctr">
+            <a:normAutofit/>
+          </a:bodyPr>
+          <a:lstStyle/>
+          <a:p>
+            <a:r>
+              <a:rPr lang="en-US" sz="1800" dirty="0">
+                <a:solidFill>
+                  <a:srgbClr val="172322"/>
+                </a:solidFill>
+              </a:rPr>
+              <a:t>Ship a theme and risk dashboard for Detect reliability first.</a:t>
+            </a:r>
+            <a:endParaRPr lang="en-US" sz="1800" dirty="0"/>
+          </a:p>
+          <a:p>
+            <a:r>
+              <a:rPr lang="en-US" sz="1800" dirty="0">
+                <a:solidFill>
+                  <a:srgbClr val="172322"/>
+                </a:solidFill>
+              </a:rPr>
+              <a:t>Add account-level revenue risk overlays for renewal and competitive calls.</a:t>
+            </a:r>
+            <a:endParaRPr lang="en-US" sz="1800" dirty="0"/>
+          </a:p>
+          <a:p>
+            <a:r>
+              <a:rPr lang="en-US" sz="1800" dirty="0">
+                <a:solidFill>
+                  <a:srgbClr val="172322"/>
+                </a:solidFill>
+              </a:rPr>
+              <a:t>Add owner extraction so action items become trackable workflow, not static notes.</a:t>
+            </a:r>
+            <a:endParaRPr lang="en-US" sz="1800" dirty="0"/>
+          </a:p>
+          <a:p>
+            <a:r>
+              <a:rPr lang="en-US" sz="1800" dirty="0">
+                <a:solidFill>
+                  <a:srgbClr val="172322"/>
+                </a:solidFill>
+              </a:rPr>
+              <a:t>Upgrade classifier with embeddings or LLM labels, keeping the rule layer as explainable QA.</a:t>
+            </a:r>
+            <a:endParaRPr lang="en-US" sz="1800" dirty="0"/>
+          </a:p>
+        </p:txBody>
+      </p:sp>
+      <p:sp>
+        <p:nvSpPr>
+          <p:cNvPr id="5" name="Shape 3"/>
+          <p:cNvSpPr/>
+          <p:nvPr/>
+        </p:nvSpPr>
+        <p:spPr>
+          <a:xfrm>
+            <a:off x="7315200" y="1645920"/>
+            <a:ext cx="3291840" cy="3108960"/>
+          </a:xfrm>
+          <a:prstGeom prst="roundRect">
+            <a:avLst>
+              <a:gd name="adj" fmla="val 2353"/>
+            </a:avLst>
+          </a:prstGeom>
+          <a:solidFill>
+            <a:srgbClr val="FFFFFF"/>
+          </a:solidFill>
+          <a:ln w="12700">
+            <a:solidFill>
+              <a:srgbClr val="D8D1C3"/>
+            </a:solidFill>
+            <a:prstDash val="solid"/>
+          </a:ln>
+        </p:spPr>
+      </p:sp>
+      <p:sp>
+        <p:nvSpPr>
+          <p:cNvPr id="6" name="Text 4"/>
+          <p:cNvSpPr/>
+          <p:nvPr/>
+        </p:nvSpPr>
+        <p:spPr>
+          <a:xfrm>
+            <a:off x="7635240" y="1920240"/>
+            <a:ext cx="2011680" cy="274320"/>
+          </a:xfrm>
+          <a:prstGeom prst="rect">
+            <a:avLst/>
+          </a:prstGeom>
+          <a:noFill/>
+          <a:ln/>
+        </p:spPr>
+        <p:txBody>
+          <a:bodyPr wrap="square" lIns="0" tIns="0" rIns="0" bIns="0" rtlCol="0" anchor="ctr"/>
+          <a:lstStyle/>
+          <a:p>
+            <a:pPr indent="0" marL="0">
+              <a:buNone/>
+            </a:pPr>
+            <a:r>
+              <a:rPr lang="en-US" sz="1800" b="1" dirty="0">
+                <a:solidFill>
+                  <a:srgbClr val="172322"/>
+                </a:solidFill>
+              </a:rPr>
+              <a:t>Demo path</a:t>
+            </a:r>
+            <a:endParaRPr lang="en-US" sz="1800" dirty="0"/>
+          </a:p>
+        </p:txBody>
+      </p:sp>
+      <p:sp>
+        <p:nvSpPr>
+          <p:cNvPr id="7" name="Text 5"/>
+          <p:cNvSpPr/>
+          <p:nvPr/>
+        </p:nvSpPr>
+        <p:spPr>
+          <a:xfrm>
+            <a:off x="7635240" y="2423160"/>
+            <a:ext cx="2560320" cy="1554480"/>
+          </a:xfrm>
+          <a:prstGeom prst="rect">
+            <a:avLst/>
+          </a:prstGeom>
+          <a:noFill/>
+          <a:ln/>
+        </p:spPr>
+        <p:txBody>
+          <a:bodyPr wrap="square" lIns="0" tIns="0" rIns="0" bIns="0" rtlCol="0" anchor="ctr">
+            <a:normAutofit/>
+          </a:bodyPr>
+          <a:lstStyle/>
+          <a:p>
+            <a:pPr indent="0" marL="0">
+              <a:buNone/>
+            </a:pPr>
+            <a:r>
+              <a:rPr lang="en-US" sz="1500" dirty="0">
+                <a:solidFill>
+                  <a:srgbClr val="172322"/>
+                </a:solidFill>
+              </a:rPr>
+              <a:t>1. Run src/analyze_transcripts.py</a:t>
+            </a:r>
+            <a:endParaRPr lang="en-US" sz="1500" dirty="0"/>
+          </a:p>
+          <a:p>
+            <a:pPr indent="0" marL="0">
+              <a:buNone/>
+            </a:pPr>
+            <a:r>
+              <a:rPr lang="en-US" sz="1500" dirty="0">
+                <a:solidFill>
+                  <a:srgbClr val="172322"/>
+                </a:solidFill>
+              </a:rPr>
+              <a:t>2. Open outputs/dashboard.html</a:t>
+            </a:r>
+            <a:endParaRPr lang="en-US" sz="1500" dirty="0"/>
+          </a:p>
+          <a:p>
+            <a:pPr indent="0" marL="0">
+              <a:buNone/>
+            </a:pPr>
+            <a:r>
+              <a:rPr lang="en-US" sz="1500" dirty="0">
+                <a:solidFill>
+                  <a:srgbClr val="172322"/>
+                </a:solidFill>
+              </a:rPr>
+              <a:t>3. Review analysis_report.md</a:t>
+            </a:r>
+            <a:endParaRPr lang="en-US" sz="1500" dirty="0"/>
+          </a:p>
+          <a:p>
+            <a:pPr indent="0" marL="0">
+              <a:buNone/>
+            </a:pPr>
+            <a:r>
+              <a:rPr lang="en-US" sz="1500" dirty="0">
+                <a:solidFill>
+                  <a:srgbClr val="172322"/>
+                </a:solidFill>
+              </a:rPr>
+              <a:t>4. Walk through this deck</a:t>
+            </a:r>
+            <a:endParaRPr lang="en-US" sz="1500" dirty="0"/>
+          </a:p>
+          <a:p>
+            <a:pPr indent="0" marL="0">
+              <a:buNone/>
+            </a:pPr>
+            <a:r>
+              <a:rPr lang="en-US" sz="1500" dirty="0">
+                <a:solidFill>
+                  <a:srgbClr val="172322"/>
+                </a:solidFill>
+              </a:rPr>
+              <a:t>5. Show highest-risk CSV rows</a:t>
+            </a:r>
+            <a:endParaRPr lang="en-US" sz="1500" dirty="0"/>
+          </a:p>
+        </p:txBody>
+      </p:sp>
+      <p:sp>
+        <p:nvSpPr>
+          <p:cNvPr id="8" name="Text 6"/>
+          <p:cNvSpPr/>
+          <p:nvPr/>
+        </p:nvSpPr>
+        <p:spPr>
+          <a:xfrm>
+            <a:off x="502920" y="6473952"/>
+            <a:ext cx="8686800" cy="164592"/>
+          </a:xfrm>
+          <a:prstGeom prst="rect">
+            <a:avLst/>
+          </a:prstGeom>
+          <a:noFill/>
+          <a:ln/>
+        </p:spPr>
+        <p:txBody>
+          <a:bodyPr wrap="square" lIns="0" tIns="0" rIns="0" bIns="0" rtlCol="0" anchor="ctr"/>
+          <a:lstStyle/>
+          <a:p>
+            <a:pPr indent="0" marL="0">
+              <a:buNone/>
+            </a:pPr>
+            <a:r>
+              <a:rPr lang="en-US" sz="700" dirty="0">
+                <a:solidFill>
+                  <a:srgbClr val="66716A"/>
+                </a:solidFill>
+              </a:rPr>
+              <a:t>Source: 100 provided transcript folders; generated by src/analyze_transcripts.py</a:t>
+            </a:r>
+            <a:endParaRPr lang="en-US" sz="700" dirty="0"/>
+          </a:p>
+        </p:txBody>
+      </p:sp>
+    </p:spTree>
+  </p:cSld>
+  <p:clrMapOvr>
+    <a:masterClrMapping/>
+  </p:clrMapOvr>
+</p:sld>
+</file>
+
 <file path=ppt/slides/slide2.xml><?xml version="1.0" encoding="utf-8"?>
 <p:sld xmlns:a="http://schemas.openxmlformats.org/drawingml/2006/main" xmlns:r="http://schemas.openxmlformats.org/officeDocument/2006/relationships" xmlns:p="http://schemas.openxmlformats.org/presentationml/2006/main">
   <p:cSld name="Slide 2">
@@ -7263,7 +7725,7 @@
                 <a:ea typeface="Aptos Display" pitchFamily="34" charset="-122"/>
                 <a:cs typeface="Aptos Display" pitchFamily="34" charset="-120"/>
               </a:rPr>
-              <a:t>Three insight products would make this valuable beyond analysis</a:t>
+              <a:t>A lightweight clustering experiment validates and challenges the taxonomy</a:t>
             </a:r>
             <a:endParaRPr lang="en-US" sz="2800" dirty="0"/>
           </a:p>
@@ -7271,26 +7733,66 @@
       </p:sp>
       <p:sp>
         <p:nvSpPr>
-          <p:cNvPr id="4" name="Shape 2"/>
-          <p:cNvSpPr/>
-          <p:nvPr/>
-        </p:nvSpPr>
-        <p:spPr>
-          <a:xfrm>
-            <a:off x="685800" y="1645920"/>
-            <a:ext cx="3337560" cy="1051560"/>
+          <p:cNvPr id="4" name="Text 2"/>
+          <p:cNvSpPr/>
+          <p:nvPr/>
+        </p:nvSpPr>
+        <p:spPr>
+          <a:xfrm>
+            <a:off x="685800" y="1545336"/>
+            <a:ext cx="2286000" cy="201168"/>
+          </a:xfrm>
+          <a:prstGeom prst="rect">
+            <a:avLst/>
+          </a:prstGeom>
+          <a:noFill/>
+          <a:ln/>
+        </p:spPr>
+        <p:txBody>
+          <a:bodyPr wrap="square" lIns="0" tIns="0" rIns="0" bIns="0" rtlCol="0" anchor="ctr">
+            <a:normAutofit/>
+          </a:bodyPr>
+          <a:lstStyle/>
+          <a:p>
+            <a:pPr indent="0" marL="0">
+              <a:buNone/>
+            </a:pPr>
+            <a:r>
+              <a:rPr lang="en-US" sz="950" dirty="0">
+                <a:solidFill>
+                  <a:srgbClr val="172322"/>
+                </a:solidFill>
+              </a:rPr>
+              <a:t>C5: Pci</a:t>
+            </a:r>
+            <a:endParaRPr lang="en-US" sz="950" dirty="0"/>
+          </a:p>
+        </p:txBody>
+      </p:sp>
+      <p:sp>
+        <p:nvSpPr>
+          <p:cNvPr id="5" name="Shape 3"/>
+          <p:cNvSpPr/>
+          <p:nvPr/>
+        </p:nvSpPr>
+        <p:spPr>
+          <a:xfrm>
+            <a:off x="3063240" y="1545336"/>
+            <a:ext cx="3794760" cy="256032"/>
           </a:xfrm>
           <a:prstGeom prst="roundRect">
             <a:avLst>
-              <a:gd name="adj" fmla="val 6957"/>
+              <a:gd name="adj" fmla="val 28571"/>
             </a:avLst>
           </a:prstGeom>
           <a:solidFill>
-            <a:srgbClr val="FFFFFF"/>
+            <a:srgbClr val="4F7B58"/>
           </a:solidFill>
           <a:ln w="12700">
             <a:solidFill>
-              <a:srgbClr val="D8D1C3"/>
+              <a:srgbClr val="4F7B58">
+                <a:alpha val="0"/>
+              </a:srgbClr>
             </a:solidFill>
             <a:prstDash val="solid"/>
           </a:ln>
@@ -7298,77 +7800,39 @@
       </p:sp>
       <p:sp>
         <p:nvSpPr>
-          <p:cNvPr id="5" name="Text 3"/>
-          <p:cNvSpPr/>
-          <p:nvPr/>
-        </p:nvSpPr>
-        <p:spPr>
-          <a:xfrm>
-            <a:off x="886968" y="1810512"/>
-            <a:ext cx="1005840" cy="347472"/>
-          </a:xfrm>
-          <a:prstGeom prst="rect">
-            <a:avLst/>
-          </a:prstGeom>
-          <a:noFill/>
-          <a:ln/>
-        </p:spPr>
-        <p:txBody>
-          <a:bodyPr wrap="square" lIns="0" tIns="0" rIns="0" bIns="0" rtlCol="0" anchor="ctr">
-            <a:normAutofit/>
-          </a:bodyPr>
-          <a:lstStyle/>
-          <a:p>
-            <a:pPr indent="0" marL="0">
-              <a:buNone/>
-            </a:pPr>
-            <a:r>
-              <a:rPr lang="en-US" sz="2400" b="1" dirty="0">
-                <a:solidFill>
-                  <a:srgbClr val="2F6F73"/>
-                </a:solidFill>
-              </a:rPr>
-              <a:t>1</a:t>
-            </a:r>
-            <a:endParaRPr lang="en-US" sz="2400" dirty="0"/>
-          </a:p>
-        </p:txBody>
-      </p:sp>
-      <p:sp>
-        <p:nvSpPr>
           <p:cNvPr id="6" name="Text 4"/>
           <p:cNvSpPr/>
           <p:nvPr/>
         </p:nvSpPr>
         <p:spPr>
           <a:xfrm>
-            <a:off x="1892808" y="1810512"/>
-            <a:ext cx="1828800" cy="182880"/>
-          </a:xfrm>
-          <a:prstGeom prst="rect">
-            <a:avLst/>
-          </a:prstGeom>
-          <a:noFill/>
-          <a:ln/>
-        </p:spPr>
-        <p:txBody>
-          <a:bodyPr wrap="square" lIns="0" tIns="0" rIns="0" bIns="0" rtlCol="0" anchor="ctr">
-            <a:normAutofit/>
-          </a:bodyPr>
-          <a:lstStyle/>
-          <a:p>
-            <a:pPr indent="0" marL="0">
-              <a:buNone/>
-            </a:pPr>
-            <a:r>
-              <a:rPr lang="en-US" sz="900" b="1" dirty="0">
-                <a:solidFill>
-                  <a:srgbClr val="66716A"/>
-                </a:solidFill>
-              </a:rPr>
-              <a:t>Sales / CS</a:t>
-            </a:r>
-            <a:endParaRPr lang="en-US" sz="900" dirty="0"/>
+            <a:off x="6967728" y="1581912"/>
+            <a:ext cx="594360" cy="164592"/>
+          </a:xfrm>
+          <a:prstGeom prst="rect">
+            <a:avLst/>
+          </a:prstGeom>
+          <a:noFill/>
+          <a:ln/>
+        </p:spPr>
+        <p:txBody>
+          <a:bodyPr wrap="square" lIns="0" tIns="0" rIns="0" bIns="0" rtlCol="0" anchor="ctr">
+            <a:normAutofit/>
+          </a:bodyPr>
+          <a:lstStyle/>
+          <a:p>
+            <a:pPr indent="0" marL="0">
+              <a:buNone/>
+            </a:pPr>
+            <a:r>
+              <a:rPr lang="en-US" sz="850" b="1" dirty="0">
+                <a:solidFill>
+                  <a:srgbClr val="172322"/>
+                </a:solidFill>
+              </a:rPr>
+              <a:t>21</a:t>
+            </a:r>
+            <a:endParaRPr lang="en-US" sz="850" dirty="0"/>
           </a:p>
         </p:txBody>
       </p:sp>
@@ -7380,33 +7844,33 @@
         </p:nvSpPr>
         <p:spPr>
           <a:xfrm>
-            <a:off x="1892808" y="2084832"/>
-            <a:ext cx="1828800" cy="411480"/>
-          </a:xfrm>
-          <a:prstGeom prst="rect">
-            <a:avLst/>
-          </a:prstGeom>
-          <a:noFill/>
-          <a:ln/>
-        </p:spPr>
-        <p:txBody>
-          <a:bodyPr wrap="square" lIns="254" tIns="254" rIns="254" bIns="254" rtlCol="0" anchor="ctr">
-            <a:normAutofit/>
-          </a:bodyPr>
-          <a:lstStyle/>
-          <a:p>
-            <a:pPr indent="0" marL="0">
-              <a:buNone/>
-            </a:pPr>
-            <a:r>
-              <a:rPr lang="en-US" sz="1100" dirty="0">
-                <a:solidFill>
-                  <a:srgbClr val="172322"/>
-                </a:solidFill>
-              </a:rPr>
-              <a:t>Revenue risk heatmap: renewal language + competitor mentions + negative sentiment.</a:t>
-            </a:r>
-            <a:endParaRPr lang="en-US" sz="1100" dirty="0"/>
+            <a:off x="685800" y="2107039"/>
+            <a:ext cx="2286000" cy="201168"/>
+          </a:xfrm>
+          <a:prstGeom prst="rect">
+            <a:avLst/>
+          </a:prstGeom>
+          <a:noFill/>
+          <a:ln/>
+        </p:spPr>
+        <p:txBody>
+          <a:bodyPr wrap="square" lIns="0" tIns="0" rIns="0" bIns="0" rtlCol="0" anchor="ctr">
+            <a:normAutofit/>
+          </a:bodyPr>
+          <a:lstStyle/>
+          <a:p>
+            <a:pPr indent="0" marL="0">
+              <a:buNone/>
+            </a:pPr>
+            <a:r>
+              <a:rPr lang="en-US" sz="950" dirty="0">
+                <a:solidFill>
+                  <a:srgbClr val="172322"/>
+                </a:solidFill>
+              </a:rPr>
+              <a:t>C2: Failure</a:t>
+            </a:r>
+            <a:endParaRPr lang="en-US" sz="950" dirty="0"/>
           </a:p>
         </p:txBody>
       </p:sp>
@@ -7418,20 +7882,22 @@
         </p:nvSpPr>
         <p:spPr>
           <a:xfrm>
-            <a:off x="4434840" y="1645920"/>
-            <a:ext cx="3337560" cy="1051560"/>
+            <a:off x="3063240" y="2107039"/>
+            <a:ext cx="3252651" cy="256032"/>
           </a:xfrm>
           <a:prstGeom prst="roundRect">
             <a:avLst>
-              <a:gd name="adj" fmla="val 6957"/>
+              <a:gd name="adj" fmla="val 28571"/>
             </a:avLst>
           </a:prstGeom>
           <a:solidFill>
-            <a:srgbClr val="FFFFFF"/>
+            <a:srgbClr val="4F7B58"/>
           </a:solidFill>
           <a:ln w="12700">
             <a:solidFill>
-              <a:srgbClr val="D8D1C3"/>
+              <a:srgbClr val="4F7B58">
+                <a:alpha val="0"/>
+              </a:srgbClr>
             </a:solidFill>
             <a:prstDash val="solid"/>
           </a:ln>
@@ -7445,33 +7911,33 @@
         </p:nvSpPr>
         <p:spPr>
           <a:xfrm>
-            <a:off x="4636008" y="1810512"/>
-            <a:ext cx="1005840" cy="347472"/>
-          </a:xfrm>
-          <a:prstGeom prst="rect">
-            <a:avLst/>
-          </a:prstGeom>
-          <a:noFill/>
-          <a:ln/>
-        </p:spPr>
-        <p:txBody>
-          <a:bodyPr wrap="square" lIns="0" tIns="0" rIns="0" bIns="0" rtlCol="0" anchor="ctr">
-            <a:normAutofit/>
-          </a:bodyPr>
-          <a:lstStyle/>
-          <a:p>
-            <a:pPr indent="0" marL="0">
-              <a:buNone/>
-            </a:pPr>
-            <a:r>
-              <a:rPr lang="en-US" sz="2400" b="1" dirty="0">
-                <a:solidFill>
-                  <a:srgbClr val="C48A2C"/>
-                </a:solidFill>
-              </a:rPr>
-              <a:t>2</a:t>
-            </a:r>
-            <a:endParaRPr lang="en-US" sz="2400" dirty="0"/>
+            <a:off x="6425619" y="2143615"/>
+            <a:ext cx="594360" cy="164592"/>
+          </a:xfrm>
+          <a:prstGeom prst="rect">
+            <a:avLst/>
+          </a:prstGeom>
+          <a:noFill/>
+          <a:ln/>
+        </p:spPr>
+        <p:txBody>
+          <a:bodyPr wrap="square" lIns="0" tIns="0" rIns="0" bIns="0" rtlCol="0" anchor="ctr">
+            <a:normAutofit/>
+          </a:bodyPr>
+          <a:lstStyle/>
+          <a:p>
+            <a:pPr indent="0" marL="0">
+              <a:buNone/>
+            </a:pPr>
+            <a:r>
+              <a:rPr lang="en-US" sz="850" b="1" dirty="0">
+                <a:solidFill>
+                  <a:srgbClr val="172322"/>
+                </a:solidFill>
+              </a:rPr>
+              <a:t>18</a:t>
+            </a:r>
+            <a:endParaRPr lang="en-US" sz="850" dirty="0"/>
           </a:p>
         </p:txBody>
       </p:sp>
@@ -7483,96 +7949,60 @@
         </p:nvSpPr>
         <p:spPr>
           <a:xfrm>
-            <a:off x="5641848" y="1810512"/>
-            <a:ext cx="1828800" cy="182880"/>
-          </a:xfrm>
-          <a:prstGeom prst="rect">
-            <a:avLst/>
-          </a:prstGeom>
-          <a:noFill/>
-          <a:ln/>
-        </p:spPr>
-        <p:txBody>
-          <a:bodyPr wrap="square" lIns="0" tIns="0" rIns="0" bIns="0" rtlCol="0" anchor="ctr">
-            <a:normAutofit/>
-          </a:bodyPr>
-          <a:lstStyle/>
-          <a:p>
-            <a:pPr indent="0" marL="0">
-              <a:buNone/>
-            </a:pPr>
-            <a:r>
-              <a:rPr lang="en-US" sz="900" b="1" dirty="0">
-                <a:solidFill>
-                  <a:srgbClr val="66716A"/>
-                </a:solidFill>
-              </a:rPr>
-              <a:t>Product</a:t>
-            </a:r>
-            <a:endParaRPr lang="en-US" sz="900" dirty="0"/>
-          </a:p>
-        </p:txBody>
-      </p:sp>
-      <p:sp>
-        <p:nvSpPr>
-          <p:cNvPr id="11" name="Text 9"/>
-          <p:cNvSpPr/>
-          <p:nvPr/>
-        </p:nvSpPr>
-        <p:spPr>
-          <a:xfrm>
-            <a:off x="5641848" y="2084832"/>
-            <a:ext cx="1828800" cy="411480"/>
-          </a:xfrm>
-          <a:prstGeom prst="rect">
-            <a:avLst/>
-          </a:prstGeom>
-          <a:noFill/>
-          <a:ln/>
-        </p:spPr>
-        <p:txBody>
-          <a:bodyPr wrap="square" lIns="254" tIns="254" rIns="254" bIns="254" rtlCol="0" anchor="ctr">
-            <a:normAutofit/>
-          </a:bodyPr>
-          <a:lstStyle/>
-          <a:p>
-            <a:pPr indent="0" marL="0">
-              <a:buNone/>
-            </a:pPr>
-            <a:r>
-              <a:rPr lang="en-US" sz="1100" dirty="0">
-                <a:solidFill>
-                  <a:srgbClr val="172322"/>
-                </a:solidFill>
-              </a:rPr>
-              <a:t>Product gap backlog: repeated pain points with quotes, accounts, and urgency.</a:t>
-            </a:r>
-            <a:endParaRPr lang="en-US" sz="1100" dirty="0"/>
-          </a:p>
-        </p:txBody>
-      </p:sp>
-      <p:sp>
-        <p:nvSpPr>
-          <p:cNvPr id="12" name="Shape 10"/>
-          <p:cNvSpPr/>
-          <p:nvPr/>
-        </p:nvSpPr>
-        <p:spPr>
-          <a:xfrm>
-            <a:off x="8183880" y="1645920"/>
-            <a:ext cx="3337560" cy="1051560"/>
+            <a:off x="685800" y="2668742"/>
+            <a:ext cx="2286000" cy="201168"/>
+          </a:xfrm>
+          <a:prstGeom prst="rect">
+            <a:avLst/>
+          </a:prstGeom>
+          <a:noFill/>
+          <a:ln/>
+        </p:spPr>
+        <p:txBody>
+          <a:bodyPr wrap="square" lIns="0" tIns="0" rIns="0" bIns="0" rtlCol="0" anchor="ctr">
+            <a:normAutofit/>
+          </a:bodyPr>
+          <a:lstStyle/>
+          <a:p>
+            <a:pPr indent="0" marL="0">
+              <a:buNone/>
+            </a:pPr>
+            <a:r>
+              <a:rPr lang="en-US" sz="950" dirty="0">
+                <a:solidFill>
+                  <a:srgbClr val="172322"/>
+                </a:solidFill>
+              </a:rPr>
+              <a:t>C6: Renewal</a:t>
+            </a:r>
+            <a:endParaRPr lang="en-US" sz="950" dirty="0"/>
+          </a:p>
+        </p:txBody>
+      </p:sp>
+      <p:sp>
+        <p:nvSpPr>
+          <p:cNvPr id="11" name="Shape 9"/>
+          <p:cNvSpPr/>
+          <p:nvPr/>
+        </p:nvSpPr>
+        <p:spPr>
+          <a:xfrm>
+            <a:off x="3063240" y="2668742"/>
+            <a:ext cx="3252651" cy="256032"/>
           </a:xfrm>
           <a:prstGeom prst="roundRect">
             <a:avLst>
-              <a:gd name="adj" fmla="val 6957"/>
+              <a:gd name="adj" fmla="val 28571"/>
             </a:avLst>
           </a:prstGeom>
           <a:solidFill>
-            <a:srgbClr val="FFFFFF"/>
+            <a:srgbClr val="4F7B58"/>
           </a:solidFill>
           <a:ln w="12700">
             <a:solidFill>
-              <a:srgbClr val="D8D1C3"/>
+              <a:srgbClr val="4F7B58">
+                <a:alpha val="0"/>
+              </a:srgbClr>
             </a:solidFill>
             <a:prstDash val="solid"/>
           </a:ln>
@@ -7580,79 +8010,108 @@
       </p:sp>
       <p:sp>
         <p:nvSpPr>
+          <p:cNvPr id="12" name="Text 10"/>
+          <p:cNvSpPr/>
+          <p:nvPr/>
+        </p:nvSpPr>
+        <p:spPr>
+          <a:xfrm>
+            <a:off x="6425619" y="2705318"/>
+            <a:ext cx="594360" cy="164592"/>
+          </a:xfrm>
+          <a:prstGeom prst="rect">
+            <a:avLst/>
+          </a:prstGeom>
+          <a:noFill/>
+          <a:ln/>
+        </p:spPr>
+        <p:txBody>
+          <a:bodyPr wrap="square" lIns="0" tIns="0" rIns="0" bIns="0" rtlCol="0" anchor="ctr">
+            <a:normAutofit/>
+          </a:bodyPr>
+          <a:lstStyle/>
+          <a:p>
+            <a:pPr indent="0" marL="0">
+              <a:buNone/>
+            </a:pPr>
+            <a:r>
+              <a:rPr lang="en-US" sz="850" b="1" dirty="0">
+                <a:solidFill>
+                  <a:srgbClr val="172322"/>
+                </a:solidFill>
+              </a:rPr>
+              <a:t>18</a:t>
+            </a:r>
+            <a:endParaRPr lang="en-US" sz="850" dirty="0"/>
+          </a:p>
+        </p:txBody>
+      </p:sp>
+      <p:sp>
+        <p:nvSpPr>
           <p:cNvPr id="13" name="Text 11"/>
           <p:cNvSpPr/>
           <p:nvPr/>
         </p:nvSpPr>
         <p:spPr>
           <a:xfrm>
-            <a:off x="8385048" y="1810512"/>
-            <a:ext cx="1005840" cy="347472"/>
-          </a:xfrm>
-          <a:prstGeom prst="rect">
-            <a:avLst/>
-          </a:prstGeom>
-          <a:noFill/>
-          <a:ln/>
-        </p:spPr>
-        <p:txBody>
-          <a:bodyPr wrap="square" lIns="0" tIns="0" rIns="0" bIns="0" rtlCol="0" anchor="ctr">
-            <a:normAutofit/>
-          </a:bodyPr>
-          <a:lstStyle/>
-          <a:p>
-            <a:pPr indent="0" marL="0">
-              <a:buNone/>
-            </a:pPr>
-            <a:r>
-              <a:rPr lang="en-US" sz="2400" b="1" dirty="0">
-                <a:solidFill>
-                  <a:srgbClr val="4F7B58"/>
-                </a:solidFill>
-              </a:rPr>
-              <a:t>3</a:t>
-            </a:r>
-            <a:endParaRPr lang="en-US" sz="2400" dirty="0"/>
-          </a:p>
-        </p:txBody>
-      </p:sp>
-      <p:sp>
-        <p:nvSpPr>
-          <p:cNvPr id="14" name="Text 12"/>
-          <p:cNvSpPr/>
-          <p:nvPr/>
-        </p:nvSpPr>
-        <p:spPr>
-          <a:xfrm>
-            <a:off x="9390888" y="1810512"/>
-            <a:ext cx="1828800" cy="182880"/>
-          </a:xfrm>
-          <a:prstGeom prst="rect">
-            <a:avLst/>
-          </a:prstGeom>
-          <a:noFill/>
-          <a:ln/>
-        </p:spPr>
-        <p:txBody>
-          <a:bodyPr wrap="square" lIns="0" tIns="0" rIns="0" bIns="0" rtlCol="0" anchor="ctr">
-            <a:normAutofit/>
-          </a:bodyPr>
-          <a:lstStyle/>
-          <a:p>
-            <a:pPr indent="0" marL="0">
-              <a:buNone/>
-            </a:pPr>
-            <a:r>
-              <a:rPr lang="en-US" sz="900" b="1" dirty="0">
-                <a:solidFill>
-                  <a:srgbClr val="66716A"/>
-                </a:solidFill>
-              </a:rPr>
-              <a:t>Engineering</a:t>
-            </a:r>
-            <a:endParaRPr lang="en-US" sz="900" dirty="0"/>
-          </a:p>
-        </p:txBody>
+            <a:off x="685800" y="3230445"/>
+            <a:ext cx="2286000" cy="201168"/>
+          </a:xfrm>
+          <a:prstGeom prst="rect">
+            <a:avLst/>
+          </a:prstGeom>
+          <a:noFill/>
+          <a:ln/>
+        </p:spPr>
+        <p:txBody>
+          <a:bodyPr wrap="square" lIns="0" tIns="0" rIns="0" bIns="0" rtlCol="0" anchor="ctr">
+            <a:normAutofit/>
+          </a:bodyPr>
+          <a:lstStyle/>
+          <a:p>
+            <a:pPr indent="0" marL="0">
+              <a:buNone/>
+            </a:pPr>
+            <a:r>
+              <a:rPr lang="en-US" sz="950" dirty="0">
+                <a:solidFill>
+                  <a:srgbClr val="172322"/>
+                </a:solidFill>
+              </a:rPr>
+              <a:t>C0: Outage</a:t>
+            </a:r>
+            <a:endParaRPr lang="en-US" sz="950" dirty="0"/>
+          </a:p>
+        </p:txBody>
+      </p:sp>
+      <p:sp>
+        <p:nvSpPr>
+          <p:cNvPr id="14" name="Shape 12"/>
+          <p:cNvSpPr/>
+          <p:nvPr/>
+        </p:nvSpPr>
+        <p:spPr>
+          <a:xfrm>
+            <a:off x="3063240" y="3230445"/>
+            <a:ext cx="2349137" cy="256032"/>
+          </a:xfrm>
+          <a:prstGeom prst="roundRect">
+            <a:avLst>
+              <a:gd name="adj" fmla="val 28571"/>
+            </a:avLst>
+          </a:prstGeom>
+          <a:solidFill>
+            <a:srgbClr val="4F7B58"/>
+          </a:solidFill>
+          <a:ln w="12700">
+            <a:solidFill>
+              <a:srgbClr val="4F7B58">
+                <a:alpha val="0"/>
+              </a:srgbClr>
+            </a:solidFill>
+            <a:prstDash val="solid"/>
+          </a:ln>
+        </p:spPr>
       </p:sp>
       <p:sp>
         <p:nvSpPr>
@@ -7662,8 +8121,397 @@
         </p:nvSpPr>
         <p:spPr>
           <a:xfrm>
-            <a:off x="9390888" y="2084832"/>
-            <a:ext cx="1828800" cy="411480"/>
+            <a:off x="5522105" y="3267021"/>
+            <a:ext cx="594360" cy="164592"/>
+          </a:xfrm>
+          <a:prstGeom prst="rect">
+            <a:avLst/>
+          </a:prstGeom>
+          <a:noFill/>
+          <a:ln/>
+        </p:spPr>
+        <p:txBody>
+          <a:bodyPr wrap="square" lIns="0" tIns="0" rIns="0" bIns="0" rtlCol="0" anchor="ctr">
+            <a:normAutofit/>
+          </a:bodyPr>
+          <a:lstStyle/>
+          <a:p>
+            <a:pPr indent="0" marL="0">
+              <a:buNone/>
+            </a:pPr>
+            <a:r>
+              <a:rPr lang="en-US" sz="850" b="1" dirty="0">
+                <a:solidFill>
+                  <a:srgbClr val="172322"/>
+                </a:solidFill>
+              </a:rPr>
+              <a:t>13</a:t>
+            </a:r>
+            <a:endParaRPr lang="en-US" sz="850" dirty="0"/>
+          </a:p>
+        </p:txBody>
+      </p:sp>
+      <p:sp>
+        <p:nvSpPr>
+          <p:cNvPr id="16" name="Text 14"/>
+          <p:cNvSpPr/>
+          <p:nvPr/>
+        </p:nvSpPr>
+        <p:spPr>
+          <a:xfrm>
+            <a:off x="685800" y="3792147"/>
+            <a:ext cx="2286000" cy="201168"/>
+          </a:xfrm>
+          <a:prstGeom prst="rect">
+            <a:avLst/>
+          </a:prstGeom>
+          <a:noFill/>
+          <a:ln/>
+        </p:spPr>
+        <p:txBody>
+          <a:bodyPr wrap="square" lIns="0" tIns="0" rIns="0" bIns="0" rtlCol="0" anchor="ctr">
+            <a:normAutofit/>
+          </a:bodyPr>
+          <a:lstStyle/>
+          <a:p>
+            <a:pPr indent="0" marL="0">
+              <a:buNone/>
+            </a:pPr>
+            <a:r>
+              <a:rPr lang="en-US" sz="950" dirty="0">
+                <a:solidFill>
+                  <a:srgbClr val="172322"/>
+                </a:solidFill>
+              </a:rPr>
+              <a:t>C1: Mfa</a:t>
+            </a:r>
+            <a:endParaRPr lang="en-US" sz="950" dirty="0"/>
+          </a:p>
+        </p:txBody>
+      </p:sp>
+      <p:sp>
+        <p:nvSpPr>
+          <p:cNvPr id="17" name="Shape 15"/>
+          <p:cNvSpPr/>
+          <p:nvPr/>
+        </p:nvSpPr>
+        <p:spPr>
+          <a:xfrm>
+            <a:off x="3063240" y="3792147"/>
+            <a:ext cx="2349137" cy="256032"/>
+          </a:xfrm>
+          <a:prstGeom prst="roundRect">
+            <a:avLst>
+              <a:gd name="adj" fmla="val 28571"/>
+            </a:avLst>
+          </a:prstGeom>
+          <a:solidFill>
+            <a:srgbClr val="4F7B58"/>
+          </a:solidFill>
+          <a:ln w="12700">
+            <a:solidFill>
+              <a:srgbClr val="4F7B58">
+                <a:alpha val="0"/>
+              </a:srgbClr>
+            </a:solidFill>
+            <a:prstDash val="solid"/>
+          </a:ln>
+        </p:spPr>
+      </p:sp>
+      <p:sp>
+        <p:nvSpPr>
+          <p:cNvPr id="18" name="Text 16"/>
+          <p:cNvSpPr/>
+          <p:nvPr/>
+        </p:nvSpPr>
+        <p:spPr>
+          <a:xfrm>
+            <a:off x="5522105" y="3828723"/>
+            <a:ext cx="594360" cy="164592"/>
+          </a:xfrm>
+          <a:prstGeom prst="rect">
+            <a:avLst/>
+          </a:prstGeom>
+          <a:noFill/>
+          <a:ln/>
+        </p:spPr>
+        <p:txBody>
+          <a:bodyPr wrap="square" lIns="0" tIns="0" rIns="0" bIns="0" rtlCol="0" anchor="ctr">
+            <a:normAutofit/>
+          </a:bodyPr>
+          <a:lstStyle/>
+          <a:p>
+            <a:pPr indent="0" marL="0">
+              <a:buNone/>
+            </a:pPr>
+            <a:r>
+              <a:rPr lang="en-US" sz="850" b="1" dirty="0">
+                <a:solidFill>
+                  <a:srgbClr val="172322"/>
+                </a:solidFill>
+              </a:rPr>
+              <a:t>13</a:t>
+            </a:r>
+            <a:endParaRPr lang="en-US" sz="850" dirty="0"/>
+          </a:p>
+        </p:txBody>
+      </p:sp>
+      <p:sp>
+        <p:nvSpPr>
+          <p:cNvPr id="19" name="Text 17"/>
+          <p:cNvSpPr/>
+          <p:nvPr/>
+        </p:nvSpPr>
+        <p:spPr>
+          <a:xfrm>
+            <a:off x="685800" y="4353850"/>
+            <a:ext cx="2286000" cy="201168"/>
+          </a:xfrm>
+          <a:prstGeom prst="rect">
+            <a:avLst/>
+          </a:prstGeom>
+          <a:noFill/>
+          <a:ln/>
+        </p:spPr>
+        <p:txBody>
+          <a:bodyPr wrap="square" lIns="0" tIns="0" rIns="0" bIns="0" rtlCol="0" anchor="ctr">
+            <a:normAutofit/>
+          </a:bodyPr>
+          <a:lstStyle/>
+          <a:p>
+            <a:pPr indent="0" marL="0">
+              <a:buNone/>
+            </a:pPr>
+            <a:r>
+              <a:rPr lang="en-US" sz="950" dirty="0">
+                <a:solidFill>
+                  <a:srgbClr val="172322"/>
+                </a:solidFill>
+              </a:rPr>
+              <a:t>C4: Data</a:t>
+            </a:r>
+            <a:endParaRPr lang="en-US" sz="950" dirty="0"/>
+          </a:p>
+        </p:txBody>
+      </p:sp>
+      <p:sp>
+        <p:nvSpPr>
+          <p:cNvPr id="20" name="Shape 18"/>
+          <p:cNvSpPr/>
+          <p:nvPr/>
+        </p:nvSpPr>
+        <p:spPr>
+          <a:xfrm>
+            <a:off x="3063240" y="4353850"/>
+            <a:ext cx="2349137" cy="256032"/>
+          </a:xfrm>
+          <a:prstGeom prst="roundRect">
+            <a:avLst>
+              <a:gd name="adj" fmla="val 28571"/>
+            </a:avLst>
+          </a:prstGeom>
+          <a:solidFill>
+            <a:srgbClr val="4F7B58"/>
+          </a:solidFill>
+          <a:ln w="12700">
+            <a:solidFill>
+              <a:srgbClr val="4F7B58">
+                <a:alpha val="0"/>
+              </a:srgbClr>
+            </a:solidFill>
+            <a:prstDash val="solid"/>
+          </a:ln>
+        </p:spPr>
+      </p:sp>
+      <p:sp>
+        <p:nvSpPr>
+          <p:cNvPr id="21" name="Text 19"/>
+          <p:cNvSpPr/>
+          <p:nvPr/>
+        </p:nvSpPr>
+        <p:spPr>
+          <a:xfrm>
+            <a:off x="5522105" y="4390426"/>
+            <a:ext cx="594360" cy="164592"/>
+          </a:xfrm>
+          <a:prstGeom prst="rect">
+            <a:avLst/>
+          </a:prstGeom>
+          <a:noFill/>
+          <a:ln/>
+        </p:spPr>
+        <p:txBody>
+          <a:bodyPr wrap="square" lIns="0" tIns="0" rIns="0" bIns="0" rtlCol="0" anchor="ctr">
+            <a:normAutofit/>
+          </a:bodyPr>
+          <a:lstStyle/>
+          <a:p>
+            <a:pPr indent="0" marL="0">
+              <a:buNone/>
+            </a:pPr>
+            <a:r>
+              <a:rPr lang="en-US" sz="850" b="1" dirty="0">
+                <a:solidFill>
+                  <a:srgbClr val="172322"/>
+                </a:solidFill>
+              </a:rPr>
+              <a:t>13</a:t>
+            </a:r>
+            <a:endParaRPr lang="en-US" sz="850" dirty="0"/>
+          </a:p>
+        </p:txBody>
+      </p:sp>
+      <p:sp>
+        <p:nvSpPr>
+          <p:cNvPr id="22" name="Text 20"/>
+          <p:cNvSpPr/>
+          <p:nvPr/>
+        </p:nvSpPr>
+        <p:spPr>
+          <a:xfrm>
+            <a:off x="685800" y="4915553"/>
+            <a:ext cx="2286000" cy="201168"/>
+          </a:xfrm>
+          <a:prstGeom prst="rect">
+            <a:avLst/>
+          </a:prstGeom>
+          <a:noFill/>
+          <a:ln/>
+        </p:spPr>
+        <p:txBody>
+          <a:bodyPr wrap="square" lIns="0" tIns="0" rIns="0" bIns="0" rtlCol="0" anchor="ctr">
+            <a:normAutofit/>
+          </a:bodyPr>
+          <a:lstStyle/>
+          <a:p>
+            <a:pPr indent="0" marL="0">
+              <a:buNone/>
+            </a:pPr>
+            <a:r>
+              <a:rPr lang="en-US" sz="950" dirty="0">
+                <a:solidFill>
+                  <a:srgbClr val="172322"/>
+                </a:solidFill>
+              </a:rPr>
+              <a:t>C3: Control</a:t>
+            </a:r>
+            <a:endParaRPr lang="en-US" sz="950" dirty="0"/>
+          </a:p>
+        </p:txBody>
+      </p:sp>
+      <p:sp>
+        <p:nvSpPr>
+          <p:cNvPr id="23" name="Shape 21"/>
+          <p:cNvSpPr/>
+          <p:nvPr/>
+        </p:nvSpPr>
+        <p:spPr>
+          <a:xfrm>
+            <a:off x="3063240" y="4915553"/>
+            <a:ext cx="722811" cy="256032"/>
+          </a:xfrm>
+          <a:prstGeom prst="roundRect">
+            <a:avLst>
+              <a:gd name="adj" fmla="val 28571"/>
+            </a:avLst>
+          </a:prstGeom>
+          <a:solidFill>
+            <a:srgbClr val="4F7B58"/>
+          </a:solidFill>
+          <a:ln w="12700">
+            <a:solidFill>
+              <a:srgbClr val="4F7B58">
+                <a:alpha val="0"/>
+              </a:srgbClr>
+            </a:solidFill>
+            <a:prstDash val="solid"/>
+          </a:ln>
+        </p:spPr>
+      </p:sp>
+      <p:sp>
+        <p:nvSpPr>
+          <p:cNvPr id="24" name="Text 22"/>
+          <p:cNvSpPr/>
+          <p:nvPr/>
+        </p:nvSpPr>
+        <p:spPr>
+          <a:xfrm>
+            <a:off x="3895779" y="4952129"/>
+            <a:ext cx="594360" cy="164592"/>
+          </a:xfrm>
+          <a:prstGeom prst="rect">
+            <a:avLst/>
+          </a:prstGeom>
+          <a:noFill/>
+          <a:ln/>
+        </p:spPr>
+        <p:txBody>
+          <a:bodyPr wrap="square" lIns="0" tIns="0" rIns="0" bIns="0" rtlCol="0" anchor="ctr">
+            <a:normAutofit/>
+          </a:bodyPr>
+          <a:lstStyle/>
+          <a:p>
+            <a:pPr indent="0" marL="0">
+              <a:buNone/>
+            </a:pPr>
+            <a:r>
+              <a:rPr lang="en-US" sz="850" b="1" dirty="0">
+                <a:solidFill>
+                  <a:srgbClr val="172322"/>
+                </a:solidFill>
+              </a:rPr>
+              <a:t>4</a:t>
+            </a:r>
+            <a:endParaRPr lang="en-US" sz="850" dirty="0"/>
+          </a:p>
+        </p:txBody>
+      </p:sp>
+      <p:sp>
+        <p:nvSpPr>
+          <p:cNvPr id="25" name="Text 23"/>
+          <p:cNvSpPr/>
+          <p:nvPr/>
+        </p:nvSpPr>
+        <p:spPr>
+          <a:xfrm>
+            <a:off x="7452360" y="1600200"/>
+            <a:ext cx="3474720" cy="256032"/>
+          </a:xfrm>
+          <a:prstGeom prst="rect">
+            <a:avLst/>
+          </a:prstGeom>
+          <a:noFill/>
+          <a:ln/>
+        </p:spPr>
+        <p:txBody>
+          <a:bodyPr wrap="square" lIns="0" tIns="0" rIns="0" bIns="0" rtlCol="0" anchor="ctr"/>
+          <a:lstStyle/>
+          <a:p>
+            <a:pPr indent="0" marL="0">
+              <a:buNone/>
+            </a:pPr>
+            <a:r>
+              <a:rPr lang="en-US" sz="1500" b="1" dirty="0">
+                <a:solidFill>
+                  <a:srgbClr val="2F6F73"/>
+                </a:solidFill>
+              </a:rPr>
+              <a:t>What the experiment adds</a:t>
+            </a:r>
+            <a:endParaRPr lang="en-US" sz="1500" dirty="0"/>
+          </a:p>
+        </p:txBody>
+      </p:sp>
+      <p:sp>
+        <p:nvSpPr>
+          <p:cNvPr id="26" name="Text 24"/>
+          <p:cNvSpPr/>
+          <p:nvPr/>
+        </p:nvSpPr>
+        <p:spPr>
+          <a:xfrm>
+            <a:off x="7452360" y="1984248"/>
+            <a:ext cx="3474720" cy="2267712"/>
           </a:xfrm>
           <a:prstGeom prst="rect">
             <a:avLst/>
@@ -7681,58 +8529,20 @@
               <a:buNone/>
             </a:pPr>
             <a:r>
-              <a:rPr lang="en-US" sz="1100" dirty="0">
-                <a:solidFill>
-                  <a:srgbClr val="172322"/>
-                </a:solidFill>
-              </a:rPr>
-              <a:t>Incident learning loop: connect support pain to post-incident and sprint-planning follow-through.</a:t>
-            </a:r>
-            <a:endParaRPr lang="en-US" sz="1100" dirty="0"/>
-          </a:p>
-        </p:txBody>
-      </p:sp>
-      <p:sp>
-        <p:nvSpPr>
-          <p:cNvPr id="16" name="Text 14"/>
-          <p:cNvSpPr/>
-          <p:nvPr/>
-        </p:nvSpPr>
-        <p:spPr>
-          <a:xfrm>
-            <a:off x="914400" y="3840480"/>
-            <a:ext cx="9875520" cy="822960"/>
-          </a:xfrm>
-          <a:prstGeom prst="rect">
-            <a:avLst/>
-          </a:prstGeom>
-          <a:noFill/>
-          <a:ln/>
-        </p:spPr>
-        <p:txBody>
-          <a:bodyPr wrap="square" lIns="0" tIns="0" rIns="0" bIns="0" rtlCol="0" anchor="ctr">
-            <a:normAutofit/>
-          </a:bodyPr>
-          <a:lstStyle/>
-          <a:p>
-            <a:pPr algn="ctr" indent="0" marL="0">
-              <a:buNone/>
-            </a:pPr>
-            <a:r>
-              <a:rPr lang="en-US" sz="2200" b="1" dirty="0">
-                <a:solidFill>
-                  <a:srgbClr val="172322"/>
-                </a:solidFill>
-              </a:rPr>
-              <a:t>These are stakeholder workflows, not charts. The product should help each leader decide what to do next and where to look for evidence.</a:t>
-            </a:r>
-            <a:endParaRPr lang="en-US" sz="2200" dirty="0"/>
-          </a:p>
-        </p:txBody>
-      </p:sp>
-      <p:sp>
-        <p:nvSpPr>
-          <p:cNvPr id="17" name="Text 15"/>
+              <a:rPr lang="en-US" sz="1600" dirty="0">
+                <a:solidFill>
+                  <a:srgbClr val="172322"/>
+                </a:solidFill>
+              </a:rPr>
+              <a:t>The pipeline includes a dependency-free TF-IDF k-means pass. It is not the production classifier; it is a discovery check that groups similar meetings and compares each cluster with the hand-labeled business theme. The result gives reviewers evidence that the taxonomy was tested, not only asserted.</a:t>
+            </a:r>
+            <a:endParaRPr lang="en-US" sz="1600" dirty="0"/>
+          </a:p>
+        </p:txBody>
+      </p:sp>
+      <p:sp>
+        <p:nvSpPr>
+          <p:cNvPr id="27" name="Text 25"/>
           <p:cNvSpPr/>
           <p:nvPr/>
         </p:nvSpPr>
@@ -7872,7 +8682,7 @@
                 <a:ea typeface="Aptos Display" pitchFamily="34" charset="-122"/>
                 <a:cs typeface="Aptos Display" pitchFamily="34" charset="-120"/>
               </a:rPr>
-              <a:t>Recommended next build</a:t>
+              <a:t>Three insight products would make this valuable beyond analysis</a:t>
             </a:r>
             <a:endParaRPr lang="en-US" sz="2800" dirty="0"/>
           </a:p>
@@ -7880,86 +8690,18 @@
       </p:sp>
       <p:sp>
         <p:nvSpPr>
-          <p:cNvPr id="4" name="Text 2"/>
-          <p:cNvSpPr/>
-          <p:nvPr/>
-        </p:nvSpPr>
-        <p:spPr>
-          <a:xfrm>
-            <a:off x="822960" y="1691640"/>
-            <a:ext cx="5852160" cy="2194560"/>
-          </a:xfrm>
-          <a:prstGeom prst="rect">
-            <a:avLst/>
-          </a:prstGeom>
-          <a:noFill/>
-          <a:ln/>
-        </p:spPr>
-        <p:txBody>
-          <a:bodyPr wrap="square" lIns="508" tIns="508" rIns="508" bIns="508" rtlCol="0" anchor="ctr">
-            <a:normAutofit/>
-          </a:bodyPr>
-          <a:lstStyle/>
-          <a:p>
-            <a:r>
-              <a:rPr lang="en-US" sz="1800" dirty="0">
-                <a:solidFill>
-                  <a:srgbClr val="172322"/>
-                </a:solidFill>
-              </a:rPr>
-              <a:t>Ship a theme and risk dashboard for Detect reliability first.</a:t>
-            </a:r>
-            <a:endParaRPr lang="en-US" sz="1800" dirty="0"/>
-          </a:p>
-          <a:p>
-            <a:r>
-              <a:rPr lang="en-US" sz="1800" dirty="0">
-                <a:solidFill>
-                  <a:srgbClr val="172322"/>
-                </a:solidFill>
-              </a:rPr>
-              <a:t>Add account-level revenue risk overlays for renewal and competitive calls.</a:t>
-            </a:r>
-            <a:endParaRPr lang="en-US" sz="1800" dirty="0"/>
-          </a:p>
-          <a:p>
-            <a:r>
-              <a:rPr lang="en-US" sz="1800" dirty="0">
-                <a:solidFill>
-                  <a:srgbClr val="172322"/>
-                </a:solidFill>
-              </a:rPr>
-              <a:t>Add owner extraction so action items become trackable workflow, not static notes.</a:t>
-            </a:r>
-            <a:endParaRPr lang="en-US" sz="1800" dirty="0"/>
-          </a:p>
-          <a:p>
-            <a:r>
-              <a:rPr lang="en-US" sz="1800" dirty="0">
-                <a:solidFill>
-                  <a:srgbClr val="172322"/>
-                </a:solidFill>
-              </a:rPr>
-              <a:t>Upgrade classifier with embeddings or LLM labels, keeping the rule layer as explainable QA.</a:t>
-            </a:r>
-            <a:endParaRPr lang="en-US" sz="1800" dirty="0"/>
-          </a:p>
-        </p:txBody>
-      </p:sp>
-      <p:sp>
-        <p:nvSpPr>
-          <p:cNvPr id="5" name="Shape 3"/>
-          <p:cNvSpPr/>
-          <p:nvPr/>
-        </p:nvSpPr>
-        <p:spPr>
-          <a:xfrm>
-            <a:off x="7315200" y="1645920"/>
-            <a:ext cx="3291840" cy="3108960"/>
+          <p:cNvPr id="4" name="Shape 2"/>
+          <p:cNvSpPr/>
+          <p:nvPr/>
+        </p:nvSpPr>
+        <p:spPr>
+          <a:xfrm>
+            <a:off x="685800" y="1645920"/>
+            <a:ext cx="3337560" cy="1051560"/>
           </a:xfrm>
           <a:prstGeom prst="roundRect">
             <a:avLst>
-              <a:gd name="adj" fmla="val 2353"/>
+              <a:gd name="adj" fmla="val 6957"/>
             </a:avLst>
           </a:prstGeom>
           <a:solidFill>
@@ -7975,37 +8717,77 @@
       </p:sp>
       <p:sp>
         <p:nvSpPr>
+          <p:cNvPr id="5" name="Text 3"/>
+          <p:cNvSpPr/>
+          <p:nvPr/>
+        </p:nvSpPr>
+        <p:spPr>
+          <a:xfrm>
+            <a:off x="886968" y="1810512"/>
+            <a:ext cx="1005840" cy="347472"/>
+          </a:xfrm>
+          <a:prstGeom prst="rect">
+            <a:avLst/>
+          </a:prstGeom>
+          <a:noFill/>
+          <a:ln/>
+        </p:spPr>
+        <p:txBody>
+          <a:bodyPr wrap="square" lIns="0" tIns="0" rIns="0" bIns="0" rtlCol="0" anchor="ctr">
+            <a:normAutofit/>
+          </a:bodyPr>
+          <a:lstStyle/>
+          <a:p>
+            <a:pPr indent="0" marL="0">
+              <a:buNone/>
+            </a:pPr>
+            <a:r>
+              <a:rPr lang="en-US" sz="2400" b="1" dirty="0">
+                <a:solidFill>
+                  <a:srgbClr val="2F6F73"/>
+                </a:solidFill>
+              </a:rPr>
+              <a:t>1</a:t>
+            </a:r>
+            <a:endParaRPr lang="en-US" sz="2400" dirty="0"/>
+          </a:p>
+        </p:txBody>
+      </p:sp>
+      <p:sp>
+        <p:nvSpPr>
           <p:cNvPr id="6" name="Text 4"/>
           <p:cNvSpPr/>
           <p:nvPr/>
         </p:nvSpPr>
         <p:spPr>
           <a:xfrm>
-            <a:off x="7635240" y="1920240"/>
-            <a:ext cx="2011680" cy="274320"/>
-          </a:xfrm>
-          <a:prstGeom prst="rect">
-            <a:avLst/>
-          </a:prstGeom>
-          <a:noFill/>
-          <a:ln/>
-        </p:spPr>
-        <p:txBody>
-          <a:bodyPr wrap="square" lIns="0" tIns="0" rIns="0" bIns="0" rtlCol="0" anchor="ctr"/>
-          <a:lstStyle/>
-          <a:p>
-            <a:pPr indent="0" marL="0">
-              <a:buNone/>
-            </a:pPr>
-            <a:r>
-              <a:rPr lang="en-US" sz="1800" b="1" dirty="0">
-                <a:solidFill>
-                  <a:srgbClr val="172322"/>
-                </a:solidFill>
-              </a:rPr>
-              <a:t>Demo path</a:t>
-            </a:r>
-            <a:endParaRPr lang="en-US" sz="1800" dirty="0"/>
+            <a:off x="1892808" y="1810512"/>
+            <a:ext cx="1828800" cy="182880"/>
+          </a:xfrm>
+          <a:prstGeom prst="rect">
+            <a:avLst/>
+          </a:prstGeom>
+          <a:noFill/>
+          <a:ln/>
+        </p:spPr>
+        <p:txBody>
+          <a:bodyPr wrap="square" lIns="0" tIns="0" rIns="0" bIns="0" rtlCol="0" anchor="ctr">
+            <a:normAutofit/>
+          </a:bodyPr>
+          <a:lstStyle/>
+          <a:p>
+            <a:pPr indent="0" marL="0">
+              <a:buNone/>
+            </a:pPr>
+            <a:r>
+              <a:rPr lang="en-US" sz="900" b="1" dirty="0">
+                <a:solidFill>
+                  <a:srgbClr val="66716A"/>
+                </a:solidFill>
+              </a:rPr>
+              <a:t>Sales / CS</a:t>
+            </a:r>
+            <a:endParaRPr lang="en-US" sz="900" dirty="0"/>
           </a:p>
         </p:txBody>
       </p:sp>
@@ -8017,95 +8799,359 @@
         </p:nvSpPr>
         <p:spPr>
           <a:xfrm>
-            <a:off x="7635240" y="2423160"/>
-            <a:ext cx="2560320" cy="1554480"/>
-          </a:xfrm>
-          <a:prstGeom prst="rect">
-            <a:avLst/>
-          </a:prstGeom>
-          <a:noFill/>
-          <a:ln/>
-        </p:spPr>
-        <p:txBody>
-          <a:bodyPr wrap="square" lIns="0" tIns="0" rIns="0" bIns="0" rtlCol="0" anchor="ctr">
-            <a:normAutofit/>
-          </a:bodyPr>
-          <a:lstStyle/>
-          <a:p>
-            <a:pPr indent="0" marL="0">
-              <a:buNone/>
-            </a:pPr>
-            <a:r>
-              <a:rPr lang="en-US" sz="1500" dirty="0">
-                <a:solidFill>
-                  <a:srgbClr val="172322"/>
-                </a:solidFill>
-              </a:rPr>
-              <a:t>1. Run src/analyze_transcripts.py</a:t>
-            </a:r>
-            <a:endParaRPr lang="en-US" sz="1500" dirty="0"/>
-          </a:p>
-          <a:p>
-            <a:pPr indent="0" marL="0">
-              <a:buNone/>
-            </a:pPr>
-            <a:r>
-              <a:rPr lang="en-US" sz="1500" dirty="0">
-                <a:solidFill>
-                  <a:srgbClr val="172322"/>
-                </a:solidFill>
-              </a:rPr>
-              <a:t>2. Open outputs/dashboard.html</a:t>
-            </a:r>
-            <a:endParaRPr lang="en-US" sz="1500" dirty="0"/>
-          </a:p>
-          <a:p>
-            <a:pPr indent="0" marL="0">
-              <a:buNone/>
-            </a:pPr>
-            <a:r>
-              <a:rPr lang="en-US" sz="1500" dirty="0">
-                <a:solidFill>
-                  <a:srgbClr val="172322"/>
-                </a:solidFill>
-              </a:rPr>
-              <a:t>3. Review analysis_report.md</a:t>
-            </a:r>
-            <a:endParaRPr lang="en-US" sz="1500" dirty="0"/>
-          </a:p>
-          <a:p>
-            <a:pPr indent="0" marL="0">
-              <a:buNone/>
-            </a:pPr>
-            <a:r>
-              <a:rPr lang="en-US" sz="1500" dirty="0">
-                <a:solidFill>
-                  <a:srgbClr val="172322"/>
-                </a:solidFill>
-              </a:rPr>
-              <a:t>4. Walk through this deck</a:t>
-            </a:r>
-            <a:endParaRPr lang="en-US" sz="1500" dirty="0"/>
-          </a:p>
-          <a:p>
-            <a:pPr indent="0" marL="0">
-              <a:buNone/>
-            </a:pPr>
-            <a:r>
-              <a:rPr lang="en-US" sz="1500" dirty="0">
-                <a:solidFill>
-                  <a:srgbClr val="172322"/>
-                </a:solidFill>
-              </a:rPr>
-              <a:t>5. Show highest-risk CSV rows</a:t>
-            </a:r>
-            <a:endParaRPr lang="en-US" sz="1500" dirty="0"/>
-          </a:p>
-        </p:txBody>
-      </p:sp>
-      <p:sp>
-        <p:nvSpPr>
-          <p:cNvPr id="8" name="Text 6"/>
+            <a:off x="1892808" y="2084832"/>
+            <a:ext cx="1828800" cy="411480"/>
+          </a:xfrm>
+          <a:prstGeom prst="rect">
+            <a:avLst/>
+          </a:prstGeom>
+          <a:noFill/>
+          <a:ln/>
+        </p:spPr>
+        <p:txBody>
+          <a:bodyPr wrap="square" lIns="254" tIns="254" rIns="254" bIns="254" rtlCol="0" anchor="ctr">
+            <a:normAutofit/>
+          </a:bodyPr>
+          <a:lstStyle/>
+          <a:p>
+            <a:pPr indent="0" marL="0">
+              <a:buNone/>
+            </a:pPr>
+            <a:r>
+              <a:rPr lang="en-US" sz="1100" dirty="0">
+                <a:solidFill>
+                  <a:srgbClr val="172322"/>
+                </a:solidFill>
+              </a:rPr>
+              <a:t>Revenue risk heatmap: renewal language + competitor mentions + negative sentiment.</a:t>
+            </a:r>
+            <a:endParaRPr lang="en-US" sz="1100" dirty="0"/>
+          </a:p>
+        </p:txBody>
+      </p:sp>
+      <p:sp>
+        <p:nvSpPr>
+          <p:cNvPr id="8" name="Shape 6"/>
+          <p:cNvSpPr/>
+          <p:nvPr/>
+        </p:nvSpPr>
+        <p:spPr>
+          <a:xfrm>
+            <a:off x="4434840" y="1645920"/>
+            <a:ext cx="3337560" cy="1051560"/>
+          </a:xfrm>
+          <a:prstGeom prst="roundRect">
+            <a:avLst>
+              <a:gd name="adj" fmla="val 6957"/>
+            </a:avLst>
+          </a:prstGeom>
+          <a:solidFill>
+            <a:srgbClr val="FFFFFF"/>
+          </a:solidFill>
+          <a:ln w="12700">
+            <a:solidFill>
+              <a:srgbClr val="D8D1C3"/>
+            </a:solidFill>
+            <a:prstDash val="solid"/>
+          </a:ln>
+        </p:spPr>
+      </p:sp>
+      <p:sp>
+        <p:nvSpPr>
+          <p:cNvPr id="9" name="Text 7"/>
+          <p:cNvSpPr/>
+          <p:nvPr/>
+        </p:nvSpPr>
+        <p:spPr>
+          <a:xfrm>
+            <a:off x="4636008" y="1810512"/>
+            <a:ext cx="1005840" cy="347472"/>
+          </a:xfrm>
+          <a:prstGeom prst="rect">
+            <a:avLst/>
+          </a:prstGeom>
+          <a:noFill/>
+          <a:ln/>
+        </p:spPr>
+        <p:txBody>
+          <a:bodyPr wrap="square" lIns="0" tIns="0" rIns="0" bIns="0" rtlCol="0" anchor="ctr">
+            <a:normAutofit/>
+          </a:bodyPr>
+          <a:lstStyle/>
+          <a:p>
+            <a:pPr indent="0" marL="0">
+              <a:buNone/>
+            </a:pPr>
+            <a:r>
+              <a:rPr lang="en-US" sz="2400" b="1" dirty="0">
+                <a:solidFill>
+                  <a:srgbClr val="C48A2C"/>
+                </a:solidFill>
+              </a:rPr>
+              <a:t>2</a:t>
+            </a:r>
+            <a:endParaRPr lang="en-US" sz="2400" dirty="0"/>
+          </a:p>
+        </p:txBody>
+      </p:sp>
+      <p:sp>
+        <p:nvSpPr>
+          <p:cNvPr id="10" name="Text 8"/>
+          <p:cNvSpPr/>
+          <p:nvPr/>
+        </p:nvSpPr>
+        <p:spPr>
+          <a:xfrm>
+            <a:off x="5641848" y="1810512"/>
+            <a:ext cx="1828800" cy="182880"/>
+          </a:xfrm>
+          <a:prstGeom prst="rect">
+            <a:avLst/>
+          </a:prstGeom>
+          <a:noFill/>
+          <a:ln/>
+        </p:spPr>
+        <p:txBody>
+          <a:bodyPr wrap="square" lIns="0" tIns="0" rIns="0" bIns="0" rtlCol="0" anchor="ctr">
+            <a:normAutofit/>
+          </a:bodyPr>
+          <a:lstStyle/>
+          <a:p>
+            <a:pPr indent="0" marL="0">
+              <a:buNone/>
+            </a:pPr>
+            <a:r>
+              <a:rPr lang="en-US" sz="900" b="1" dirty="0">
+                <a:solidFill>
+                  <a:srgbClr val="66716A"/>
+                </a:solidFill>
+              </a:rPr>
+              <a:t>Product</a:t>
+            </a:r>
+            <a:endParaRPr lang="en-US" sz="900" dirty="0"/>
+          </a:p>
+        </p:txBody>
+      </p:sp>
+      <p:sp>
+        <p:nvSpPr>
+          <p:cNvPr id="11" name="Text 9"/>
+          <p:cNvSpPr/>
+          <p:nvPr/>
+        </p:nvSpPr>
+        <p:spPr>
+          <a:xfrm>
+            <a:off x="5641848" y="2084832"/>
+            <a:ext cx="1828800" cy="411480"/>
+          </a:xfrm>
+          <a:prstGeom prst="rect">
+            <a:avLst/>
+          </a:prstGeom>
+          <a:noFill/>
+          <a:ln/>
+        </p:spPr>
+        <p:txBody>
+          <a:bodyPr wrap="square" lIns="254" tIns="254" rIns="254" bIns="254" rtlCol="0" anchor="ctr">
+            <a:normAutofit/>
+          </a:bodyPr>
+          <a:lstStyle/>
+          <a:p>
+            <a:pPr indent="0" marL="0">
+              <a:buNone/>
+            </a:pPr>
+            <a:r>
+              <a:rPr lang="en-US" sz="1100" dirty="0">
+                <a:solidFill>
+                  <a:srgbClr val="172322"/>
+                </a:solidFill>
+              </a:rPr>
+              <a:t>Product gap backlog: repeated pain points with quotes, accounts, and urgency.</a:t>
+            </a:r>
+            <a:endParaRPr lang="en-US" sz="1100" dirty="0"/>
+          </a:p>
+        </p:txBody>
+      </p:sp>
+      <p:sp>
+        <p:nvSpPr>
+          <p:cNvPr id="12" name="Shape 10"/>
+          <p:cNvSpPr/>
+          <p:nvPr/>
+        </p:nvSpPr>
+        <p:spPr>
+          <a:xfrm>
+            <a:off x="8183880" y="1645920"/>
+            <a:ext cx="3337560" cy="1051560"/>
+          </a:xfrm>
+          <a:prstGeom prst="roundRect">
+            <a:avLst>
+              <a:gd name="adj" fmla="val 6957"/>
+            </a:avLst>
+          </a:prstGeom>
+          <a:solidFill>
+            <a:srgbClr val="FFFFFF"/>
+          </a:solidFill>
+          <a:ln w="12700">
+            <a:solidFill>
+              <a:srgbClr val="D8D1C3"/>
+            </a:solidFill>
+            <a:prstDash val="solid"/>
+          </a:ln>
+        </p:spPr>
+      </p:sp>
+      <p:sp>
+        <p:nvSpPr>
+          <p:cNvPr id="13" name="Text 11"/>
+          <p:cNvSpPr/>
+          <p:nvPr/>
+        </p:nvSpPr>
+        <p:spPr>
+          <a:xfrm>
+            <a:off x="8385048" y="1810512"/>
+            <a:ext cx="1005840" cy="347472"/>
+          </a:xfrm>
+          <a:prstGeom prst="rect">
+            <a:avLst/>
+          </a:prstGeom>
+          <a:noFill/>
+          <a:ln/>
+        </p:spPr>
+        <p:txBody>
+          <a:bodyPr wrap="square" lIns="0" tIns="0" rIns="0" bIns="0" rtlCol="0" anchor="ctr">
+            <a:normAutofit/>
+          </a:bodyPr>
+          <a:lstStyle/>
+          <a:p>
+            <a:pPr indent="0" marL="0">
+              <a:buNone/>
+            </a:pPr>
+            <a:r>
+              <a:rPr lang="en-US" sz="2400" b="1" dirty="0">
+                <a:solidFill>
+                  <a:srgbClr val="4F7B58"/>
+                </a:solidFill>
+              </a:rPr>
+              <a:t>3</a:t>
+            </a:r>
+            <a:endParaRPr lang="en-US" sz="2400" dirty="0"/>
+          </a:p>
+        </p:txBody>
+      </p:sp>
+      <p:sp>
+        <p:nvSpPr>
+          <p:cNvPr id="14" name="Text 12"/>
+          <p:cNvSpPr/>
+          <p:nvPr/>
+        </p:nvSpPr>
+        <p:spPr>
+          <a:xfrm>
+            <a:off x="9390888" y="1810512"/>
+            <a:ext cx="1828800" cy="182880"/>
+          </a:xfrm>
+          <a:prstGeom prst="rect">
+            <a:avLst/>
+          </a:prstGeom>
+          <a:noFill/>
+          <a:ln/>
+        </p:spPr>
+        <p:txBody>
+          <a:bodyPr wrap="square" lIns="0" tIns="0" rIns="0" bIns="0" rtlCol="0" anchor="ctr">
+            <a:normAutofit/>
+          </a:bodyPr>
+          <a:lstStyle/>
+          <a:p>
+            <a:pPr indent="0" marL="0">
+              <a:buNone/>
+            </a:pPr>
+            <a:r>
+              <a:rPr lang="en-US" sz="900" b="1" dirty="0">
+                <a:solidFill>
+                  <a:srgbClr val="66716A"/>
+                </a:solidFill>
+              </a:rPr>
+              <a:t>Engineering</a:t>
+            </a:r>
+            <a:endParaRPr lang="en-US" sz="900" dirty="0"/>
+          </a:p>
+        </p:txBody>
+      </p:sp>
+      <p:sp>
+        <p:nvSpPr>
+          <p:cNvPr id="15" name="Text 13"/>
+          <p:cNvSpPr/>
+          <p:nvPr/>
+        </p:nvSpPr>
+        <p:spPr>
+          <a:xfrm>
+            <a:off x="9390888" y="2084832"/>
+            <a:ext cx="1828800" cy="411480"/>
+          </a:xfrm>
+          <a:prstGeom prst="rect">
+            <a:avLst/>
+          </a:prstGeom>
+          <a:noFill/>
+          <a:ln/>
+        </p:spPr>
+        <p:txBody>
+          <a:bodyPr wrap="square" lIns="254" tIns="254" rIns="254" bIns="254" rtlCol="0" anchor="ctr">
+            <a:normAutofit/>
+          </a:bodyPr>
+          <a:lstStyle/>
+          <a:p>
+            <a:pPr indent="0" marL="0">
+              <a:buNone/>
+            </a:pPr>
+            <a:r>
+              <a:rPr lang="en-US" sz="1100" dirty="0">
+                <a:solidFill>
+                  <a:srgbClr val="172322"/>
+                </a:solidFill>
+              </a:rPr>
+              <a:t>Incident learning loop: connect support pain to post-incident and sprint-planning follow-through.</a:t>
+            </a:r>
+            <a:endParaRPr lang="en-US" sz="1100" dirty="0"/>
+          </a:p>
+        </p:txBody>
+      </p:sp>
+      <p:sp>
+        <p:nvSpPr>
+          <p:cNvPr id="16" name="Text 14"/>
+          <p:cNvSpPr/>
+          <p:nvPr/>
+        </p:nvSpPr>
+        <p:spPr>
+          <a:xfrm>
+            <a:off x="914400" y="3840480"/>
+            <a:ext cx="9875520" cy="822960"/>
+          </a:xfrm>
+          <a:prstGeom prst="rect">
+            <a:avLst/>
+          </a:prstGeom>
+          <a:noFill/>
+          <a:ln/>
+        </p:spPr>
+        <p:txBody>
+          <a:bodyPr wrap="square" lIns="0" tIns="0" rIns="0" bIns="0" rtlCol="0" anchor="ctr">
+            <a:normAutofit/>
+          </a:bodyPr>
+          <a:lstStyle/>
+          <a:p>
+            <a:pPr algn="ctr" indent="0" marL="0">
+              <a:buNone/>
+            </a:pPr>
+            <a:r>
+              <a:rPr lang="en-US" sz="2200" b="1" dirty="0">
+                <a:solidFill>
+                  <a:srgbClr val="172322"/>
+                </a:solidFill>
+              </a:rPr>
+              <a:t>These are stakeholder workflows, not charts. The product should help each leader decide what to do next and where to look for evidence.</a:t>
+            </a:r>
+            <a:endParaRPr lang="en-US" sz="2200" dirty="0"/>
+          </a:p>
+        </p:txBody>
+      </p:sp>
+      <p:sp>
+        <p:nvSpPr>
+          <p:cNvPr id="17" name="Text 15"/>
           <p:cNvSpPr/>
           <p:nvPr/>
         </p:nvSpPr>

</xml_diff>

<commit_message>
Add AI retrieval and evaluation layer
</commit_message>
<xml_diff>
--- a/interview-assignment/deliverables/Transcript_Intelligence_Leadership_Deck.pptx
+++ b/interview-assignment/deliverables/Transcript_Intelligence_Leadership_Deck.pptx
@@ -15,9 +15,10 @@
     <p:sldId id="263" r:id="rId9"/>
     <p:sldId id="264" r:id="rId10"/>
     <p:sldId id="265" r:id="rId11"/>
+    <p:sldId id="266" r:id="rId12"/>
   </p:sldIdLst>
   <p:notesMasterIdLst>
-    <p:notesMasterId r:id="rId12"/>
+    <p:notesMasterId r:id="rId13"/>
   </p:notesMasterIdLst>
   <p:sldSz cx="12191695" cy="6858000"/>
   <p:notesSz cx="6858000" cy="12191695"/>
@@ -623,6 +624,94 @@
             <a:fld id="{F7021451-1387-4CA6-816F-3879F97B5CBC}" type="slidenum">
               <a:rPr lang="en-US"/>
               <a:t>10</a:t>
+            </a:fld>
+            <a:endParaRPr lang="en-US"/>
+          </a:p>
+        </p:txBody>
+      </p:sp>
+    </p:spTree>
+    <p:extLst>
+      <p:ext uri="{BB962C8B-B14F-4D97-AF65-F5344CB8AC3E}">
+        <p14:creationId xmlns:p14="http://schemas.microsoft.com/office/powerpoint/2010/main" val="1024086991"/>
+      </p:ext>
+    </p:extLst>
+  </p:cSld>
+  <p:clrMapOvr>
+    <a:masterClrMapping/>
+  </p:clrMapOvr>
+</p:notes>
+</file>
+
+<file path=ppt/notesSlides/notesSlide11.xml><?xml version="1.0" encoding="utf-8"?>
+<p:notes xmlns:a="http://schemas.openxmlformats.org/drawingml/2006/main" xmlns:r="http://schemas.openxmlformats.org/officeDocument/2006/relationships" xmlns:p="http://schemas.openxmlformats.org/presentationml/2006/main">
+  <p:cSld>
+    <p:spTree>
+      <p:nvGrpSpPr>
+        <p:cNvPr id="1" name=""/>
+        <p:cNvGrpSpPr/>
+        <p:nvPr/>
+      </p:nvGrpSpPr>
+      <p:grpSpPr>
+        <a:xfrm>
+          <a:off x="0" y="0"/>
+          <a:ext cx="0" cy="0"/>
+          <a:chOff x="0" y="0"/>
+          <a:chExt cx="0" cy="0"/>
+        </a:xfrm>
+      </p:grpSpPr>
+      <p:sp>
+        <p:nvSpPr>
+          <p:cNvPr id="2" name="Slide Image Placeholder 1"/>
+          <p:cNvSpPr>
+            <a:spLocks noGrp="1" noRot="1" noChangeAspect="1"/>
+          </p:cNvSpPr>
+          <p:nvPr>
+            <p:ph type="sldImg"/>
+          </p:nvPr>
+        </p:nvSpPr>
+        <p:spPr/>
+      </p:sp>
+      <p:sp>
+        <p:nvSpPr>
+          <p:cNvPr id="3" name="Notes Placeholder 2"/>
+          <p:cNvSpPr>
+            <a:spLocks noGrp="1"/>
+          </p:cNvSpPr>
+          <p:nvPr>
+            <p:ph type="body" idx="1"/>
+          </p:nvPr>
+        </p:nvSpPr>
+        <p:spPr/>
+        <p:txBody>
+          <a:bodyPr/>
+          <a:lstStyle/>
+          <a:p>
+            <a:r>
+              <a:rPr lang="en-US" dirty="0"/>
+              <a:t/>
+            </a:r>
+            <a:endParaRPr lang="en-US" dirty="0"/>
+          </a:p>
+        </p:txBody>
+      </p:sp>
+      <p:sp>
+        <p:nvSpPr>
+          <p:cNvPr id="4" name="Slide Number Placeholder 3"/>
+          <p:cNvSpPr>
+            <a:spLocks noGrp="1"/>
+          </p:cNvSpPr>
+          <p:nvPr>
+            <p:ph type="sldNum" sz="quarter" idx="10"/>
+          </p:nvPr>
+        </p:nvSpPr>
+        <p:spPr/>
+        <p:txBody>
+          <a:bodyPr/>
+          <a:lstStyle/>
+          <a:p>
+            <a:fld id="{F7021451-1387-4CA6-816F-3879F97B5CBC}" type="slidenum">
+              <a:rPr lang="en-US"/>
+              <a:t>11</a:t>
             </a:fld>
             <a:endParaRPr lang="en-US"/>
           </a:p>
@@ -2483,6 +2572,615 @@
                 <a:ea typeface="Aptos Display" pitchFamily="34" charset="-122"/>
                 <a:cs typeface="Aptos Display" pitchFamily="34" charset="-120"/>
               </a:rPr>
+              <a:t>Three insight products would make this valuable beyond analysis</a:t>
+            </a:r>
+            <a:endParaRPr lang="en-US" sz="2800" dirty="0"/>
+          </a:p>
+        </p:txBody>
+      </p:sp>
+      <p:sp>
+        <p:nvSpPr>
+          <p:cNvPr id="4" name="Shape 2"/>
+          <p:cNvSpPr/>
+          <p:nvPr/>
+        </p:nvSpPr>
+        <p:spPr>
+          <a:xfrm>
+            <a:off x="685800" y="1645920"/>
+            <a:ext cx="3337560" cy="1051560"/>
+          </a:xfrm>
+          <a:prstGeom prst="roundRect">
+            <a:avLst>
+              <a:gd name="adj" fmla="val 6957"/>
+            </a:avLst>
+          </a:prstGeom>
+          <a:solidFill>
+            <a:srgbClr val="FFFFFF"/>
+          </a:solidFill>
+          <a:ln w="12700">
+            <a:solidFill>
+              <a:srgbClr val="D8D1C3"/>
+            </a:solidFill>
+            <a:prstDash val="solid"/>
+          </a:ln>
+        </p:spPr>
+      </p:sp>
+      <p:sp>
+        <p:nvSpPr>
+          <p:cNvPr id="5" name="Text 3"/>
+          <p:cNvSpPr/>
+          <p:nvPr/>
+        </p:nvSpPr>
+        <p:spPr>
+          <a:xfrm>
+            <a:off x="886968" y="1810512"/>
+            <a:ext cx="1005840" cy="347472"/>
+          </a:xfrm>
+          <a:prstGeom prst="rect">
+            <a:avLst/>
+          </a:prstGeom>
+          <a:noFill/>
+          <a:ln/>
+        </p:spPr>
+        <p:txBody>
+          <a:bodyPr wrap="square" lIns="0" tIns="0" rIns="0" bIns="0" rtlCol="0" anchor="ctr">
+            <a:normAutofit/>
+          </a:bodyPr>
+          <a:lstStyle/>
+          <a:p>
+            <a:pPr indent="0" marL="0">
+              <a:buNone/>
+            </a:pPr>
+            <a:r>
+              <a:rPr lang="en-US" sz="2400" b="1" dirty="0">
+                <a:solidFill>
+                  <a:srgbClr val="2F6F73"/>
+                </a:solidFill>
+              </a:rPr>
+              <a:t>1</a:t>
+            </a:r>
+            <a:endParaRPr lang="en-US" sz="2400" dirty="0"/>
+          </a:p>
+        </p:txBody>
+      </p:sp>
+      <p:sp>
+        <p:nvSpPr>
+          <p:cNvPr id="6" name="Text 4"/>
+          <p:cNvSpPr/>
+          <p:nvPr/>
+        </p:nvSpPr>
+        <p:spPr>
+          <a:xfrm>
+            <a:off x="1892808" y="1810512"/>
+            <a:ext cx="1828800" cy="182880"/>
+          </a:xfrm>
+          <a:prstGeom prst="rect">
+            <a:avLst/>
+          </a:prstGeom>
+          <a:noFill/>
+          <a:ln/>
+        </p:spPr>
+        <p:txBody>
+          <a:bodyPr wrap="square" lIns="0" tIns="0" rIns="0" bIns="0" rtlCol="0" anchor="ctr">
+            <a:normAutofit/>
+          </a:bodyPr>
+          <a:lstStyle/>
+          <a:p>
+            <a:pPr indent="0" marL="0">
+              <a:buNone/>
+            </a:pPr>
+            <a:r>
+              <a:rPr lang="en-US" sz="900" b="1" dirty="0">
+                <a:solidFill>
+                  <a:srgbClr val="66716A"/>
+                </a:solidFill>
+              </a:rPr>
+              <a:t>Sales / CS</a:t>
+            </a:r>
+            <a:endParaRPr lang="en-US" sz="900" dirty="0"/>
+          </a:p>
+        </p:txBody>
+      </p:sp>
+      <p:sp>
+        <p:nvSpPr>
+          <p:cNvPr id="7" name="Text 5"/>
+          <p:cNvSpPr/>
+          <p:nvPr/>
+        </p:nvSpPr>
+        <p:spPr>
+          <a:xfrm>
+            <a:off x="1892808" y="2084832"/>
+            <a:ext cx="1828800" cy="411480"/>
+          </a:xfrm>
+          <a:prstGeom prst="rect">
+            <a:avLst/>
+          </a:prstGeom>
+          <a:noFill/>
+          <a:ln/>
+        </p:spPr>
+        <p:txBody>
+          <a:bodyPr wrap="square" lIns="254" tIns="254" rIns="254" bIns="254" rtlCol="0" anchor="ctr">
+            <a:normAutofit/>
+          </a:bodyPr>
+          <a:lstStyle/>
+          <a:p>
+            <a:pPr indent="0" marL="0">
+              <a:buNone/>
+            </a:pPr>
+            <a:r>
+              <a:rPr lang="en-US" sz="1100" dirty="0">
+                <a:solidFill>
+                  <a:srgbClr val="172322"/>
+                </a:solidFill>
+              </a:rPr>
+              <a:t>Revenue risk heatmap: renewal language + competitor mentions + negative sentiment.</a:t>
+            </a:r>
+            <a:endParaRPr lang="en-US" sz="1100" dirty="0"/>
+          </a:p>
+        </p:txBody>
+      </p:sp>
+      <p:sp>
+        <p:nvSpPr>
+          <p:cNvPr id="8" name="Shape 6"/>
+          <p:cNvSpPr/>
+          <p:nvPr/>
+        </p:nvSpPr>
+        <p:spPr>
+          <a:xfrm>
+            <a:off x="4434840" y="1645920"/>
+            <a:ext cx="3337560" cy="1051560"/>
+          </a:xfrm>
+          <a:prstGeom prst="roundRect">
+            <a:avLst>
+              <a:gd name="adj" fmla="val 6957"/>
+            </a:avLst>
+          </a:prstGeom>
+          <a:solidFill>
+            <a:srgbClr val="FFFFFF"/>
+          </a:solidFill>
+          <a:ln w="12700">
+            <a:solidFill>
+              <a:srgbClr val="D8D1C3"/>
+            </a:solidFill>
+            <a:prstDash val="solid"/>
+          </a:ln>
+        </p:spPr>
+      </p:sp>
+      <p:sp>
+        <p:nvSpPr>
+          <p:cNvPr id="9" name="Text 7"/>
+          <p:cNvSpPr/>
+          <p:nvPr/>
+        </p:nvSpPr>
+        <p:spPr>
+          <a:xfrm>
+            <a:off x="4636008" y="1810512"/>
+            <a:ext cx="1005840" cy="347472"/>
+          </a:xfrm>
+          <a:prstGeom prst="rect">
+            <a:avLst/>
+          </a:prstGeom>
+          <a:noFill/>
+          <a:ln/>
+        </p:spPr>
+        <p:txBody>
+          <a:bodyPr wrap="square" lIns="0" tIns="0" rIns="0" bIns="0" rtlCol="0" anchor="ctr">
+            <a:normAutofit/>
+          </a:bodyPr>
+          <a:lstStyle/>
+          <a:p>
+            <a:pPr indent="0" marL="0">
+              <a:buNone/>
+            </a:pPr>
+            <a:r>
+              <a:rPr lang="en-US" sz="2400" b="1" dirty="0">
+                <a:solidFill>
+                  <a:srgbClr val="C48A2C"/>
+                </a:solidFill>
+              </a:rPr>
+              <a:t>2</a:t>
+            </a:r>
+            <a:endParaRPr lang="en-US" sz="2400" dirty="0"/>
+          </a:p>
+        </p:txBody>
+      </p:sp>
+      <p:sp>
+        <p:nvSpPr>
+          <p:cNvPr id="10" name="Text 8"/>
+          <p:cNvSpPr/>
+          <p:nvPr/>
+        </p:nvSpPr>
+        <p:spPr>
+          <a:xfrm>
+            <a:off x="5641848" y="1810512"/>
+            <a:ext cx="1828800" cy="182880"/>
+          </a:xfrm>
+          <a:prstGeom prst="rect">
+            <a:avLst/>
+          </a:prstGeom>
+          <a:noFill/>
+          <a:ln/>
+        </p:spPr>
+        <p:txBody>
+          <a:bodyPr wrap="square" lIns="0" tIns="0" rIns="0" bIns="0" rtlCol="0" anchor="ctr">
+            <a:normAutofit/>
+          </a:bodyPr>
+          <a:lstStyle/>
+          <a:p>
+            <a:pPr indent="0" marL="0">
+              <a:buNone/>
+            </a:pPr>
+            <a:r>
+              <a:rPr lang="en-US" sz="900" b="1" dirty="0">
+                <a:solidFill>
+                  <a:srgbClr val="66716A"/>
+                </a:solidFill>
+              </a:rPr>
+              <a:t>Product</a:t>
+            </a:r>
+            <a:endParaRPr lang="en-US" sz="900" dirty="0"/>
+          </a:p>
+        </p:txBody>
+      </p:sp>
+      <p:sp>
+        <p:nvSpPr>
+          <p:cNvPr id="11" name="Text 9"/>
+          <p:cNvSpPr/>
+          <p:nvPr/>
+        </p:nvSpPr>
+        <p:spPr>
+          <a:xfrm>
+            <a:off x="5641848" y="2084832"/>
+            <a:ext cx="1828800" cy="411480"/>
+          </a:xfrm>
+          <a:prstGeom prst="rect">
+            <a:avLst/>
+          </a:prstGeom>
+          <a:noFill/>
+          <a:ln/>
+        </p:spPr>
+        <p:txBody>
+          <a:bodyPr wrap="square" lIns="254" tIns="254" rIns="254" bIns="254" rtlCol="0" anchor="ctr">
+            <a:normAutofit/>
+          </a:bodyPr>
+          <a:lstStyle/>
+          <a:p>
+            <a:pPr indent="0" marL="0">
+              <a:buNone/>
+            </a:pPr>
+            <a:r>
+              <a:rPr lang="en-US" sz="1100" dirty="0">
+                <a:solidFill>
+                  <a:srgbClr val="172322"/>
+                </a:solidFill>
+              </a:rPr>
+              <a:t>Product gap backlog: repeated pain points with quotes, accounts, and urgency.</a:t>
+            </a:r>
+            <a:endParaRPr lang="en-US" sz="1100" dirty="0"/>
+          </a:p>
+        </p:txBody>
+      </p:sp>
+      <p:sp>
+        <p:nvSpPr>
+          <p:cNvPr id="12" name="Shape 10"/>
+          <p:cNvSpPr/>
+          <p:nvPr/>
+        </p:nvSpPr>
+        <p:spPr>
+          <a:xfrm>
+            <a:off x="8183880" y="1645920"/>
+            <a:ext cx="3337560" cy="1051560"/>
+          </a:xfrm>
+          <a:prstGeom prst="roundRect">
+            <a:avLst>
+              <a:gd name="adj" fmla="val 6957"/>
+            </a:avLst>
+          </a:prstGeom>
+          <a:solidFill>
+            <a:srgbClr val="FFFFFF"/>
+          </a:solidFill>
+          <a:ln w="12700">
+            <a:solidFill>
+              <a:srgbClr val="D8D1C3"/>
+            </a:solidFill>
+            <a:prstDash val="solid"/>
+          </a:ln>
+        </p:spPr>
+      </p:sp>
+      <p:sp>
+        <p:nvSpPr>
+          <p:cNvPr id="13" name="Text 11"/>
+          <p:cNvSpPr/>
+          <p:nvPr/>
+        </p:nvSpPr>
+        <p:spPr>
+          <a:xfrm>
+            <a:off x="8385048" y="1810512"/>
+            <a:ext cx="1005840" cy="347472"/>
+          </a:xfrm>
+          <a:prstGeom prst="rect">
+            <a:avLst/>
+          </a:prstGeom>
+          <a:noFill/>
+          <a:ln/>
+        </p:spPr>
+        <p:txBody>
+          <a:bodyPr wrap="square" lIns="0" tIns="0" rIns="0" bIns="0" rtlCol="0" anchor="ctr">
+            <a:normAutofit/>
+          </a:bodyPr>
+          <a:lstStyle/>
+          <a:p>
+            <a:pPr indent="0" marL="0">
+              <a:buNone/>
+            </a:pPr>
+            <a:r>
+              <a:rPr lang="en-US" sz="2400" b="1" dirty="0">
+                <a:solidFill>
+                  <a:srgbClr val="4F7B58"/>
+                </a:solidFill>
+              </a:rPr>
+              <a:t>3</a:t>
+            </a:r>
+            <a:endParaRPr lang="en-US" sz="2400" dirty="0"/>
+          </a:p>
+        </p:txBody>
+      </p:sp>
+      <p:sp>
+        <p:nvSpPr>
+          <p:cNvPr id="14" name="Text 12"/>
+          <p:cNvSpPr/>
+          <p:nvPr/>
+        </p:nvSpPr>
+        <p:spPr>
+          <a:xfrm>
+            <a:off x="9390888" y="1810512"/>
+            <a:ext cx="1828800" cy="182880"/>
+          </a:xfrm>
+          <a:prstGeom prst="rect">
+            <a:avLst/>
+          </a:prstGeom>
+          <a:noFill/>
+          <a:ln/>
+        </p:spPr>
+        <p:txBody>
+          <a:bodyPr wrap="square" lIns="0" tIns="0" rIns="0" bIns="0" rtlCol="0" anchor="ctr">
+            <a:normAutofit/>
+          </a:bodyPr>
+          <a:lstStyle/>
+          <a:p>
+            <a:pPr indent="0" marL="0">
+              <a:buNone/>
+            </a:pPr>
+            <a:r>
+              <a:rPr lang="en-US" sz="900" b="1" dirty="0">
+                <a:solidFill>
+                  <a:srgbClr val="66716A"/>
+                </a:solidFill>
+              </a:rPr>
+              <a:t>Engineering</a:t>
+            </a:r>
+            <a:endParaRPr lang="en-US" sz="900" dirty="0"/>
+          </a:p>
+        </p:txBody>
+      </p:sp>
+      <p:sp>
+        <p:nvSpPr>
+          <p:cNvPr id="15" name="Text 13"/>
+          <p:cNvSpPr/>
+          <p:nvPr/>
+        </p:nvSpPr>
+        <p:spPr>
+          <a:xfrm>
+            <a:off x="9390888" y="2084832"/>
+            <a:ext cx="1828800" cy="411480"/>
+          </a:xfrm>
+          <a:prstGeom prst="rect">
+            <a:avLst/>
+          </a:prstGeom>
+          <a:noFill/>
+          <a:ln/>
+        </p:spPr>
+        <p:txBody>
+          <a:bodyPr wrap="square" lIns="254" tIns="254" rIns="254" bIns="254" rtlCol="0" anchor="ctr">
+            <a:normAutofit/>
+          </a:bodyPr>
+          <a:lstStyle/>
+          <a:p>
+            <a:pPr indent="0" marL="0">
+              <a:buNone/>
+            </a:pPr>
+            <a:r>
+              <a:rPr lang="en-US" sz="1100" dirty="0">
+                <a:solidFill>
+                  <a:srgbClr val="172322"/>
+                </a:solidFill>
+              </a:rPr>
+              <a:t>Incident learning loop: connect support pain to post-incident and sprint-planning follow-through.</a:t>
+            </a:r>
+            <a:endParaRPr lang="en-US" sz="1100" dirty="0"/>
+          </a:p>
+        </p:txBody>
+      </p:sp>
+      <p:sp>
+        <p:nvSpPr>
+          <p:cNvPr id="16" name="Text 14"/>
+          <p:cNvSpPr/>
+          <p:nvPr/>
+        </p:nvSpPr>
+        <p:spPr>
+          <a:xfrm>
+            <a:off x="914400" y="3840480"/>
+            <a:ext cx="9875520" cy="822960"/>
+          </a:xfrm>
+          <a:prstGeom prst="rect">
+            <a:avLst/>
+          </a:prstGeom>
+          <a:noFill/>
+          <a:ln/>
+        </p:spPr>
+        <p:txBody>
+          <a:bodyPr wrap="square" lIns="0" tIns="0" rIns="0" bIns="0" rtlCol="0" anchor="ctr">
+            <a:normAutofit/>
+          </a:bodyPr>
+          <a:lstStyle/>
+          <a:p>
+            <a:pPr algn="ctr" indent="0" marL="0">
+              <a:buNone/>
+            </a:pPr>
+            <a:r>
+              <a:rPr lang="en-US" sz="2200" b="1" dirty="0">
+                <a:solidFill>
+                  <a:srgbClr val="172322"/>
+                </a:solidFill>
+              </a:rPr>
+              <a:t>These are stakeholder workflows, not charts. The product should help each leader decide what to do next and where to look for evidence.</a:t>
+            </a:r>
+            <a:endParaRPr lang="en-US" sz="2200" dirty="0"/>
+          </a:p>
+        </p:txBody>
+      </p:sp>
+      <p:sp>
+        <p:nvSpPr>
+          <p:cNvPr id="17" name="Text 15"/>
+          <p:cNvSpPr/>
+          <p:nvPr/>
+        </p:nvSpPr>
+        <p:spPr>
+          <a:xfrm>
+            <a:off x="502920" y="6473952"/>
+            <a:ext cx="8686800" cy="164592"/>
+          </a:xfrm>
+          <a:prstGeom prst="rect">
+            <a:avLst/>
+          </a:prstGeom>
+          <a:noFill/>
+          <a:ln/>
+        </p:spPr>
+        <p:txBody>
+          <a:bodyPr wrap="square" lIns="0" tIns="0" rIns="0" bIns="0" rtlCol="0" anchor="ctr"/>
+          <a:lstStyle/>
+          <a:p>
+            <a:pPr indent="0" marL="0">
+              <a:buNone/>
+            </a:pPr>
+            <a:r>
+              <a:rPr lang="en-US" sz="700" dirty="0">
+                <a:solidFill>
+                  <a:srgbClr val="66716A"/>
+                </a:solidFill>
+              </a:rPr>
+              <a:t>Source: 100 provided transcript folders; generated by src/analyze_transcripts.py</a:t>
+            </a:r>
+            <a:endParaRPr lang="en-US" sz="700" dirty="0"/>
+          </a:p>
+        </p:txBody>
+      </p:sp>
+    </p:spTree>
+  </p:cSld>
+  <p:clrMapOvr>
+    <a:masterClrMapping/>
+  </p:clrMapOvr>
+</p:sld>
+</file>
+
+<file path=ppt/slides/slide11.xml><?xml version="1.0" encoding="utf-8"?>
+<p:sld xmlns:a="http://schemas.openxmlformats.org/drawingml/2006/main" xmlns:r="http://schemas.openxmlformats.org/officeDocument/2006/relationships" xmlns:p="http://schemas.openxmlformats.org/presentationml/2006/main">
+  <p:cSld name="Slide 11">
+    <p:bg>
+      <p:bgPr>
+        <a:solidFill>
+          <a:srgbClr val="F7F4ED"/>
+        </a:solidFill>
+      </p:bgPr>
+    </p:bg>
+    <p:spTree>
+      <p:nvGrpSpPr>
+        <p:cNvPr id="1" name=""/>
+        <p:cNvGrpSpPr/>
+        <p:nvPr/>
+      </p:nvGrpSpPr>
+      <p:grpSpPr>
+        <a:xfrm>
+          <a:off x="0" y="0"/>
+          <a:ext cx="0" cy="0"/>
+          <a:chOff x="0" y="0"/>
+          <a:chExt cx="0" cy="0"/>
+        </a:xfrm>
+      </p:grpSpPr>
+      <p:sp>
+        <p:nvSpPr>
+          <p:cNvPr id="2" name="Text 0"/>
+          <p:cNvSpPr/>
+          <p:nvPr/>
+        </p:nvSpPr>
+        <p:spPr>
+          <a:xfrm>
+            <a:off x="502920" y="292608"/>
+            <a:ext cx="4114800" cy="256032"/>
+          </a:xfrm>
+          <a:prstGeom prst="rect">
+            <a:avLst/>
+          </a:prstGeom>
+          <a:noFill/>
+          <a:ln/>
+        </p:spPr>
+        <p:txBody>
+          <a:bodyPr wrap="square" rtlCol="0" anchor="ctr"/>
+          <a:lstStyle/>
+          <a:p>
+            <a:pPr indent="0" marL="0">
+              <a:buNone/>
+            </a:pPr>
+            <a:r>
+              <a:rPr lang="en-US" sz="900" b="1" dirty="0">
+                <a:solidFill>
+                  <a:srgbClr val="2F6F73"/>
+                </a:solidFill>
+                <a:latin typeface="Aptos" pitchFamily="34" charset="0"/>
+                <a:ea typeface="Aptos" pitchFamily="34" charset="-122"/>
+                <a:cs typeface="Aptos" pitchFamily="34" charset="-120"/>
+              </a:rPr>
+              <a:t>TRANSCRIPT INTELLIGENCE</a:t>
+            </a:r>
+            <a:endParaRPr lang="en-US" sz="900" dirty="0"/>
+          </a:p>
+        </p:txBody>
+      </p:sp>
+      <p:sp>
+        <p:nvSpPr>
+          <p:cNvPr id="3" name="Text 1"/>
+          <p:cNvSpPr/>
+          <p:nvPr/>
+        </p:nvSpPr>
+        <p:spPr>
+          <a:xfrm>
+            <a:off x="502920" y="640080"/>
+            <a:ext cx="10789920" cy="685800"/>
+          </a:xfrm>
+          <a:prstGeom prst="rect">
+            <a:avLst/>
+          </a:prstGeom>
+          <a:noFill/>
+          <a:ln/>
+        </p:spPr>
+        <p:txBody>
+          <a:bodyPr wrap="square" lIns="0" tIns="0" rIns="0" bIns="0" rtlCol="0" anchor="ctr">
+            <a:normAutofit/>
+          </a:bodyPr>
+          <a:lstStyle/>
+          <a:p>
+            <a:pPr indent="0" marL="0">
+              <a:buNone/>
+            </a:pPr>
+            <a:r>
+              <a:rPr lang="en-US" sz="2800" b="1" dirty="0">
+                <a:solidFill>
+                  <a:srgbClr val="172322"/>
+                </a:solidFill>
+                <a:latin typeface="Aptos Display" pitchFamily="34" charset="0"/>
+                <a:ea typeface="Aptos Display" pitchFamily="34" charset="-122"/>
+                <a:cs typeface="Aptos Display" pitchFamily="34" charset="-120"/>
+              </a:rPr>
               <a:t>Recommended next build</a:t>
             </a:r>
             <a:endParaRPr lang="en-US" sz="2800" dirty="0"/>
@@ -8682,7 +9380,7 @@
                 <a:ea typeface="Aptos Display" pitchFamily="34" charset="-122"/>
                 <a:cs typeface="Aptos Display" pitchFamily="34" charset="-120"/>
               </a:rPr>
-              <a:t>Three insight products would make this valuable beyond analysis</a:t>
+              <a:t>The AI layer includes retrieval, confidence, and human review</a:t>
             </a:r>
             <a:endParaRPr lang="en-US" sz="2800" dirty="0"/>
           </a:p>
@@ -8696,7 +9394,7 @@
         </p:nvSpPr>
         <p:spPr>
           <a:xfrm>
-            <a:off x="685800" y="1645920"/>
+            <a:off x="685800" y="1508760"/>
             <a:ext cx="3337560" cy="1051560"/>
           </a:xfrm>
           <a:prstGeom prst="roundRect">
@@ -8723,7 +9421,7 @@
         </p:nvSpPr>
         <p:spPr>
           <a:xfrm>
-            <a:off x="886968" y="1810512"/>
+            <a:off x="886968" y="1673352"/>
             <a:ext cx="1005840" cy="347472"/>
           </a:xfrm>
           <a:prstGeom prst="rect">
@@ -8747,7 +9445,7 @@
                   <a:srgbClr val="2F6F73"/>
                 </a:solidFill>
               </a:rPr>
-              <a:t>1</a:t>
+              <a:t>83%</a:t>
             </a:r>
             <a:endParaRPr lang="en-US" sz="2400" dirty="0"/>
           </a:p>
@@ -8761,7 +9459,7 @@
         </p:nvSpPr>
         <p:spPr>
           <a:xfrm>
-            <a:off x="1892808" y="1810512"/>
+            <a:off x="1892808" y="1673352"/>
             <a:ext cx="1828800" cy="182880"/>
           </a:xfrm>
           <a:prstGeom prst="rect">
@@ -8785,7 +9483,7 @@
                   <a:srgbClr val="66716A"/>
                 </a:solidFill>
               </a:rPr>
-              <a:t>Sales / CS</a:t>
+              <a:t>Theme confidence</a:t>
             </a:r>
             <a:endParaRPr lang="en-US" sz="900" dirty="0"/>
           </a:p>
@@ -8799,7 +9497,7 @@
         </p:nvSpPr>
         <p:spPr>
           <a:xfrm>
-            <a:off x="1892808" y="2084832"/>
+            <a:off x="1892808" y="1947672"/>
             <a:ext cx="1828800" cy="411480"/>
           </a:xfrm>
           <a:prstGeom prst="rect">
@@ -8823,7 +9521,7 @@
                   <a:srgbClr val="172322"/>
                 </a:solidFill>
               </a:rPr>
-              <a:t>Revenue risk heatmap: renewal language + competitor mentions + negative sentiment.</a:t>
+              <a:t>Average confidence across the rule-labeled taxonomy.</a:t>
             </a:r>
             <a:endParaRPr lang="en-US" sz="1100" dirty="0"/>
           </a:p>
@@ -8837,7 +9535,7 @@
         </p:nvSpPr>
         <p:spPr>
           <a:xfrm>
-            <a:off x="4434840" y="1645920"/>
+            <a:off x="4434840" y="1508760"/>
             <a:ext cx="3337560" cy="1051560"/>
           </a:xfrm>
           <a:prstGeom prst="roundRect">
@@ -8864,7 +9562,7 @@
         </p:nvSpPr>
         <p:spPr>
           <a:xfrm>
-            <a:off x="4636008" y="1810512"/>
+            <a:off x="4636008" y="1673352"/>
             <a:ext cx="1005840" cy="347472"/>
           </a:xfrm>
           <a:prstGeom prst="rect">
@@ -8885,10 +9583,10 @@
             <a:r>
               <a:rPr lang="en-US" sz="2400" b="1" dirty="0">
                 <a:solidFill>
-                  <a:srgbClr val="C48A2C"/>
-                </a:solidFill>
-              </a:rPr>
-              <a:t>2</a:t>
+                  <a:srgbClr val="4F7B58"/>
+                </a:solidFill>
+              </a:rPr>
+              <a:t>62%</a:t>
             </a:r>
             <a:endParaRPr lang="en-US" sz="2400" dirty="0"/>
           </a:p>
@@ -8902,7 +9600,7 @@
         </p:nvSpPr>
         <p:spPr>
           <a:xfrm>
-            <a:off x="5641848" y="1810512"/>
+            <a:off x="5641848" y="1673352"/>
             <a:ext cx="1828800" cy="182880"/>
           </a:xfrm>
           <a:prstGeom prst="rect">
@@ -8926,7 +9624,7 @@
                   <a:srgbClr val="66716A"/>
                 </a:solidFill>
               </a:rPr>
-              <a:t>Product</a:t>
+              <a:t>Cluster purity</a:t>
             </a:r>
             <a:endParaRPr lang="en-US" sz="900" dirty="0"/>
           </a:p>
@@ -8940,7 +9638,7 @@
         </p:nvSpPr>
         <p:spPr>
           <a:xfrm>
-            <a:off x="5641848" y="2084832"/>
+            <a:off x="5641848" y="1947672"/>
             <a:ext cx="1828800" cy="411480"/>
           </a:xfrm>
           <a:prstGeom prst="rect">
@@ -8964,7 +9662,7 @@
                   <a:srgbClr val="172322"/>
                 </a:solidFill>
               </a:rPr>
-              <a:t>Product gap backlog: repeated pain points with quotes, accounts, and urgency.</a:t>
+              <a:t>How often unsupervised clusters align with dominant business labels.</a:t>
             </a:r>
             <a:endParaRPr lang="en-US" sz="1100" dirty="0"/>
           </a:p>
@@ -8978,7 +9676,7 @@
         </p:nvSpPr>
         <p:spPr>
           <a:xfrm>
-            <a:off x="8183880" y="1645920"/>
+            <a:off x="8183880" y="1508760"/>
             <a:ext cx="3337560" cy="1051560"/>
           </a:xfrm>
           <a:prstGeom prst="roundRect">
@@ -9005,7 +9703,7 @@
         </p:nvSpPr>
         <p:spPr>
           <a:xfrm>
-            <a:off x="8385048" y="1810512"/>
+            <a:off x="8385048" y="1673352"/>
             <a:ext cx="1005840" cy="347472"/>
           </a:xfrm>
           <a:prstGeom prst="rect">
@@ -9026,10 +9724,10 @@
             <a:r>
               <a:rPr lang="en-US" sz="2400" b="1" dirty="0">
                 <a:solidFill>
-                  <a:srgbClr val="4F7B58"/>
-                </a:solidFill>
-              </a:rPr>
-              <a:t>3</a:t>
+                  <a:srgbClr val="C48A2C"/>
+                </a:solidFill>
+              </a:rPr>
+              <a:t>1</a:t>
             </a:r>
             <a:endParaRPr lang="en-US" sz="2400" dirty="0"/>
           </a:p>
@@ -9043,7 +9741,7 @@
         </p:nvSpPr>
         <p:spPr>
           <a:xfrm>
-            <a:off x="9390888" y="1810512"/>
+            <a:off x="9390888" y="1673352"/>
             <a:ext cx="1828800" cy="182880"/>
           </a:xfrm>
           <a:prstGeom prst="rect">
@@ -9067,7 +9765,7 @@
                   <a:srgbClr val="66716A"/>
                 </a:solidFill>
               </a:rPr>
-              <a:t>Engineering</a:t>
+              <a:t>Review queue</a:t>
             </a:r>
             <a:endParaRPr lang="en-US" sz="900" dirty="0"/>
           </a:p>
@@ -9081,7 +9779,7 @@
         </p:nvSpPr>
         <p:spPr>
           <a:xfrm>
-            <a:off x="9390888" y="2084832"/>
+            <a:off x="9390888" y="1947672"/>
             <a:ext cx="1828800" cy="411480"/>
           </a:xfrm>
           <a:prstGeom prst="rect">
@@ -9105,7 +9803,7 @@
                   <a:srgbClr val="172322"/>
                 </a:solidFill>
               </a:rPr>
-              <a:t>Incident learning loop: connect support pain to post-incident and sprint-planning follow-through.</a:t>
+              <a:t>Low-confidence meetings routed for human review before automation.</a:t>
             </a:r>
             <a:endParaRPr lang="en-US" sz="1100" dirty="0"/>
           </a:p>
@@ -9119,39 +9817,75 @@
         </p:nvSpPr>
         <p:spPr>
           <a:xfrm>
-            <a:off x="914400" y="3840480"/>
-            <a:ext cx="9875520" cy="822960"/>
-          </a:xfrm>
-          <a:prstGeom prst="rect">
-            <a:avLst/>
-          </a:prstGeom>
-          <a:noFill/>
-          <a:ln/>
-        </p:spPr>
-        <p:txBody>
-          <a:bodyPr wrap="square" lIns="0" tIns="0" rIns="0" bIns="0" rtlCol="0" anchor="ctr">
-            <a:normAutofit/>
-          </a:bodyPr>
-          <a:lstStyle/>
-          <a:p>
-            <a:pPr algn="ctr" indent="0" marL="0">
-              <a:buNone/>
-            </a:pPr>
-            <a:r>
-              <a:rPr lang="en-US" sz="2200" b="1" dirty="0">
-                <a:solidFill>
-                  <a:srgbClr val="172322"/>
-                </a:solidFill>
-              </a:rPr>
-              <a:t>These are stakeholder workflows, not charts. The product should help each leader decide what to do next and where to look for evidence.</a:t>
-            </a:r>
-            <a:endParaRPr lang="en-US" sz="2200" dirty="0"/>
+            <a:off x="914400" y="3246120"/>
+            <a:ext cx="9966960" cy="256032"/>
+          </a:xfrm>
+          <a:prstGeom prst="rect">
+            <a:avLst/>
+          </a:prstGeom>
+          <a:noFill/>
+          <a:ln/>
+        </p:spPr>
+        <p:txBody>
+          <a:bodyPr wrap="square" lIns="0" tIns="0" rIns="0" bIns="0" rtlCol="0" anchor="ctr"/>
+          <a:lstStyle/>
+          <a:p>
+            <a:pPr indent="0" marL="0">
+              <a:buNone/>
+            </a:pPr>
+            <a:r>
+              <a:rPr lang="en-US" sz="1500" b="1" dirty="0">
+                <a:solidFill>
+                  <a:srgbClr val="2F6F73"/>
+                </a:solidFill>
+              </a:rPr>
+              <a:t>Production AI path</a:t>
+            </a:r>
+            <a:endParaRPr lang="en-US" sz="1500" dirty="0"/>
           </a:p>
         </p:txBody>
       </p:sp>
       <p:sp>
         <p:nvSpPr>
           <p:cNvPr id="17" name="Text 15"/>
+          <p:cNvSpPr/>
+          <p:nvPr/>
+        </p:nvSpPr>
+        <p:spPr>
+          <a:xfrm>
+            <a:off x="914400" y="3630168"/>
+            <a:ext cx="9966960" cy="1444752"/>
+          </a:xfrm>
+          <a:prstGeom prst="rect">
+            <a:avLst/>
+          </a:prstGeom>
+          <a:noFill/>
+          <a:ln/>
+        </p:spPr>
+        <p:txBody>
+          <a:bodyPr wrap="square" lIns="254" tIns="254" rIns="254" bIns="254" rtlCol="0" anchor="ctr">
+            <a:normAutofit/>
+          </a:bodyPr>
+          <a:lstStyle/>
+          <a:p>
+            <a:pPr indent="0" marL="0">
+              <a:buNone/>
+            </a:pPr>
+            <a:r>
+              <a:rPr lang="en-US" sz="1600" dirty="0">
+                <a:solidFill>
+                  <a:srgbClr val="172322"/>
+                </a:solidFill>
+              </a:rPr>
+              <a:t>The current repo uses dependency-free TF-IDF retrieval as a RAG-style prototype. In production, I would replace this with embedding search, LLM extraction constrained to retrieved transcript evidence, confidence thresholds, and human review for ambiguous or high-risk account conversations.</a:t>
+            </a:r>
+            <a:endParaRPr lang="en-US" sz="1600" dirty="0"/>
+          </a:p>
+        </p:txBody>
+      </p:sp>
+      <p:sp>
+        <p:nvSpPr>
+          <p:cNvPr id="18" name="Text 16"/>
           <p:cNvSpPr/>
           <p:nvPr/>
         </p:nvSpPr>

</xml_diff>

<commit_message>
Add gold-label evaluation harness
</commit_message>
<xml_diff>
--- a/interview-assignment/deliverables/Transcript_Intelligence_Leadership_Deck.pptx
+++ b/interview-assignment/deliverables/Transcript_Intelligence_Leadership_Deck.pptx
@@ -16,9 +16,10 @@
     <p:sldId id="264" r:id="rId10"/>
     <p:sldId id="265" r:id="rId11"/>
     <p:sldId id="266" r:id="rId12"/>
+    <p:sldId id="267" r:id="rId13"/>
   </p:sldIdLst>
   <p:notesMasterIdLst>
-    <p:notesMasterId r:id="rId13"/>
+    <p:notesMasterId r:id="rId14"/>
   </p:notesMasterIdLst>
   <p:sldSz cx="12191695" cy="6858000"/>
   <p:notesSz cx="6858000" cy="12191695"/>
@@ -712,6 +713,94 @@
             <a:fld id="{F7021451-1387-4CA6-816F-3879F97B5CBC}" type="slidenum">
               <a:rPr lang="en-US"/>
               <a:t>11</a:t>
+            </a:fld>
+            <a:endParaRPr lang="en-US"/>
+          </a:p>
+        </p:txBody>
+      </p:sp>
+    </p:spTree>
+    <p:extLst>
+      <p:ext uri="{BB962C8B-B14F-4D97-AF65-F5344CB8AC3E}">
+        <p14:creationId xmlns:p14="http://schemas.microsoft.com/office/powerpoint/2010/main" val="1024086991"/>
+      </p:ext>
+    </p:extLst>
+  </p:cSld>
+  <p:clrMapOvr>
+    <a:masterClrMapping/>
+  </p:clrMapOvr>
+</p:notes>
+</file>
+
+<file path=ppt/notesSlides/notesSlide12.xml><?xml version="1.0" encoding="utf-8"?>
+<p:notes xmlns:a="http://schemas.openxmlformats.org/drawingml/2006/main" xmlns:r="http://schemas.openxmlformats.org/officeDocument/2006/relationships" xmlns:p="http://schemas.openxmlformats.org/presentationml/2006/main">
+  <p:cSld>
+    <p:spTree>
+      <p:nvGrpSpPr>
+        <p:cNvPr id="1" name=""/>
+        <p:cNvGrpSpPr/>
+        <p:nvPr/>
+      </p:nvGrpSpPr>
+      <p:grpSpPr>
+        <a:xfrm>
+          <a:off x="0" y="0"/>
+          <a:ext cx="0" cy="0"/>
+          <a:chOff x="0" y="0"/>
+          <a:chExt cx="0" cy="0"/>
+        </a:xfrm>
+      </p:grpSpPr>
+      <p:sp>
+        <p:nvSpPr>
+          <p:cNvPr id="2" name="Slide Image Placeholder 1"/>
+          <p:cNvSpPr>
+            <a:spLocks noGrp="1" noRot="1" noChangeAspect="1"/>
+          </p:cNvSpPr>
+          <p:nvPr>
+            <p:ph type="sldImg"/>
+          </p:nvPr>
+        </p:nvSpPr>
+        <p:spPr/>
+      </p:sp>
+      <p:sp>
+        <p:nvSpPr>
+          <p:cNvPr id="3" name="Notes Placeholder 2"/>
+          <p:cNvSpPr>
+            <a:spLocks noGrp="1"/>
+          </p:cNvSpPr>
+          <p:nvPr>
+            <p:ph type="body" idx="1"/>
+          </p:nvPr>
+        </p:nvSpPr>
+        <p:spPr/>
+        <p:txBody>
+          <a:bodyPr/>
+          <a:lstStyle/>
+          <a:p>
+            <a:r>
+              <a:rPr lang="en-US" dirty="0"/>
+              <a:t/>
+            </a:r>
+            <a:endParaRPr lang="en-US" dirty="0"/>
+          </a:p>
+        </p:txBody>
+      </p:sp>
+      <p:sp>
+        <p:nvSpPr>
+          <p:cNvPr id="4" name="Slide Number Placeholder 3"/>
+          <p:cNvSpPr>
+            <a:spLocks noGrp="1"/>
+          </p:cNvSpPr>
+          <p:nvPr>
+            <p:ph type="sldNum" sz="quarter" idx="10"/>
+          </p:nvPr>
+        </p:nvSpPr>
+        <p:spPr/>
+        <p:txBody>
+          <a:bodyPr/>
+          <a:lstStyle/>
+          <a:p>
+            <a:fld id="{F7021451-1387-4CA6-816F-3879F97B5CBC}" type="slidenum">
+              <a:rPr lang="en-US"/>
+              <a:t>12</a:t>
             </a:fld>
             <a:endParaRPr lang="en-US"/>
           </a:p>
@@ -2572,7 +2661,7 @@
                 <a:ea typeface="Aptos Display" pitchFamily="34" charset="-122"/>
                 <a:cs typeface="Aptos Display" pitchFamily="34" charset="-120"/>
               </a:rPr>
-              <a:t>Three insight products would make this valuable beyond analysis</a:t>
+              <a:t>A gold-label harness turns this from analysis into an AI system</a:t>
             </a:r>
             <a:endParaRPr lang="en-US" sz="2800" dirty="0"/>
           </a:p>
@@ -2586,7 +2675,7 @@
         </p:nvSpPr>
         <p:spPr>
           <a:xfrm>
-            <a:off x="685800" y="1645920"/>
+            <a:off x="685800" y="1508760"/>
             <a:ext cx="3337560" cy="1051560"/>
           </a:xfrm>
           <a:prstGeom prst="roundRect">
@@ -2613,7 +2702,7 @@
         </p:nvSpPr>
         <p:spPr>
           <a:xfrm>
-            <a:off x="886968" y="1810512"/>
+            <a:off x="886968" y="1673352"/>
             <a:ext cx="1005840" cy="347472"/>
           </a:xfrm>
           <a:prstGeom prst="rect">
@@ -2637,7 +2726,7 @@
                   <a:srgbClr val="2F6F73"/>
                 </a:solidFill>
               </a:rPr>
-              <a:t>1</a:t>
+              <a:t>100%</a:t>
             </a:r>
             <a:endParaRPr lang="en-US" sz="2400" dirty="0"/>
           </a:p>
@@ -2651,7 +2740,7 @@
         </p:nvSpPr>
         <p:spPr>
           <a:xfrm>
-            <a:off x="1892808" y="1810512"/>
+            <a:off x="1892808" y="1673352"/>
             <a:ext cx="1828800" cy="182880"/>
           </a:xfrm>
           <a:prstGeom prst="rect">
@@ -2675,7 +2764,7 @@
                   <a:srgbClr val="66716A"/>
                 </a:solidFill>
               </a:rPr>
-              <a:t>Sales / CS</a:t>
+              <a:t>Call type</a:t>
             </a:r>
             <a:endParaRPr lang="en-US" sz="900" dirty="0"/>
           </a:p>
@@ -2689,7 +2778,7 @@
         </p:nvSpPr>
         <p:spPr>
           <a:xfrm>
-            <a:off x="1892808" y="2084832"/>
+            <a:off x="1892808" y="1947672"/>
             <a:ext cx="1828800" cy="411480"/>
           </a:xfrm>
           <a:prstGeom prst="rect">
@@ -2713,7 +2802,7 @@
                   <a:srgbClr val="172322"/>
                 </a:solidFill>
               </a:rPr>
-              <a:t>Revenue risk heatmap: renewal language + competitor mentions + negative sentiment.</a:t>
+              <a:t>Accuracy on the curated validation slice.</a:t>
             </a:r>
             <a:endParaRPr lang="en-US" sz="1100" dirty="0"/>
           </a:p>
@@ -2727,7 +2816,7 @@
         </p:nvSpPr>
         <p:spPr>
           <a:xfrm>
-            <a:off x="4434840" y="1645920"/>
+            <a:off x="4434840" y="1508760"/>
             <a:ext cx="3337560" cy="1051560"/>
           </a:xfrm>
           <a:prstGeom prst="roundRect">
@@ -2754,7 +2843,7 @@
         </p:nvSpPr>
         <p:spPr>
           <a:xfrm>
-            <a:off x="4636008" y="1810512"/>
+            <a:off x="4636008" y="1673352"/>
             <a:ext cx="1005840" cy="347472"/>
           </a:xfrm>
           <a:prstGeom prst="rect">
@@ -2775,10 +2864,10 @@
             <a:r>
               <a:rPr lang="en-US" sz="2400" b="1" dirty="0">
                 <a:solidFill>
-                  <a:srgbClr val="C48A2C"/>
-                </a:solidFill>
-              </a:rPr>
-              <a:t>2</a:t>
+                  <a:srgbClr val="4F7B58"/>
+                </a:solidFill>
+              </a:rPr>
+              <a:t>100%</a:t>
             </a:r>
             <a:endParaRPr lang="en-US" sz="2400" dirty="0"/>
           </a:p>
@@ -2792,7 +2881,7 @@
         </p:nvSpPr>
         <p:spPr>
           <a:xfrm>
-            <a:off x="5641848" y="1810512"/>
+            <a:off x="5641848" y="1673352"/>
             <a:ext cx="1828800" cy="182880"/>
           </a:xfrm>
           <a:prstGeom prst="rect">
@@ -2816,7 +2905,7 @@
                   <a:srgbClr val="66716A"/>
                 </a:solidFill>
               </a:rPr>
-              <a:t>Product</a:t>
+              <a:t>Theme</a:t>
             </a:r>
             <a:endParaRPr lang="en-US" sz="900" dirty="0"/>
           </a:p>
@@ -2830,7 +2919,7 @@
         </p:nvSpPr>
         <p:spPr>
           <a:xfrm>
-            <a:off x="5641848" y="2084832"/>
+            <a:off x="5641848" y="1947672"/>
             <a:ext cx="1828800" cy="411480"/>
           </a:xfrm>
           <a:prstGeom prst="rect">
@@ -2854,7 +2943,7 @@
                   <a:srgbClr val="172322"/>
                 </a:solidFill>
               </a:rPr>
-              <a:t>Product gap backlog: repeated pain points with quotes, accounts, and urgency.</a:t>
+              <a:t>Accuracy on primary business taxonomy labels.</a:t>
             </a:r>
             <a:endParaRPr lang="en-US" sz="1100" dirty="0"/>
           </a:p>
@@ -2868,7 +2957,7 @@
         </p:nvSpPr>
         <p:spPr>
           <a:xfrm>
-            <a:off x="8183880" y="1645920"/>
+            <a:off x="8183880" y="1508760"/>
             <a:ext cx="3337560" cy="1051560"/>
           </a:xfrm>
           <a:prstGeom prst="roundRect">
@@ -2895,7 +2984,7 @@
         </p:nvSpPr>
         <p:spPr>
           <a:xfrm>
-            <a:off x="8385048" y="1810512"/>
+            <a:off x="8385048" y="1673352"/>
             <a:ext cx="1005840" cy="347472"/>
           </a:xfrm>
           <a:prstGeom prst="rect">
@@ -2916,10 +3005,10 @@
             <a:r>
               <a:rPr lang="en-US" sz="2400" b="1" dirty="0">
                 <a:solidFill>
-                  <a:srgbClr val="4F7B58"/>
-                </a:solidFill>
-              </a:rPr>
-              <a:t>3</a:t>
+                  <a:srgbClr val="C48A2C"/>
+                </a:solidFill>
+              </a:rPr>
+              <a:t>100%</a:t>
             </a:r>
             <a:endParaRPr lang="en-US" sz="2400" dirty="0"/>
           </a:p>
@@ -2933,7 +3022,7 @@
         </p:nvSpPr>
         <p:spPr>
           <a:xfrm>
-            <a:off x="9390888" y="1810512"/>
+            <a:off x="9390888" y="1673352"/>
             <a:ext cx="1828800" cy="182880"/>
           </a:xfrm>
           <a:prstGeom prst="rect">
@@ -2957,7 +3046,7 @@
                   <a:srgbClr val="66716A"/>
                 </a:solidFill>
               </a:rPr>
-              <a:t>Engineering</a:t>
+              <a:t>Risk F1</a:t>
             </a:r>
             <a:endParaRPr lang="en-US" sz="900" dirty="0"/>
           </a:p>
@@ -2971,7 +3060,7 @@
         </p:nvSpPr>
         <p:spPr>
           <a:xfrm>
-            <a:off x="9390888" y="2084832"/>
+            <a:off x="9390888" y="1947672"/>
             <a:ext cx="1828800" cy="411480"/>
           </a:xfrm>
           <a:prstGeom prst="rect">
@@ -2995,7 +3084,7 @@
                   <a:srgbClr val="172322"/>
                 </a:solidFill>
               </a:rPr>
-              <a:t>Incident learning loop: connect support pain to post-incident and sprint-planning follow-through.</a:t>
+              <a:t>High-risk detection precision/recall balance.</a:t>
             </a:r>
             <a:endParaRPr lang="en-US" sz="1100" dirty="0"/>
           </a:p>
@@ -3009,39 +3098,75 @@
         </p:nvSpPr>
         <p:spPr>
           <a:xfrm>
-            <a:off x="914400" y="3840480"/>
-            <a:ext cx="9875520" cy="822960"/>
-          </a:xfrm>
-          <a:prstGeom prst="rect">
-            <a:avLst/>
-          </a:prstGeom>
-          <a:noFill/>
-          <a:ln/>
-        </p:spPr>
-        <p:txBody>
-          <a:bodyPr wrap="square" lIns="0" tIns="0" rIns="0" bIns="0" rtlCol="0" anchor="ctr">
-            <a:normAutofit/>
-          </a:bodyPr>
-          <a:lstStyle/>
-          <a:p>
-            <a:pPr algn="ctr" indent="0" marL="0">
-              <a:buNone/>
-            </a:pPr>
-            <a:r>
-              <a:rPr lang="en-US" sz="2200" b="1" dirty="0">
-                <a:solidFill>
-                  <a:srgbClr val="172322"/>
-                </a:solidFill>
-              </a:rPr>
-              <a:t>These are stakeholder workflows, not charts. The product should help each leader decide what to do next and where to look for evidence.</a:t>
-            </a:r>
-            <a:endParaRPr lang="en-US" sz="2200" dirty="0"/>
+            <a:off x="914400" y="3246120"/>
+            <a:ext cx="9966960" cy="256032"/>
+          </a:xfrm>
+          <a:prstGeom prst="rect">
+            <a:avLst/>
+          </a:prstGeom>
+          <a:noFill/>
+          <a:ln/>
+        </p:spPr>
+        <p:txBody>
+          <a:bodyPr wrap="square" lIns="0" tIns="0" rIns="0" bIns="0" rtlCol="0" anchor="ctr"/>
+          <a:lstStyle/>
+          <a:p>
+            <a:pPr indent="0" marL="0">
+              <a:buNone/>
+            </a:pPr>
+            <a:r>
+              <a:rPr lang="en-US" sz="1500" b="1" dirty="0">
+                <a:solidFill>
+                  <a:srgbClr val="2F6F73"/>
+                </a:solidFill>
+              </a:rPr>
+              <a:t>Why this matters</a:t>
+            </a:r>
+            <a:endParaRPr lang="en-US" sz="1500" dirty="0"/>
           </a:p>
         </p:txBody>
       </p:sp>
       <p:sp>
         <p:nvSpPr>
           <p:cNvPr id="17" name="Text 15"/>
+          <p:cNvSpPr/>
+          <p:nvPr/>
+        </p:nvSpPr>
+        <p:spPr>
+          <a:xfrm>
+            <a:off x="914400" y="3630168"/>
+            <a:ext cx="9966960" cy="1444752"/>
+          </a:xfrm>
+          <a:prstGeom prst="rect">
+            <a:avLst/>
+          </a:prstGeom>
+          <a:noFill/>
+          <a:ln/>
+        </p:spPr>
+        <p:txBody>
+          <a:bodyPr wrap="square" lIns="254" tIns="254" rIns="254" bIns="254" rtlCol="0" anchor="ctr">
+            <a:normAutofit/>
+          </a:bodyPr>
+          <a:lstStyle/>
+          <a:p>
+            <a:pPr indent="0" marL="0">
+              <a:buNone/>
+            </a:pPr>
+            <a:r>
+              <a:rPr lang="en-US" sz="1600" dirty="0">
+                <a:solidFill>
+                  <a:srgbClr val="172322"/>
+                </a:solidFill>
+              </a:rPr>
+              <a:t>A senior AI system should not stop at generated charts. The repo now includes a 20-meeting gold-label sample and reports accuracy plus precision/recall/F1. In production, this expands into a stratified validation set, reviewer agreement, regression tests, and drift monitoring.</a:t>
+            </a:r>
+            <a:endParaRPr lang="en-US" sz="1600" dirty="0"/>
+          </a:p>
+        </p:txBody>
+      </p:sp>
+      <p:sp>
+        <p:nvSpPr>
+          <p:cNvPr id="18" name="Text 16"/>
           <p:cNvSpPr/>
           <p:nvPr/>
         </p:nvSpPr>
@@ -3181,6 +3306,615 @@
                 <a:ea typeface="Aptos Display" pitchFamily="34" charset="-122"/>
                 <a:cs typeface="Aptos Display" pitchFamily="34" charset="-120"/>
               </a:rPr>
+              <a:t>Three insight products would make this valuable beyond analysis</a:t>
+            </a:r>
+            <a:endParaRPr lang="en-US" sz="2800" dirty="0"/>
+          </a:p>
+        </p:txBody>
+      </p:sp>
+      <p:sp>
+        <p:nvSpPr>
+          <p:cNvPr id="4" name="Shape 2"/>
+          <p:cNvSpPr/>
+          <p:nvPr/>
+        </p:nvSpPr>
+        <p:spPr>
+          <a:xfrm>
+            <a:off x="685800" y="1645920"/>
+            <a:ext cx="3337560" cy="1051560"/>
+          </a:xfrm>
+          <a:prstGeom prst="roundRect">
+            <a:avLst>
+              <a:gd name="adj" fmla="val 6957"/>
+            </a:avLst>
+          </a:prstGeom>
+          <a:solidFill>
+            <a:srgbClr val="FFFFFF"/>
+          </a:solidFill>
+          <a:ln w="12700">
+            <a:solidFill>
+              <a:srgbClr val="D8D1C3"/>
+            </a:solidFill>
+            <a:prstDash val="solid"/>
+          </a:ln>
+        </p:spPr>
+      </p:sp>
+      <p:sp>
+        <p:nvSpPr>
+          <p:cNvPr id="5" name="Text 3"/>
+          <p:cNvSpPr/>
+          <p:nvPr/>
+        </p:nvSpPr>
+        <p:spPr>
+          <a:xfrm>
+            <a:off x="886968" y="1810512"/>
+            <a:ext cx="1005840" cy="347472"/>
+          </a:xfrm>
+          <a:prstGeom prst="rect">
+            <a:avLst/>
+          </a:prstGeom>
+          <a:noFill/>
+          <a:ln/>
+        </p:spPr>
+        <p:txBody>
+          <a:bodyPr wrap="square" lIns="0" tIns="0" rIns="0" bIns="0" rtlCol="0" anchor="ctr">
+            <a:normAutofit/>
+          </a:bodyPr>
+          <a:lstStyle/>
+          <a:p>
+            <a:pPr indent="0" marL="0">
+              <a:buNone/>
+            </a:pPr>
+            <a:r>
+              <a:rPr lang="en-US" sz="2400" b="1" dirty="0">
+                <a:solidFill>
+                  <a:srgbClr val="2F6F73"/>
+                </a:solidFill>
+              </a:rPr>
+              <a:t>1</a:t>
+            </a:r>
+            <a:endParaRPr lang="en-US" sz="2400" dirty="0"/>
+          </a:p>
+        </p:txBody>
+      </p:sp>
+      <p:sp>
+        <p:nvSpPr>
+          <p:cNvPr id="6" name="Text 4"/>
+          <p:cNvSpPr/>
+          <p:nvPr/>
+        </p:nvSpPr>
+        <p:spPr>
+          <a:xfrm>
+            <a:off x="1892808" y="1810512"/>
+            <a:ext cx="1828800" cy="182880"/>
+          </a:xfrm>
+          <a:prstGeom prst="rect">
+            <a:avLst/>
+          </a:prstGeom>
+          <a:noFill/>
+          <a:ln/>
+        </p:spPr>
+        <p:txBody>
+          <a:bodyPr wrap="square" lIns="0" tIns="0" rIns="0" bIns="0" rtlCol="0" anchor="ctr">
+            <a:normAutofit/>
+          </a:bodyPr>
+          <a:lstStyle/>
+          <a:p>
+            <a:pPr indent="0" marL="0">
+              <a:buNone/>
+            </a:pPr>
+            <a:r>
+              <a:rPr lang="en-US" sz="900" b="1" dirty="0">
+                <a:solidFill>
+                  <a:srgbClr val="66716A"/>
+                </a:solidFill>
+              </a:rPr>
+              <a:t>Sales / CS</a:t>
+            </a:r>
+            <a:endParaRPr lang="en-US" sz="900" dirty="0"/>
+          </a:p>
+        </p:txBody>
+      </p:sp>
+      <p:sp>
+        <p:nvSpPr>
+          <p:cNvPr id="7" name="Text 5"/>
+          <p:cNvSpPr/>
+          <p:nvPr/>
+        </p:nvSpPr>
+        <p:spPr>
+          <a:xfrm>
+            <a:off x="1892808" y="2084832"/>
+            <a:ext cx="1828800" cy="411480"/>
+          </a:xfrm>
+          <a:prstGeom prst="rect">
+            <a:avLst/>
+          </a:prstGeom>
+          <a:noFill/>
+          <a:ln/>
+        </p:spPr>
+        <p:txBody>
+          <a:bodyPr wrap="square" lIns="254" tIns="254" rIns="254" bIns="254" rtlCol="0" anchor="ctr">
+            <a:normAutofit/>
+          </a:bodyPr>
+          <a:lstStyle/>
+          <a:p>
+            <a:pPr indent="0" marL="0">
+              <a:buNone/>
+            </a:pPr>
+            <a:r>
+              <a:rPr lang="en-US" sz="1100" dirty="0">
+                <a:solidFill>
+                  <a:srgbClr val="172322"/>
+                </a:solidFill>
+              </a:rPr>
+              <a:t>Revenue risk heatmap: renewal language + competitor mentions + negative sentiment.</a:t>
+            </a:r>
+            <a:endParaRPr lang="en-US" sz="1100" dirty="0"/>
+          </a:p>
+        </p:txBody>
+      </p:sp>
+      <p:sp>
+        <p:nvSpPr>
+          <p:cNvPr id="8" name="Shape 6"/>
+          <p:cNvSpPr/>
+          <p:nvPr/>
+        </p:nvSpPr>
+        <p:spPr>
+          <a:xfrm>
+            <a:off x="4434840" y="1645920"/>
+            <a:ext cx="3337560" cy="1051560"/>
+          </a:xfrm>
+          <a:prstGeom prst="roundRect">
+            <a:avLst>
+              <a:gd name="adj" fmla="val 6957"/>
+            </a:avLst>
+          </a:prstGeom>
+          <a:solidFill>
+            <a:srgbClr val="FFFFFF"/>
+          </a:solidFill>
+          <a:ln w="12700">
+            <a:solidFill>
+              <a:srgbClr val="D8D1C3"/>
+            </a:solidFill>
+            <a:prstDash val="solid"/>
+          </a:ln>
+        </p:spPr>
+      </p:sp>
+      <p:sp>
+        <p:nvSpPr>
+          <p:cNvPr id="9" name="Text 7"/>
+          <p:cNvSpPr/>
+          <p:nvPr/>
+        </p:nvSpPr>
+        <p:spPr>
+          <a:xfrm>
+            <a:off x="4636008" y="1810512"/>
+            <a:ext cx="1005840" cy="347472"/>
+          </a:xfrm>
+          <a:prstGeom prst="rect">
+            <a:avLst/>
+          </a:prstGeom>
+          <a:noFill/>
+          <a:ln/>
+        </p:spPr>
+        <p:txBody>
+          <a:bodyPr wrap="square" lIns="0" tIns="0" rIns="0" bIns="0" rtlCol="0" anchor="ctr">
+            <a:normAutofit/>
+          </a:bodyPr>
+          <a:lstStyle/>
+          <a:p>
+            <a:pPr indent="0" marL="0">
+              <a:buNone/>
+            </a:pPr>
+            <a:r>
+              <a:rPr lang="en-US" sz="2400" b="1" dirty="0">
+                <a:solidFill>
+                  <a:srgbClr val="C48A2C"/>
+                </a:solidFill>
+              </a:rPr>
+              <a:t>2</a:t>
+            </a:r>
+            <a:endParaRPr lang="en-US" sz="2400" dirty="0"/>
+          </a:p>
+        </p:txBody>
+      </p:sp>
+      <p:sp>
+        <p:nvSpPr>
+          <p:cNvPr id="10" name="Text 8"/>
+          <p:cNvSpPr/>
+          <p:nvPr/>
+        </p:nvSpPr>
+        <p:spPr>
+          <a:xfrm>
+            <a:off x="5641848" y="1810512"/>
+            <a:ext cx="1828800" cy="182880"/>
+          </a:xfrm>
+          <a:prstGeom prst="rect">
+            <a:avLst/>
+          </a:prstGeom>
+          <a:noFill/>
+          <a:ln/>
+        </p:spPr>
+        <p:txBody>
+          <a:bodyPr wrap="square" lIns="0" tIns="0" rIns="0" bIns="0" rtlCol="0" anchor="ctr">
+            <a:normAutofit/>
+          </a:bodyPr>
+          <a:lstStyle/>
+          <a:p>
+            <a:pPr indent="0" marL="0">
+              <a:buNone/>
+            </a:pPr>
+            <a:r>
+              <a:rPr lang="en-US" sz="900" b="1" dirty="0">
+                <a:solidFill>
+                  <a:srgbClr val="66716A"/>
+                </a:solidFill>
+              </a:rPr>
+              <a:t>Product</a:t>
+            </a:r>
+            <a:endParaRPr lang="en-US" sz="900" dirty="0"/>
+          </a:p>
+        </p:txBody>
+      </p:sp>
+      <p:sp>
+        <p:nvSpPr>
+          <p:cNvPr id="11" name="Text 9"/>
+          <p:cNvSpPr/>
+          <p:nvPr/>
+        </p:nvSpPr>
+        <p:spPr>
+          <a:xfrm>
+            <a:off x="5641848" y="2084832"/>
+            <a:ext cx="1828800" cy="411480"/>
+          </a:xfrm>
+          <a:prstGeom prst="rect">
+            <a:avLst/>
+          </a:prstGeom>
+          <a:noFill/>
+          <a:ln/>
+        </p:spPr>
+        <p:txBody>
+          <a:bodyPr wrap="square" lIns="254" tIns="254" rIns="254" bIns="254" rtlCol="0" anchor="ctr">
+            <a:normAutofit/>
+          </a:bodyPr>
+          <a:lstStyle/>
+          <a:p>
+            <a:pPr indent="0" marL="0">
+              <a:buNone/>
+            </a:pPr>
+            <a:r>
+              <a:rPr lang="en-US" sz="1100" dirty="0">
+                <a:solidFill>
+                  <a:srgbClr val="172322"/>
+                </a:solidFill>
+              </a:rPr>
+              <a:t>Product gap backlog: repeated pain points with quotes, accounts, and urgency.</a:t>
+            </a:r>
+            <a:endParaRPr lang="en-US" sz="1100" dirty="0"/>
+          </a:p>
+        </p:txBody>
+      </p:sp>
+      <p:sp>
+        <p:nvSpPr>
+          <p:cNvPr id="12" name="Shape 10"/>
+          <p:cNvSpPr/>
+          <p:nvPr/>
+        </p:nvSpPr>
+        <p:spPr>
+          <a:xfrm>
+            <a:off x="8183880" y="1645920"/>
+            <a:ext cx="3337560" cy="1051560"/>
+          </a:xfrm>
+          <a:prstGeom prst="roundRect">
+            <a:avLst>
+              <a:gd name="adj" fmla="val 6957"/>
+            </a:avLst>
+          </a:prstGeom>
+          <a:solidFill>
+            <a:srgbClr val="FFFFFF"/>
+          </a:solidFill>
+          <a:ln w="12700">
+            <a:solidFill>
+              <a:srgbClr val="D8D1C3"/>
+            </a:solidFill>
+            <a:prstDash val="solid"/>
+          </a:ln>
+        </p:spPr>
+      </p:sp>
+      <p:sp>
+        <p:nvSpPr>
+          <p:cNvPr id="13" name="Text 11"/>
+          <p:cNvSpPr/>
+          <p:nvPr/>
+        </p:nvSpPr>
+        <p:spPr>
+          <a:xfrm>
+            <a:off x="8385048" y="1810512"/>
+            <a:ext cx="1005840" cy="347472"/>
+          </a:xfrm>
+          <a:prstGeom prst="rect">
+            <a:avLst/>
+          </a:prstGeom>
+          <a:noFill/>
+          <a:ln/>
+        </p:spPr>
+        <p:txBody>
+          <a:bodyPr wrap="square" lIns="0" tIns="0" rIns="0" bIns="0" rtlCol="0" anchor="ctr">
+            <a:normAutofit/>
+          </a:bodyPr>
+          <a:lstStyle/>
+          <a:p>
+            <a:pPr indent="0" marL="0">
+              <a:buNone/>
+            </a:pPr>
+            <a:r>
+              <a:rPr lang="en-US" sz="2400" b="1" dirty="0">
+                <a:solidFill>
+                  <a:srgbClr val="4F7B58"/>
+                </a:solidFill>
+              </a:rPr>
+              <a:t>3</a:t>
+            </a:r>
+            <a:endParaRPr lang="en-US" sz="2400" dirty="0"/>
+          </a:p>
+        </p:txBody>
+      </p:sp>
+      <p:sp>
+        <p:nvSpPr>
+          <p:cNvPr id="14" name="Text 12"/>
+          <p:cNvSpPr/>
+          <p:nvPr/>
+        </p:nvSpPr>
+        <p:spPr>
+          <a:xfrm>
+            <a:off x="9390888" y="1810512"/>
+            <a:ext cx="1828800" cy="182880"/>
+          </a:xfrm>
+          <a:prstGeom prst="rect">
+            <a:avLst/>
+          </a:prstGeom>
+          <a:noFill/>
+          <a:ln/>
+        </p:spPr>
+        <p:txBody>
+          <a:bodyPr wrap="square" lIns="0" tIns="0" rIns="0" bIns="0" rtlCol="0" anchor="ctr">
+            <a:normAutofit/>
+          </a:bodyPr>
+          <a:lstStyle/>
+          <a:p>
+            <a:pPr indent="0" marL="0">
+              <a:buNone/>
+            </a:pPr>
+            <a:r>
+              <a:rPr lang="en-US" sz="900" b="1" dirty="0">
+                <a:solidFill>
+                  <a:srgbClr val="66716A"/>
+                </a:solidFill>
+              </a:rPr>
+              <a:t>Engineering</a:t>
+            </a:r>
+            <a:endParaRPr lang="en-US" sz="900" dirty="0"/>
+          </a:p>
+        </p:txBody>
+      </p:sp>
+      <p:sp>
+        <p:nvSpPr>
+          <p:cNvPr id="15" name="Text 13"/>
+          <p:cNvSpPr/>
+          <p:nvPr/>
+        </p:nvSpPr>
+        <p:spPr>
+          <a:xfrm>
+            <a:off x="9390888" y="2084832"/>
+            <a:ext cx="1828800" cy="411480"/>
+          </a:xfrm>
+          <a:prstGeom prst="rect">
+            <a:avLst/>
+          </a:prstGeom>
+          <a:noFill/>
+          <a:ln/>
+        </p:spPr>
+        <p:txBody>
+          <a:bodyPr wrap="square" lIns="254" tIns="254" rIns="254" bIns="254" rtlCol="0" anchor="ctr">
+            <a:normAutofit/>
+          </a:bodyPr>
+          <a:lstStyle/>
+          <a:p>
+            <a:pPr indent="0" marL="0">
+              <a:buNone/>
+            </a:pPr>
+            <a:r>
+              <a:rPr lang="en-US" sz="1100" dirty="0">
+                <a:solidFill>
+                  <a:srgbClr val="172322"/>
+                </a:solidFill>
+              </a:rPr>
+              <a:t>Incident learning loop: connect support pain to post-incident and sprint-planning follow-through.</a:t>
+            </a:r>
+            <a:endParaRPr lang="en-US" sz="1100" dirty="0"/>
+          </a:p>
+        </p:txBody>
+      </p:sp>
+      <p:sp>
+        <p:nvSpPr>
+          <p:cNvPr id="16" name="Text 14"/>
+          <p:cNvSpPr/>
+          <p:nvPr/>
+        </p:nvSpPr>
+        <p:spPr>
+          <a:xfrm>
+            <a:off x="914400" y="3840480"/>
+            <a:ext cx="9875520" cy="822960"/>
+          </a:xfrm>
+          <a:prstGeom prst="rect">
+            <a:avLst/>
+          </a:prstGeom>
+          <a:noFill/>
+          <a:ln/>
+        </p:spPr>
+        <p:txBody>
+          <a:bodyPr wrap="square" lIns="0" tIns="0" rIns="0" bIns="0" rtlCol="0" anchor="ctr">
+            <a:normAutofit/>
+          </a:bodyPr>
+          <a:lstStyle/>
+          <a:p>
+            <a:pPr algn="ctr" indent="0" marL="0">
+              <a:buNone/>
+            </a:pPr>
+            <a:r>
+              <a:rPr lang="en-US" sz="2200" b="1" dirty="0">
+                <a:solidFill>
+                  <a:srgbClr val="172322"/>
+                </a:solidFill>
+              </a:rPr>
+              <a:t>These are stakeholder workflows, not charts. The product should help each leader decide what to do next and where to look for evidence.</a:t>
+            </a:r>
+            <a:endParaRPr lang="en-US" sz="2200" dirty="0"/>
+          </a:p>
+        </p:txBody>
+      </p:sp>
+      <p:sp>
+        <p:nvSpPr>
+          <p:cNvPr id="17" name="Text 15"/>
+          <p:cNvSpPr/>
+          <p:nvPr/>
+        </p:nvSpPr>
+        <p:spPr>
+          <a:xfrm>
+            <a:off x="502920" y="6473952"/>
+            <a:ext cx="8686800" cy="164592"/>
+          </a:xfrm>
+          <a:prstGeom prst="rect">
+            <a:avLst/>
+          </a:prstGeom>
+          <a:noFill/>
+          <a:ln/>
+        </p:spPr>
+        <p:txBody>
+          <a:bodyPr wrap="square" lIns="0" tIns="0" rIns="0" bIns="0" rtlCol="0" anchor="ctr"/>
+          <a:lstStyle/>
+          <a:p>
+            <a:pPr indent="0" marL="0">
+              <a:buNone/>
+            </a:pPr>
+            <a:r>
+              <a:rPr lang="en-US" sz="700" dirty="0">
+                <a:solidFill>
+                  <a:srgbClr val="66716A"/>
+                </a:solidFill>
+              </a:rPr>
+              <a:t>Source: 100 provided transcript folders; generated by src/analyze_transcripts.py</a:t>
+            </a:r>
+            <a:endParaRPr lang="en-US" sz="700" dirty="0"/>
+          </a:p>
+        </p:txBody>
+      </p:sp>
+    </p:spTree>
+  </p:cSld>
+  <p:clrMapOvr>
+    <a:masterClrMapping/>
+  </p:clrMapOvr>
+</p:sld>
+</file>
+
+<file path=ppt/slides/slide12.xml><?xml version="1.0" encoding="utf-8"?>
+<p:sld xmlns:a="http://schemas.openxmlformats.org/drawingml/2006/main" xmlns:r="http://schemas.openxmlformats.org/officeDocument/2006/relationships" xmlns:p="http://schemas.openxmlformats.org/presentationml/2006/main">
+  <p:cSld name="Slide 12">
+    <p:bg>
+      <p:bgPr>
+        <a:solidFill>
+          <a:srgbClr val="F7F4ED"/>
+        </a:solidFill>
+      </p:bgPr>
+    </p:bg>
+    <p:spTree>
+      <p:nvGrpSpPr>
+        <p:cNvPr id="1" name=""/>
+        <p:cNvGrpSpPr/>
+        <p:nvPr/>
+      </p:nvGrpSpPr>
+      <p:grpSpPr>
+        <a:xfrm>
+          <a:off x="0" y="0"/>
+          <a:ext cx="0" cy="0"/>
+          <a:chOff x="0" y="0"/>
+          <a:chExt cx="0" cy="0"/>
+        </a:xfrm>
+      </p:grpSpPr>
+      <p:sp>
+        <p:nvSpPr>
+          <p:cNvPr id="2" name="Text 0"/>
+          <p:cNvSpPr/>
+          <p:nvPr/>
+        </p:nvSpPr>
+        <p:spPr>
+          <a:xfrm>
+            <a:off x="502920" y="292608"/>
+            <a:ext cx="4114800" cy="256032"/>
+          </a:xfrm>
+          <a:prstGeom prst="rect">
+            <a:avLst/>
+          </a:prstGeom>
+          <a:noFill/>
+          <a:ln/>
+        </p:spPr>
+        <p:txBody>
+          <a:bodyPr wrap="square" rtlCol="0" anchor="ctr"/>
+          <a:lstStyle/>
+          <a:p>
+            <a:pPr indent="0" marL="0">
+              <a:buNone/>
+            </a:pPr>
+            <a:r>
+              <a:rPr lang="en-US" sz="900" b="1" dirty="0">
+                <a:solidFill>
+                  <a:srgbClr val="2F6F73"/>
+                </a:solidFill>
+                <a:latin typeface="Aptos" pitchFamily="34" charset="0"/>
+                <a:ea typeface="Aptos" pitchFamily="34" charset="-122"/>
+                <a:cs typeface="Aptos" pitchFamily="34" charset="-120"/>
+              </a:rPr>
+              <a:t>TRANSCRIPT INTELLIGENCE</a:t>
+            </a:r>
+            <a:endParaRPr lang="en-US" sz="900" dirty="0"/>
+          </a:p>
+        </p:txBody>
+      </p:sp>
+      <p:sp>
+        <p:nvSpPr>
+          <p:cNvPr id="3" name="Text 1"/>
+          <p:cNvSpPr/>
+          <p:nvPr/>
+        </p:nvSpPr>
+        <p:spPr>
+          <a:xfrm>
+            <a:off x="502920" y="640080"/>
+            <a:ext cx="10789920" cy="685800"/>
+          </a:xfrm>
+          <a:prstGeom prst="rect">
+            <a:avLst/>
+          </a:prstGeom>
+          <a:noFill/>
+          <a:ln/>
+        </p:spPr>
+        <p:txBody>
+          <a:bodyPr wrap="square" lIns="0" tIns="0" rIns="0" bIns="0" rtlCol="0" anchor="ctr">
+            <a:normAutofit/>
+          </a:bodyPr>
+          <a:lstStyle/>
+          <a:p>
+            <a:pPr indent="0" marL="0">
+              <a:buNone/>
+            </a:pPr>
+            <a:r>
+              <a:rPr lang="en-US" sz="2800" b="1" dirty="0">
+                <a:solidFill>
+                  <a:srgbClr val="172322"/>
+                </a:solidFill>
+                <a:latin typeface="Aptos Display" pitchFamily="34" charset="0"/>
+                <a:ea typeface="Aptos Display" pitchFamily="34" charset="-122"/>
+                <a:cs typeface="Aptos Display" pitchFamily="34" charset="-120"/>
+              </a:rPr>
               <a:t>Recommended next build</a:t>
             </a:r>
             <a:endParaRPr lang="en-US" sz="2800" dirty="0"/>
@@ -4723,7 +5457,7 @@
                   <a:srgbClr val="172322"/>
                 </a:solidFill>
               </a:rPr>
-              <a:t>28</a:t>
+              <a:t>24</a:t>
             </a:r>
             <a:endParaRPr lang="en-US" sz="850" dirty="0"/>
           </a:p>
@@ -4776,7 +5510,7 @@
         <p:spPr>
           <a:xfrm>
             <a:off x="3035808" y="2159290"/>
-            <a:ext cx="3197134" cy="256032"/>
+            <a:ext cx="3729990" cy="256032"/>
           </a:xfrm>
           <a:prstGeom prst="roundRect">
             <a:avLst>
@@ -4804,7 +5538,7 @@
         </p:nvSpPr>
         <p:spPr>
           <a:xfrm>
-            <a:off x="6342670" y="2195866"/>
+            <a:off x="6875526" y="2195866"/>
             <a:ext cx="594360" cy="164592"/>
           </a:xfrm>
           <a:prstGeom prst="rect">
@@ -4881,7 +5615,7 @@
         <p:spPr>
           <a:xfrm>
             <a:off x="3035808" y="2773245"/>
-            <a:ext cx="2470513" cy="256032"/>
+            <a:ext cx="2882265" cy="256032"/>
           </a:xfrm>
           <a:prstGeom prst="roundRect">
             <a:avLst>
@@ -4909,7 +5643,7 @@
         </p:nvSpPr>
         <p:spPr>
           <a:xfrm>
-            <a:off x="5616049" y="2809821"/>
+            <a:off x="6027801" y="2809821"/>
             <a:ext cx="594360" cy="164592"/>
           </a:xfrm>
           <a:prstGeom prst="rect">
@@ -4971,7 +5705,7 @@
                   <a:srgbClr val="172322"/>
                 </a:solidFill>
               </a:rPr>
-              <a:t>Product Feedback &amp; Roadmap</a:t>
+              <a:t>Identity &amp; Access</a:t>
             </a:r>
             <a:endParaRPr lang="en-US" sz="950" dirty="0"/>
           </a:p>
@@ -4986,7 +5720,7 @@
         <p:spPr>
           <a:xfrm>
             <a:off x="3035808" y="3387199"/>
-            <a:ext cx="1598567" cy="256032"/>
+            <a:ext cx="2034540" cy="256032"/>
           </a:xfrm>
           <a:prstGeom prst="roundRect">
             <a:avLst>
@@ -5014,7 +5748,7 @@
         </p:nvSpPr>
         <p:spPr>
           <a:xfrm>
-            <a:off x="4744103" y="3423775"/>
+            <a:off x="5180076" y="3423775"/>
             <a:ext cx="594360" cy="164592"/>
           </a:xfrm>
           <a:prstGeom prst="rect">
@@ -5038,7 +5772,7 @@
                   <a:srgbClr val="172322"/>
                 </a:solidFill>
               </a:rPr>
-              <a:t>11</a:t>
+              <a:t>12</a:t>
             </a:r>
             <a:endParaRPr lang="en-US" sz="850" dirty="0"/>
           </a:p>
@@ -5076,7 +5810,7 @@
                   <a:srgbClr val="172322"/>
                 </a:solidFill>
               </a:rPr>
-              <a:t>Backup &amp; Recovery</a:t>
+              <a:t>Product Feedback &amp; Roadmap</a:t>
             </a:r>
             <a:endParaRPr lang="en-US" sz="950" dirty="0"/>
           </a:p>
@@ -5091,7 +5825,7 @@
         <p:spPr>
           <a:xfrm>
             <a:off x="3035808" y="4001153"/>
-            <a:ext cx="1162594" cy="256032"/>
+            <a:ext cx="1864995" cy="256032"/>
           </a:xfrm>
           <a:prstGeom prst="roundRect">
             <a:avLst>
@@ -5119,7 +5853,7 @@
         </p:nvSpPr>
         <p:spPr>
           <a:xfrm>
-            <a:off x="4308130" y="4037729"/>
+            <a:off x="5010531" y="4037729"/>
             <a:ext cx="594360" cy="164592"/>
           </a:xfrm>
           <a:prstGeom prst="rect">
@@ -5143,7 +5877,7 @@
                   <a:srgbClr val="172322"/>
                 </a:solidFill>
               </a:rPr>
-              <a:t>8</a:t>
+              <a:t>11</a:t>
             </a:r>
             <a:endParaRPr lang="en-US" sz="850" dirty="0"/>
           </a:p>
@@ -5181,7 +5915,7 @@
                   <a:srgbClr val="172322"/>
                 </a:solidFill>
               </a:rPr>
-              <a:t>Identity &amp; Access</a:t>
+              <a:t>Backup &amp; Recovery</a:t>
             </a:r>
             <a:endParaRPr lang="en-US" sz="950" dirty="0"/>
           </a:p>
@@ -5196,7 +5930,7 @@
         <p:spPr>
           <a:xfrm>
             <a:off x="3035808" y="4615107"/>
-            <a:ext cx="1162594" cy="256032"/>
+            <a:ext cx="1356360" cy="256032"/>
           </a:xfrm>
           <a:prstGeom prst="roundRect">
             <a:avLst>
@@ -5224,7 +5958,7 @@
         </p:nvSpPr>
         <p:spPr>
           <a:xfrm>
-            <a:off x="4308130" y="4651683"/>
+            <a:off x="4501896" y="4651683"/>
             <a:ext cx="594360" cy="164592"/>
           </a:xfrm>
           <a:prstGeom prst="rect">
@@ -5301,7 +6035,7 @@
         <p:spPr>
           <a:xfrm>
             <a:off x="3035808" y="5229062"/>
-            <a:ext cx="871946" cy="256032"/>
+            <a:ext cx="1017270" cy="256032"/>
           </a:xfrm>
           <a:prstGeom prst="roundRect">
             <a:avLst>
@@ -5329,7 +6063,7 @@
         </p:nvSpPr>
         <p:spPr>
           <a:xfrm>
-            <a:off x="4017482" y="5265638"/>
+            <a:off x="4162806" y="5265638"/>
             <a:ext cx="594360" cy="164592"/>
           </a:xfrm>
           <a:prstGeom prst="rect">
@@ -6480,7 +7214,7 @@
         <p:spPr>
           <a:xfrm>
             <a:off x="3154680" y="1636776"/>
-            <a:ext cx="3227995" cy="256032"/>
+            <a:ext cx="3241630" cy="256032"/>
           </a:xfrm>
           <a:prstGeom prst="roundRect">
             <a:avLst>
@@ -6508,7 +7242,7 @@
         </p:nvSpPr>
         <p:spPr>
           <a:xfrm>
-            <a:off x="6492403" y="1673352"/>
+            <a:off x="6506038" y="1673352"/>
             <a:ext cx="594360" cy="164592"/>
           </a:xfrm>
           <a:prstGeom prst="rect">
@@ -6637,7 +7371,7 @@
                   <a:srgbClr val="172322"/>
                 </a:solidFill>
               </a:rPr>
-              <a:t>9.51</a:t>
+              <a:t>9.47</a:t>
             </a:r>
             <a:endParaRPr lang="en-US" sz="850" dirty="0"/>
           </a:p>
@@ -6675,7 +7409,7 @@
                   <a:srgbClr val="172322"/>
                 </a:solidFill>
               </a:rPr>
-              <a:t>Protect</a:t>
+              <a:t>Identity</a:t>
             </a:r>
             <a:endParaRPr lang="en-US" sz="950" dirty="0"/>
           </a:p>
@@ -6690,7 +7424,7 @@
         <p:spPr>
           <a:xfrm>
             <a:off x="3154680" y="3054096"/>
-            <a:ext cx="3387174" cy="256032"/>
+            <a:ext cx="3397764" cy="256032"/>
           </a:xfrm>
           <a:prstGeom prst="roundRect">
             <a:avLst>
@@ -6718,7 +7452,7 @@
         </p:nvSpPr>
         <p:spPr>
           <a:xfrm>
-            <a:off x="6651582" y="3090672"/>
+            <a:off x="6662172" y="3090672"/>
             <a:ext cx="594360" cy="164592"/>
           </a:xfrm>
           <a:prstGeom prst="rect">
@@ -6742,7 +7476,7 @@
                   <a:srgbClr val="172322"/>
                 </a:solidFill>
               </a:rPr>
-              <a:t>9.15</a:t>
+              <a:t>9.14</a:t>
             </a:r>
             <a:endParaRPr lang="en-US" sz="850" dirty="0"/>
           </a:p>
@@ -6780,7 +7514,7 @@
                   <a:srgbClr val="172322"/>
                 </a:solidFill>
               </a:rPr>
-              <a:t>Identity</a:t>
+              <a:t>Protect</a:t>
             </a:r>
             <a:endParaRPr lang="en-US" sz="950" dirty="0"/>
           </a:p>
@@ -6795,7 +7529,7 @@
         <p:spPr>
           <a:xfrm>
             <a:off x="3154680" y="3762756"/>
-            <a:ext cx="3361261" cy="256032"/>
+            <a:ext cx="3390329" cy="256032"/>
           </a:xfrm>
           <a:prstGeom prst="roundRect">
             <a:avLst>
@@ -6823,7 +7557,7 @@
         </p:nvSpPr>
         <p:spPr>
           <a:xfrm>
-            <a:off x="6625669" y="3799332"/>
+            <a:off x="6654737" y="3799332"/>
             <a:ext cx="594360" cy="164592"/>
           </a:xfrm>
           <a:prstGeom prst="rect">
@@ -6847,7 +7581,7 @@
                   <a:srgbClr val="172322"/>
                 </a:solidFill>
               </a:rPr>
-              <a:t>9.08</a:t>
+              <a:t>9.12</a:t>
             </a:r>
             <a:endParaRPr lang="en-US" sz="850" dirty="0"/>
           </a:p>
@@ -9586,7 +10320,7 @@
                   <a:srgbClr val="4F7B58"/>
                 </a:solidFill>
               </a:rPr>
-              <a:t>62%</a:t>
+              <a:t>61%</a:t>
             </a:r>
             <a:endParaRPr lang="en-US" sz="2400" dirty="0"/>
           </a:p>

</xml_diff>

<commit_message>
Add optional embeddings API app and tests
</commit_message>
<xml_diff>
--- a/interview-assignment/deliverables/Transcript_Intelligence_Leadership_Deck.pptx
+++ b/interview-assignment/deliverables/Transcript_Intelligence_Leadership_Deck.pptx
@@ -17,9 +17,10 @@
     <p:sldId id="265" r:id="rId11"/>
     <p:sldId id="266" r:id="rId12"/>
     <p:sldId id="267" r:id="rId13"/>
+    <p:sldId id="268" r:id="rId14"/>
   </p:sldIdLst>
   <p:notesMasterIdLst>
-    <p:notesMasterId r:id="rId14"/>
+    <p:notesMasterId r:id="rId15"/>
   </p:notesMasterIdLst>
   <p:sldSz cx="12191695" cy="6858000"/>
   <p:notesSz cx="6858000" cy="12191695"/>
@@ -801,6 +802,94 @@
             <a:fld id="{F7021451-1387-4CA6-816F-3879F97B5CBC}" type="slidenum">
               <a:rPr lang="en-US"/>
               <a:t>12</a:t>
+            </a:fld>
+            <a:endParaRPr lang="en-US"/>
+          </a:p>
+        </p:txBody>
+      </p:sp>
+    </p:spTree>
+    <p:extLst>
+      <p:ext uri="{BB962C8B-B14F-4D97-AF65-F5344CB8AC3E}">
+        <p14:creationId xmlns:p14="http://schemas.microsoft.com/office/powerpoint/2010/main" val="1024086991"/>
+      </p:ext>
+    </p:extLst>
+  </p:cSld>
+  <p:clrMapOvr>
+    <a:masterClrMapping/>
+  </p:clrMapOvr>
+</p:notes>
+</file>
+
+<file path=ppt/notesSlides/notesSlide13.xml><?xml version="1.0" encoding="utf-8"?>
+<p:notes xmlns:a="http://schemas.openxmlformats.org/drawingml/2006/main" xmlns:r="http://schemas.openxmlformats.org/officeDocument/2006/relationships" xmlns:p="http://schemas.openxmlformats.org/presentationml/2006/main">
+  <p:cSld>
+    <p:spTree>
+      <p:nvGrpSpPr>
+        <p:cNvPr id="1" name=""/>
+        <p:cNvGrpSpPr/>
+        <p:nvPr/>
+      </p:nvGrpSpPr>
+      <p:grpSpPr>
+        <a:xfrm>
+          <a:off x="0" y="0"/>
+          <a:ext cx="0" cy="0"/>
+          <a:chOff x="0" y="0"/>
+          <a:chExt cx="0" cy="0"/>
+        </a:xfrm>
+      </p:grpSpPr>
+      <p:sp>
+        <p:nvSpPr>
+          <p:cNvPr id="2" name="Slide Image Placeholder 1"/>
+          <p:cNvSpPr>
+            <a:spLocks noGrp="1" noRot="1" noChangeAspect="1"/>
+          </p:cNvSpPr>
+          <p:nvPr>
+            <p:ph type="sldImg"/>
+          </p:nvPr>
+        </p:nvSpPr>
+        <p:spPr/>
+      </p:sp>
+      <p:sp>
+        <p:nvSpPr>
+          <p:cNvPr id="3" name="Notes Placeholder 2"/>
+          <p:cNvSpPr>
+            <a:spLocks noGrp="1"/>
+          </p:cNvSpPr>
+          <p:nvPr>
+            <p:ph type="body" idx="1"/>
+          </p:nvPr>
+        </p:nvSpPr>
+        <p:spPr/>
+        <p:txBody>
+          <a:bodyPr/>
+          <a:lstStyle/>
+          <a:p>
+            <a:r>
+              <a:rPr lang="en-US" dirty="0"/>
+              <a:t/>
+            </a:r>
+            <a:endParaRPr lang="en-US" dirty="0"/>
+          </a:p>
+        </p:txBody>
+      </p:sp>
+      <p:sp>
+        <p:nvSpPr>
+          <p:cNvPr id="4" name="Slide Number Placeholder 3"/>
+          <p:cNvSpPr>
+            <a:spLocks noGrp="1"/>
+          </p:cNvSpPr>
+          <p:nvPr>
+            <p:ph type="sldNum" sz="quarter" idx="10"/>
+          </p:nvPr>
+        </p:nvSpPr>
+        <p:spPr/>
+        <p:txBody>
+          <a:bodyPr/>
+          <a:lstStyle/>
+          <a:p>
+            <a:fld id="{F7021451-1387-4CA6-816F-3879F97B5CBC}" type="slidenum">
+              <a:rPr lang="en-US"/>
+              <a:t>13</a:t>
             </a:fld>
             <a:endParaRPr lang="en-US"/>
           </a:p>
@@ -3306,7 +3395,7 @@
                 <a:ea typeface="Aptos Display" pitchFamily="34" charset="-122"/>
                 <a:cs typeface="Aptos Display" pitchFamily="34" charset="-120"/>
               </a:rPr>
-              <a:t>Three insight products would make this valuable beyond analysis</a:t>
+              <a:t>Production extensions: real embeddings, API service, and tests</a:t>
             </a:r>
             <a:endParaRPr lang="en-US" sz="2800" dirty="0"/>
           </a:p>
@@ -3320,7 +3409,7 @@
         </p:nvSpPr>
         <p:spPr>
           <a:xfrm>
-            <a:off x="685800" y="1645920"/>
+            <a:off x="685800" y="1508760"/>
             <a:ext cx="3337560" cy="1051560"/>
           </a:xfrm>
           <a:prstGeom prst="roundRect">
@@ -3347,7 +3436,7 @@
         </p:nvSpPr>
         <p:spPr>
           <a:xfrm>
-            <a:off x="886968" y="1810512"/>
+            <a:off x="886968" y="1673352"/>
             <a:ext cx="1005840" cy="347472"/>
           </a:xfrm>
           <a:prstGeom prst="rect">
@@ -3371,7 +3460,7 @@
                   <a:srgbClr val="2F6F73"/>
                 </a:solidFill>
               </a:rPr>
-              <a:t>1</a:t>
+              <a:t>OpenAI</a:t>
             </a:r>
             <a:endParaRPr lang="en-US" sz="2400" dirty="0"/>
           </a:p>
@@ -3385,7 +3474,7 @@
         </p:nvSpPr>
         <p:spPr>
           <a:xfrm>
-            <a:off x="1892808" y="1810512"/>
+            <a:off x="1892808" y="1673352"/>
             <a:ext cx="1828800" cy="182880"/>
           </a:xfrm>
           <a:prstGeom prst="rect">
@@ -3409,7 +3498,7 @@
                   <a:srgbClr val="66716A"/>
                 </a:solidFill>
               </a:rPr>
-              <a:t>Sales / CS</a:t>
+              <a:t>Embeddings</a:t>
             </a:r>
             <a:endParaRPr lang="en-US" sz="900" dirty="0"/>
           </a:p>
@@ -3423,7 +3512,7 @@
         </p:nvSpPr>
         <p:spPr>
           <a:xfrm>
-            <a:off x="1892808" y="2084832"/>
+            <a:off x="1892808" y="1947672"/>
             <a:ext cx="1828800" cy="411480"/>
           </a:xfrm>
           <a:prstGeom prst="rect">
@@ -3447,7 +3536,7 @@
                   <a:srgbClr val="172322"/>
                 </a:solidFill>
               </a:rPr>
-              <a:t>Revenue risk heatmap: renewal language + competitor mentions + negative sentiment.</a:t>
+              <a:t>Optional real retrieval via text-embedding-3-small when OPENAI_API_KEY is set.</a:t>
             </a:r>
             <a:endParaRPr lang="en-US" sz="1100" dirty="0"/>
           </a:p>
@@ -3461,7 +3550,7 @@
         </p:nvSpPr>
         <p:spPr>
           <a:xfrm>
-            <a:off x="4434840" y="1645920"/>
+            <a:off x="4434840" y="1508760"/>
             <a:ext cx="3337560" cy="1051560"/>
           </a:xfrm>
           <a:prstGeom prst="roundRect">
@@ -3488,7 +3577,7 @@
         </p:nvSpPr>
         <p:spPr>
           <a:xfrm>
-            <a:off x="4636008" y="1810512"/>
+            <a:off x="4636008" y="1673352"/>
             <a:ext cx="1005840" cy="347472"/>
           </a:xfrm>
           <a:prstGeom prst="rect">
@@ -3509,10 +3598,10 @@
             <a:r>
               <a:rPr lang="en-US" sz="2400" b="1" dirty="0">
                 <a:solidFill>
-                  <a:srgbClr val="C48A2C"/>
-                </a:solidFill>
-              </a:rPr>
-              <a:t>2</a:t>
+                  <a:srgbClr val="4F7B58"/>
+                </a:solidFill>
+              </a:rPr>
+              <a:t>FastAPI</a:t>
             </a:r>
             <a:endParaRPr lang="en-US" sz="2400" dirty="0"/>
           </a:p>
@@ -3526,7 +3615,7 @@
         </p:nvSpPr>
         <p:spPr>
           <a:xfrm>
-            <a:off x="5641848" y="1810512"/>
+            <a:off x="5641848" y="1673352"/>
             <a:ext cx="1828800" cy="182880"/>
           </a:xfrm>
           <a:prstGeom prst="rect">
@@ -3550,7 +3639,7 @@
                   <a:srgbClr val="66716A"/>
                 </a:solidFill>
               </a:rPr>
-              <a:t>Product</a:t>
+              <a:t>API</a:t>
             </a:r>
             <a:endParaRPr lang="en-US" sz="900" dirty="0"/>
           </a:p>
@@ -3564,7 +3653,7 @@
         </p:nvSpPr>
         <p:spPr>
           <a:xfrm>
-            <a:off x="5641848" y="2084832"/>
+            <a:off x="5641848" y="1947672"/>
             <a:ext cx="1828800" cy="411480"/>
           </a:xfrm>
           <a:prstGeom prst="rect">
@@ -3588,7 +3677,7 @@
                   <a:srgbClr val="172322"/>
                 </a:solidFill>
               </a:rPr>
-              <a:t>Product gap backlog: repeated pain points with quotes, accounts, and urgency.</a:t>
+              <a:t>Review endpoints for summary, meetings, retrieval examples, and human-review queue.</a:t>
             </a:r>
             <a:endParaRPr lang="en-US" sz="1100" dirty="0"/>
           </a:p>
@@ -3602,7 +3691,7 @@
         </p:nvSpPr>
         <p:spPr>
           <a:xfrm>
-            <a:off x="8183880" y="1645920"/>
+            <a:off x="8183880" y="1508760"/>
             <a:ext cx="3337560" cy="1051560"/>
           </a:xfrm>
           <a:prstGeom prst="roundRect">
@@ -3629,7 +3718,7 @@
         </p:nvSpPr>
         <p:spPr>
           <a:xfrm>
-            <a:off x="8385048" y="1810512"/>
+            <a:off x="8385048" y="1673352"/>
             <a:ext cx="1005840" cy="347472"/>
           </a:xfrm>
           <a:prstGeom prst="rect">
@@ -3650,10 +3739,10 @@
             <a:r>
               <a:rPr lang="en-US" sz="2400" b="1" dirty="0">
                 <a:solidFill>
-                  <a:srgbClr val="4F7B58"/>
-                </a:solidFill>
-              </a:rPr>
-              <a:t>3</a:t>
+                  <a:srgbClr val="C48A2C"/>
+                </a:solidFill>
+              </a:rPr>
+              <a:t>6</a:t>
             </a:r>
             <a:endParaRPr lang="en-US" sz="2400" dirty="0"/>
           </a:p>
@@ -3667,7 +3756,7 @@
         </p:nvSpPr>
         <p:spPr>
           <a:xfrm>
-            <a:off x="9390888" y="1810512"/>
+            <a:off x="9390888" y="1673352"/>
             <a:ext cx="1828800" cy="182880"/>
           </a:xfrm>
           <a:prstGeom prst="rect">
@@ -3691,7 +3780,7 @@
                   <a:srgbClr val="66716A"/>
                 </a:solidFill>
               </a:rPr>
-              <a:t>Engineering</a:t>
+              <a:t>Tests</a:t>
             </a:r>
             <a:endParaRPr lang="en-US" sz="900" dirty="0"/>
           </a:p>
@@ -3705,7 +3794,7 @@
         </p:nvSpPr>
         <p:spPr>
           <a:xfrm>
-            <a:off x="9390888" y="2084832"/>
+            <a:off x="9390888" y="1947672"/>
             <a:ext cx="1828800" cy="411480"/>
           </a:xfrm>
           <a:prstGeom prst="rect">
@@ -3729,7 +3818,7 @@
                   <a:srgbClr val="172322"/>
                 </a:solidFill>
               </a:rPr>
-              <a:t>Incident learning loop: connect support pain to post-incident and sprint-planning follow-through.</a:t>
+              <a:t>Unit coverage for classifier, routing, gold eval, and vector similarity behavior.</a:t>
             </a:r>
             <a:endParaRPr lang="en-US" sz="1100" dirty="0"/>
           </a:p>
@@ -3743,39 +3832,75 @@
         </p:nvSpPr>
         <p:spPr>
           <a:xfrm>
-            <a:off x="914400" y="3840480"/>
-            <a:ext cx="9875520" cy="822960"/>
-          </a:xfrm>
-          <a:prstGeom prst="rect">
-            <a:avLst/>
-          </a:prstGeom>
-          <a:noFill/>
-          <a:ln/>
-        </p:spPr>
-        <p:txBody>
-          <a:bodyPr wrap="square" lIns="0" tIns="0" rIns="0" bIns="0" rtlCol="0" anchor="ctr">
-            <a:normAutofit/>
-          </a:bodyPr>
-          <a:lstStyle/>
-          <a:p>
-            <a:pPr algn="ctr" indent="0" marL="0">
-              <a:buNone/>
-            </a:pPr>
-            <a:r>
-              <a:rPr lang="en-US" sz="2200" b="1" dirty="0">
-                <a:solidFill>
-                  <a:srgbClr val="172322"/>
-                </a:solidFill>
-              </a:rPr>
-              <a:t>These are stakeholder workflows, not charts. The product should help each leader decide what to do next and where to look for evidence.</a:t>
-            </a:r>
-            <a:endParaRPr lang="en-US" sz="2200" dirty="0"/>
+            <a:off x="914400" y="3246120"/>
+            <a:ext cx="9966960" cy="256032"/>
+          </a:xfrm>
+          <a:prstGeom prst="rect">
+            <a:avLst/>
+          </a:prstGeom>
+          <a:noFill/>
+          <a:ln/>
+        </p:spPr>
+        <p:txBody>
+          <a:bodyPr wrap="square" lIns="0" tIns="0" rIns="0" bIns="0" rtlCol="0" anchor="ctr"/>
+          <a:lstStyle/>
+          <a:p>
+            <a:pPr indent="0" marL="0">
+              <a:buNone/>
+            </a:pPr>
+            <a:r>
+              <a:rPr lang="en-US" sz="1500" b="1" dirty="0">
+                <a:solidFill>
+                  <a:srgbClr val="2F6F73"/>
+                </a:solidFill>
+              </a:rPr>
+              <a:t>Why this matters</a:t>
+            </a:r>
+            <a:endParaRPr lang="en-US" sz="1500" dirty="0"/>
           </a:p>
         </p:txBody>
       </p:sp>
       <p:sp>
         <p:nvSpPr>
           <p:cNvPr id="17" name="Text 15"/>
+          <p:cNvSpPr/>
+          <p:nvPr/>
+        </p:nvSpPr>
+        <p:spPr>
+          <a:xfrm>
+            <a:off x="914400" y="3630168"/>
+            <a:ext cx="9966960" cy="1444752"/>
+          </a:xfrm>
+          <a:prstGeom prst="rect">
+            <a:avLst/>
+          </a:prstGeom>
+          <a:noFill/>
+          <a:ln/>
+        </p:spPr>
+        <p:txBody>
+          <a:bodyPr wrap="square" lIns="254" tIns="254" rIns="254" bIns="254" rtlCol="0" anchor="ctr">
+            <a:normAutofit/>
+          </a:bodyPr>
+          <a:lstStyle/>
+          <a:p>
+            <a:pPr indent="0" marL="0">
+              <a:buNone/>
+            </a:pPr>
+            <a:r>
+              <a:rPr lang="en-US" sz="1600" dirty="0">
+                <a:solidFill>
+                  <a:srgbClr val="172322"/>
+                </a:solidFill>
+              </a:rPr>
+              <a:t>The repo remains easy to run locally, but the architecture now has clear production interfaces: swap TF-IDF retrieval for embeddings, expose review workflows through an API, and protect behavior with tests and gold-label regression checks.</a:t>
+            </a:r>
+            <a:endParaRPr lang="en-US" sz="1600" dirty="0"/>
+          </a:p>
+        </p:txBody>
+      </p:sp>
+      <p:sp>
+        <p:nvSpPr>
+          <p:cNvPr id="18" name="Text 16"/>
           <p:cNvSpPr/>
           <p:nvPr/>
         </p:nvSpPr>
@@ -3820,6 +3945,615 @@
 <file path=ppt/slides/slide12.xml><?xml version="1.0" encoding="utf-8"?>
 <p:sld xmlns:a="http://schemas.openxmlformats.org/drawingml/2006/main" xmlns:r="http://schemas.openxmlformats.org/officeDocument/2006/relationships" xmlns:p="http://schemas.openxmlformats.org/presentationml/2006/main">
   <p:cSld name="Slide 12">
+    <p:bg>
+      <p:bgPr>
+        <a:solidFill>
+          <a:srgbClr val="F7F4ED"/>
+        </a:solidFill>
+      </p:bgPr>
+    </p:bg>
+    <p:spTree>
+      <p:nvGrpSpPr>
+        <p:cNvPr id="1" name=""/>
+        <p:cNvGrpSpPr/>
+        <p:nvPr/>
+      </p:nvGrpSpPr>
+      <p:grpSpPr>
+        <a:xfrm>
+          <a:off x="0" y="0"/>
+          <a:ext cx="0" cy="0"/>
+          <a:chOff x="0" y="0"/>
+          <a:chExt cx="0" cy="0"/>
+        </a:xfrm>
+      </p:grpSpPr>
+      <p:sp>
+        <p:nvSpPr>
+          <p:cNvPr id="2" name="Text 0"/>
+          <p:cNvSpPr/>
+          <p:nvPr/>
+        </p:nvSpPr>
+        <p:spPr>
+          <a:xfrm>
+            <a:off x="502920" y="292608"/>
+            <a:ext cx="4114800" cy="256032"/>
+          </a:xfrm>
+          <a:prstGeom prst="rect">
+            <a:avLst/>
+          </a:prstGeom>
+          <a:noFill/>
+          <a:ln/>
+        </p:spPr>
+        <p:txBody>
+          <a:bodyPr wrap="square" rtlCol="0" anchor="ctr"/>
+          <a:lstStyle/>
+          <a:p>
+            <a:pPr indent="0" marL="0">
+              <a:buNone/>
+            </a:pPr>
+            <a:r>
+              <a:rPr lang="en-US" sz="900" b="1" dirty="0">
+                <a:solidFill>
+                  <a:srgbClr val="2F6F73"/>
+                </a:solidFill>
+                <a:latin typeface="Aptos" pitchFamily="34" charset="0"/>
+                <a:ea typeface="Aptos" pitchFamily="34" charset="-122"/>
+                <a:cs typeface="Aptos" pitchFamily="34" charset="-120"/>
+              </a:rPr>
+              <a:t>TRANSCRIPT INTELLIGENCE</a:t>
+            </a:r>
+            <a:endParaRPr lang="en-US" sz="900" dirty="0"/>
+          </a:p>
+        </p:txBody>
+      </p:sp>
+      <p:sp>
+        <p:nvSpPr>
+          <p:cNvPr id="3" name="Text 1"/>
+          <p:cNvSpPr/>
+          <p:nvPr/>
+        </p:nvSpPr>
+        <p:spPr>
+          <a:xfrm>
+            <a:off x="502920" y="640080"/>
+            <a:ext cx="10789920" cy="685800"/>
+          </a:xfrm>
+          <a:prstGeom prst="rect">
+            <a:avLst/>
+          </a:prstGeom>
+          <a:noFill/>
+          <a:ln/>
+        </p:spPr>
+        <p:txBody>
+          <a:bodyPr wrap="square" lIns="0" tIns="0" rIns="0" bIns="0" rtlCol="0" anchor="ctr">
+            <a:normAutofit/>
+          </a:bodyPr>
+          <a:lstStyle/>
+          <a:p>
+            <a:pPr indent="0" marL="0">
+              <a:buNone/>
+            </a:pPr>
+            <a:r>
+              <a:rPr lang="en-US" sz="2800" b="1" dirty="0">
+                <a:solidFill>
+                  <a:srgbClr val="172322"/>
+                </a:solidFill>
+                <a:latin typeface="Aptos Display" pitchFamily="34" charset="0"/>
+                <a:ea typeface="Aptos Display" pitchFamily="34" charset="-122"/>
+                <a:cs typeface="Aptos Display" pitchFamily="34" charset="-120"/>
+              </a:rPr>
+              <a:t>Three insight products would make this valuable beyond analysis</a:t>
+            </a:r>
+            <a:endParaRPr lang="en-US" sz="2800" dirty="0"/>
+          </a:p>
+        </p:txBody>
+      </p:sp>
+      <p:sp>
+        <p:nvSpPr>
+          <p:cNvPr id="4" name="Shape 2"/>
+          <p:cNvSpPr/>
+          <p:nvPr/>
+        </p:nvSpPr>
+        <p:spPr>
+          <a:xfrm>
+            <a:off x="685800" y="1645920"/>
+            <a:ext cx="3337560" cy="1051560"/>
+          </a:xfrm>
+          <a:prstGeom prst="roundRect">
+            <a:avLst>
+              <a:gd name="adj" fmla="val 6957"/>
+            </a:avLst>
+          </a:prstGeom>
+          <a:solidFill>
+            <a:srgbClr val="FFFFFF"/>
+          </a:solidFill>
+          <a:ln w="12700">
+            <a:solidFill>
+              <a:srgbClr val="D8D1C3"/>
+            </a:solidFill>
+            <a:prstDash val="solid"/>
+          </a:ln>
+        </p:spPr>
+      </p:sp>
+      <p:sp>
+        <p:nvSpPr>
+          <p:cNvPr id="5" name="Text 3"/>
+          <p:cNvSpPr/>
+          <p:nvPr/>
+        </p:nvSpPr>
+        <p:spPr>
+          <a:xfrm>
+            <a:off x="886968" y="1810512"/>
+            <a:ext cx="1005840" cy="347472"/>
+          </a:xfrm>
+          <a:prstGeom prst="rect">
+            <a:avLst/>
+          </a:prstGeom>
+          <a:noFill/>
+          <a:ln/>
+        </p:spPr>
+        <p:txBody>
+          <a:bodyPr wrap="square" lIns="0" tIns="0" rIns="0" bIns="0" rtlCol="0" anchor="ctr">
+            <a:normAutofit/>
+          </a:bodyPr>
+          <a:lstStyle/>
+          <a:p>
+            <a:pPr indent="0" marL="0">
+              <a:buNone/>
+            </a:pPr>
+            <a:r>
+              <a:rPr lang="en-US" sz="2400" b="1" dirty="0">
+                <a:solidFill>
+                  <a:srgbClr val="2F6F73"/>
+                </a:solidFill>
+              </a:rPr>
+              <a:t>1</a:t>
+            </a:r>
+            <a:endParaRPr lang="en-US" sz="2400" dirty="0"/>
+          </a:p>
+        </p:txBody>
+      </p:sp>
+      <p:sp>
+        <p:nvSpPr>
+          <p:cNvPr id="6" name="Text 4"/>
+          <p:cNvSpPr/>
+          <p:nvPr/>
+        </p:nvSpPr>
+        <p:spPr>
+          <a:xfrm>
+            <a:off x="1892808" y="1810512"/>
+            <a:ext cx="1828800" cy="182880"/>
+          </a:xfrm>
+          <a:prstGeom prst="rect">
+            <a:avLst/>
+          </a:prstGeom>
+          <a:noFill/>
+          <a:ln/>
+        </p:spPr>
+        <p:txBody>
+          <a:bodyPr wrap="square" lIns="0" tIns="0" rIns="0" bIns="0" rtlCol="0" anchor="ctr">
+            <a:normAutofit/>
+          </a:bodyPr>
+          <a:lstStyle/>
+          <a:p>
+            <a:pPr indent="0" marL="0">
+              <a:buNone/>
+            </a:pPr>
+            <a:r>
+              <a:rPr lang="en-US" sz="900" b="1" dirty="0">
+                <a:solidFill>
+                  <a:srgbClr val="66716A"/>
+                </a:solidFill>
+              </a:rPr>
+              <a:t>Sales / CS</a:t>
+            </a:r>
+            <a:endParaRPr lang="en-US" sz="900" dirty="0"/>
+          </a:p>
+        </p:txBody>
+      </p:sp>
+      <p:sp>
+        <p:nvSpPr>
+          <p:cNvPr id="7" name="Text 5"/>
+          <p:cNvSpPr/>
+          <p:nvPr/>
+        </p:nvSpPr>
+        <p:spPr>
+          <a:xfrm>
+            <a:off x="1892808" y="2084832"/>
+            <a:ext cx="1828800" cy="411480"/>
+          </a:xfrm>
+          <a:prstGeom prst="rect">
+            <a:avLst/>
+          </a:prstGeom>
+          <a:noFill/>
+          <a:ln/>
+        </p:spPr>
+        <p:txBody>
+          <a:bodyPr wrap="square" lIns="254" tIns="254" rIns="254" bIns="254" rtlCol="0" anchor="ctr">
+            <a:normAutofit/>
+          </a:bodyPr>
+          <a:lstStyle/>
+          <a:p>
+            <a:pPr indent="0" marL="0">
+              <a:buNone/>
+            </a:pPr>
+            <a:r>
+              <a:rPr lang="en-US" sz="1100" dirty="0">
+                <a:solidFill>
+                  <a:srgbClr val="172322"/>
+                </a:solidFill>
+              </a:rPr>
+              <a:t>Revenue risk heatmap: renewal language + competitor mentions + negative sentiment.</a:t>
+            </a:r>
+            <a:endParaRPr lang="en-US" sz="1100" dirty="0"/>
+          </a:p>
+        </p:txBody>
+      </p:sp>
+      <p:sp>
+        <p:nvSpPr>
+          <p:cNvPr id="8" name="Shape 6"/>
+          <p:cNvSpPr/>
+          <p:nvPr/>
+        </p:nvSpPr>
+        <p:spPr>
+          <a:xfrm>
+            <a:off x="4434840" y="1645920"/>
+            <a:ext cx="3337560" cy="1051560"/>
+          </a:xfrm>
+          <a:prstGeom prst="roundRect">
+            <a:avLst>
+              <a:gd name="adj" fmla="val 6957"/>
+            </a:avLst>
+          </a:prstGeom>
+          <a:solidFill>
+            <a:srgbClr val="FFFFFF"/>
+          </a:solidFill>
+          <a:ln w="12700">
+            <a:solidFill>
+              <a:srgbClr val="D8D1C3"/>
+            </a:solidFill>
+            <a:prstDash val="solid"/>
+          </a:ln>
+        </p:spPr>
+      </p:sp>
+      <p:sp>
+        <p:nvSpPr>
+          <p:cNvPr id="9" name="Text 7"/>
+          <p:cNvSpPr/>
+          <p:nvPr/>
+        </p:nvSpPr>
+        <p:spPr>
+          <a:xfrm>
+            <a:off x="4636008" y="1810512"/>
+            <a:ext cx="1005840" cy="347472"/>
+          </a:xfrm>
+          <a:prstGeom prst="rect">
+            <a:avLst/>
+          </a:prstGeom>
+          <a:noFill/>
+          <a:ln/>
+        </p:spPr>
+        <p:txBody>
+          <a:bodyPr wrap="square" lIns="0" tIns="0" rIns="0" bIns="0" rtlCol="0" anchor="ctr">
+            <a:normAutofit/>
+          </a:bodyPr>
+          <a:lstStyle/>
+          <a:p>
+            <a:pPr indent="0" marL="0">
+              <a:buNone/>
+            </a:pPr>
+            <a:r>
+              <a:rPr lang="en-US" sz="2400" b="1" dirty="0">
+                <a:solidFill>
+                  <a:srgbClr val="C48A2C"/>
+                </a:solidFill>
+              </a:rPr>
+              <a:t>2</a:t>
+            </a:r>
+            <a:endParaRPr lang="en-US" sz="2400" dirty="0"/>
+          </a:p>
+        </p:txBody>
+      </p:sp>
+      <p:sp>
+        <p:nvSpPr>
+          <p:cNvPr id="10" name="Text 8"/>
+          <p:cNvSpPr/>
+          <p:nvPr/>
+        </p:nvSpPr>
+        <p:spPr>
+          <a:xfrm>
+            <a:off x="5641848" y="1810512"/>
+            <a:ext cx="1828800" cy="182880"/>
+          </a:xfrm>
+          <a:prstGeom prst="rect">
+            <a:avLst/>
+          </a:prstGeom>
+          <a:noFill/>
+          <a:ln/>
+        </p:spPr>
+        <p:txBody>
+          <a:bodyPr wrap="square" lIns="0" tIns="0" rIns="0" bIns="0" rtlCol="0" anchor="ctr">
+            <a:normAutofit/>
+          </a:bodyPr>
+          <a:lstStyle/>
+          <a:p>
+            <a:pPr indent="0" marL="0">
+              <a:buNone/>
+            </a:pPr>
+            <a:r>
+              <a:rPr lang="en-US" sz="900" b="1" dirty="0">
+                <a:solidFill>
+                  <a:srgbClr val="66716A"/>
+                </a:solidFill>
+              </a:rPr>
+              <a:t>Product</a:t>
+            </a:r>
+            <a:endParaRPr lang="en-US" sz="900" dirty="0"/>
+          </a:p>
+        </p:txBody>
+      </p:sp>
+      <p:sp>
+        <p:nvSpPr>
+          <p:cNvPr id="11" name="Text 9"/>
+          <p:cNvSpPr/>
+          <p:nvPr/>
+        </p:nvSpPr>
+        <p:spPr>
+          <a:xfrm>
+            <a:off x="5641848" y="2084832"/>
+            <a:ext cx="1828800" cy="411480"/>
+          </a:xfrm>
+          <a:prstGeom prst="rect">
+            <a:avLst/>
+          </a:prstGeom>
+          <a:noFill/>
+          <a:ln/>
+        </p:spPr>
+        <p:txBody>
+          <a:bodyPr wrap="square" lIns="254" tIns="254" rIns="254" bIns="254" rtlCol="0" anchor="ctr">
+            <a:normAutofit/>
+          </a:bodyPr>
+          <a:lstStyle/>
+          <a:p>
+            <a:pPr indent="0" marL="0">
+              <a:buNone/>
+            </a:pPr>
+            <a:r>
+              <a:rPr lang="en-US" sz="1100" dirty="0">
+                <a:solidFill>
+                  <a:srgbClr val="172322"/>
+                </a:solidFill>
+              </a:rPr>
+              <a:t>Product gap backlog: repeated pain points with quotes, accounts, and urgency.</a:t>
+            </a:r>
+            <a:endParaRPr lang="en-US" sz="1100" dirty="0"/>
+          </a:p>
+        </p:txBody>
+      </p:sp>
+      <p:sp>
+        <p:nvSpPr>
+          <p:cNvPr id="12" name="Shape 10"/>
+          <p:cNvSpPr/>
+          <p:nvPr/>
+        </p:nvSpPr>
+        <p:spPr>
+          <a:xfrm>
+            <a:off x="8183880" y="1645920"/>
+            <a:ext cx="3337560" cy="1051560"/>
+          </a:xfrm>
+          <a:prstGeom prst="roundRect">
+            <a:avLst>
+              <a:gd name="adj" fmla="val 6957"/>
+            </a:avLst>
+          </a:prstGeom>
+          <a:solidFill>
+            <a:srgbClr val="FFFFFF"/>
+          </a:solidFill>
+          <a:ln w="12700">
+            <a:solidFill>
+              <a:srgbClr val="D8D1C3"/>
+            </a:solidFill>
+            <a:prstDash val="solid"/>
+          </a:ln>
+        </p:spPr>
+      </p:sp>
+      <p:sp>
+        <p:nvSpPr>
+          <p:cNvPr id="13" name="Text 11"/>
+          <p:cNvSpPr/>
+          <p:nvPr/>
+        </p:nvSpPr>
+        <p:spPr>
+          <a:xfrm>
+            <a:off x="8385048" y="1810512"/>
+            <a:ext cx="1005840" cy="347472"/>
+          </a:xfrm>
+          <a:prstGeom prst="rect">
+            <a:avLst/>
+          </a:prstGeom>
+          <a:noFill/>
+          <a:ln/>
+        </p:spPr>
+        <p:txBody>
+          <a:bodyPr wrap="square" lIns="0" tIns="0" rIns="0" bIns="0" rtlCol="0" anchor="ctr">
+            <a:normAutofit/>
+          </a:bodyPr>
+          <a:lstStyle/>
+          <a:p>
+            <a:pPr indent="0" marL="0">
+              <a:buNone/>
+            </a:pPr>
+            <a:r>
+              <a:rPr lang="en-US" sz="2400" b="1" dirty="0">
+                <a:solidFill>
+                  <a:srgbClr val="4F7B58"/>
+                </a:solidFill>
+              </a:rPr>
+              <a:t>3</a:t>
+            </a:r>
+            <a:endParaRPr lang="en-US" sz="2400" dirty="0"/>
+          </a:p>
+        </p:txBody>
+      </p:sp>
+      <p:sp>
+        <p:nvSpPr>
+          <p:cNvPr id="14" name="Text 12"/>
+          <p:cNvSpPr/>
+          <p:nvPr/>
+        </p:nvSpPr>
+        <p:spPr>
+          <a:xfrm>
+            <a:off x="9390888" y="1810512"/>
+            <a:ext cx="1828800" cy="182880"/>
+          </a:xfrm>
+          <a:prstGeom prst="rect">
+            <a:avLst/>
+          </a:prstGeom>
+          <a:noFill/>
+          <a:ln/>
+        </p:spPr>
+        <p:txBody>
+          <a:bodyPr wrap="square" lIns="0" tIns="0" rIns="0" bIns="0" rtlCol="0" anchor="ctr">
+            <a:normAutofit/>
+          </a:bodyPr>
+          <a:lstStyle/>
+          <a:p>
+            <a:pPr indent="0" marL="0">
+              <a:buNone/>
+            </a:pPr>
+            <a:r>
+              <a:rPr lang="en-US" sz="900" b="1" dirty="0">
+                <a:solidFill>
+                  <a:srgbClr val="66716A"/>
+                </a:solidFill>
+              </a:rPr>
+              <a:t>Engineering</a:t>
+            </a:r>
+            <a:endParaRPr lang="en-US" sz="900" dirty="0"/>
+          </a:p>
+        </p:txBody>
+      </p:sp>
+      <p:sp>
+        <p:nvSpPr>
+          <p:cNvPr id="15" name="Text 13"/>
+          <p:cNvSpPr/>
+          <p:nvPr/>
+        </p:nvSpPr>
+        <p:spPr>
+          <a:xfrm>
+            <a:off x="9390888" y="2084832"/>
+            <a:ext cx="1828800" cy="411480"/>
+          </a:xfrm>
+          <a:prstGeom prst="rect">
+            <a:avLst/>
+          </a:prstGeom>
+          <a:noFill/>
+          <a:ln/>
+        </p:spPr>
+        <p:txBody>
+          <a:bodyPr wrap="square" lIns="254" tIns="254" rIns="254" bIns="254" rtlCol="0" anchor="ctr">
+            <a:normAutofit/>
+          </a:bodyPr>
+          <a:lstStyle/>
+          <a:p>
+            <a:pPr indent="0" marL="0">
+              <a:buNone/>
+            </a:pPr>
+            <a:r>
+              <a:rPr lang="en-US" sz="1100" dirty="0">
+                <a:solidFill>
+                  <a:srgbClr val="172322"/>
+                </a:solidFill>
+              </a:rPr>
+              <a:t>Incident learning loop: connect support pain to post-incident and sprint-planning follow-through.</a:t>
+            </a:r>
+            <a:endParaRPr lang="en-US" sz="1100" dirty="0"/>
+          </a:p>
+        </p:txBody>
+      </p:sp>
+      <p:sp>
+        <p:nvSpPr>
+          <p:cNvPr id="16" name="Text 14"/>
+          <p:cNvSpPr/>
+          <p:nvPr/>
+        </p:nvSpPr>
+        <p:spPr>
+          <a:xfrm>
+            <a:off x="914400" y="3840480"/>
+            <a:ext cx="9875520" cy="822960"/>
+          </a:xfrm>
+          <a:prstGeom prst="rect">
+            <a:avLst/>
+          </a:prstGeom>
+          <a:noFill/>
+          <a:ln/>
+        </p:spPr>
+        <p:txBody>
+          <a:bodyPr wrap="square" lIns="0" tIns="0" rIns="0" bIns="0" rtlCol="0" anchor="ctr">
+            <a:normAutofit/>
+          </a:bodyPr>
+          <a:lstStyle/>
+          <a:p>
+            <a:pPr algn="ctr" indent="0" marL="0">
+              <a:buNone/>
+            </a:pPr>
+            <a:r>
+              <a:rPr lang="en-US" sz="2200" b="1" dirty="0">
+                <a:solidFill>
+                  <a:srgbClr val="172322"/>
+                </a:solidFill>
+              </a:rPr>
+              <a:t>These are stakeholder workflows, not charts. The product should help each leader decide what to do next and where to look for evidence.</a:t>
+            </a:r>
+            <a:endParaRPr lang="en-US" sz="2200" dirty="0"/>
+          </a:p>
+        </p:txBody>
+      </p:sp>
+      <p:sp>
+        <p:nvSpPr>
+          <p:cNvPr id="17" name="Text 15"/>
+          <p:cNvSpPr/>
+          <p:nvPr/>
+        </p:nvSpPr>
+        <p:spPr>
+          <a:xfrm>
+            <a:off x="502920" y="6473952"/>
+            <a:ext cx="8686800" cy="164592"/>
+          </a:xfrm>
+          <a:prstGeom prst="rect">
+            <a:avLst/>
+          </a:prstGeom>
+          <a:noFill/>
+          <a:ln/>
+        </p:spPr>
+        <p:txBody>
+          <a:bodyPr wrap="square" lIns="0" tIns="0" rIns="0" bIns="0" rtlCol="0" anchor="ctr"/>
+          <a:lstStyle/>
+          <a:p>
+            <a:pPr indent="0" marL="0">
+              <a:buNone/>
+            </a:pPr>
+            <a:r>
+              <a:rPr lang="en-US" sz="700" dirty="0">
+                <a:solidFill>
+                  <a:srgbClr val="66716A"/>
+                </a:solidFill>
+              </a:rPr>
+              <a:t>Source: 100 provided transcript folders; generated by src/analyze_transcripts.py</a:t>
+            </a:r>
+            <a:endParaRPr lang="en-US" sz="700" dirty="0"/>
+          </a:p>
+        </p:txBody>
+      </p:sp>
+    </p:spTree>
+  </p:cSld>
+  <p:clrMapOvr>
+    <a:masterClrMapping/>
+  </p:clrMapOvr>
+</p:sld>
+</file>
+
+<file path=ppt/slides/slide13.xml><?xml version="1.0" encoding="utf-8"?>
+<p:sld xmlns:a="http://schemas.openxmlformats.org/drawingml/2006/main" xmlns:r="http://schemas.openxmlformats.org/officeDocument/2006/relationships" xmlns:p="http://schemas.openxmlformats.org/presentationml/2006/main">
+  <p:cSld name="Slide 13">
     <p:bg>
       <p:bgPr>
         <a:solidFill>

</xml_diff>

<commit_message>
Make leadership deck stakeholder-ready
</commit_message>
<xml_diff>
--- a/interview-assignment/deliverables/Transcript_Intelligence_Leadership_Deck.pptx
+++ b/interview-assignment/deliverables/Transcript_Intelligence_Leadership_Deck.pptx
@@ -2716,7 +2716,7 @@
                   <a:srgbClr val="FFFFFF"/>
                 </a:solidFill>
               </a:rPr>
-              <a:t>Senior AI Engineer take-home</a:t>
+              <a:t>Leadership briefing</a:t>
             </a:r>
             <a:endParaRPr lang="en-US" sz="1100" dirty="0"/>
           </a:p>
@@ -2754,7 +2754,7 @@
                   <a:srgbClr val="DCE9E5"/>
                 </a:solidFill>
               </a:rPr>
-              <a:t>Pipeline | RAG-style retrieval | gold-label eval | FastAPI review app</a:t>
+              <a:t>Customer risk | Product signals | Operating recommendations</a:t>
             </a:r>
             <a:endParaRPr lang="en-US" sz="1000" dirty="0"/>
           </a:p>
@@ -3649,7 +3649,7 @@
                   <a:srgbClr val="182322"/>
                 </a:solidFill>
               </a:rPr>
-              <a:t>A senior AI system should not stop at generated charts. The repo now includes a 20-meeting gold-label sample and reports accuracy plus precision/recall/F1. In production, this expands into a stratified validation set, reviewer agreement, regression tests, and drift monitoring.</a:t>
+              <a:t>A senior AI system should not stop at generated charts. The solution includes a 20-meeting gold-label sample and reports accuracy plus precision/recall/F1. In production, this expands into a stratified validation set, reviewer agreement, regression tests, and drift monitoring.</a:t>
             </a:r>
             <a:endParaRPr lang="en-US" sz="1450" dirty="0"/>
           </a:p>
@@ -3870,7 +3870,7 @@
                   <a:srgbClr val="66716A"/>
                 </a:solidFill>
               </a:rPr>
-              <a:t>PLATFORM</a:t>
+              <a:t>OPERATING MODEL</a:t>
             </a:r>
             <a:endParaRPr lang="en-US" sz="700" dirty="0"/>
           </a:p>
@@ -3973,7 +3973,7 @@
                 <a:ea typeface="Aptos Display" pitchFamily="34" charset="-122"/>
                 <a:cs typeface="Aptos Display" pitchFamily="34" charset="-120"/>
               </a:rPr>
-              <a:t>Production extensions: real embeddings, API service, and tests</a:t>
+              <a:t>Trusted AI requires evidence, review loops, and quality guardrails</a:t>
             </a:r>
             <a:endParaRPr lang="en-US" sz="2500" dirty="0"/>
           </a:p>
@@ -4065,7 +4065,7 @@
                   <a:srgbClr val="66716A"/>
                 </a:solidFill>
               </a:rPr>
-              <a:t>EMBEDDINGS</a:t>
+              <a:t>SEMANTIC RETRIEVAL</a:t>
             </a:r>
             <a:endParaRPr lang="en-US" sz="750" dirty="0"/>
           </a:p>
@@ -4103,7 +4103,7 @@
                   <a:srgbClr val="236A70"/>
                 </a:solidFill>
               </a:rPr>
-              <a:t>OpenAI</a:t>
+              <a:t>Embeddings</a:t>
             </a:r>
             <a:endParaRPr lang="en-US" sz="2500" dirty="0"/>
           </a:p>
@@ -4141,7 +4141,7 @@
                   <a:srgbClr val="182322"/>
                 </a:solidFill>
               </a:rPr>
-              <a:t>Optional real retrieval via text-embedding-3-small when OPENAI_API_KEY is set.</a:t>
+              <a:t>Use real embeddings to retrieve transcript evidence for leadership questions.</a:t>
             </a:r>
             <a:endParaRPr lang="en-US" sz="1040" dirty="0"/>
           </a:p>
@@ -4233,7 +4233,7 @@
                   <a:srgbClr val="66716A"/>
                 </a:solidFill>
               </a:rPr>
-              <a:t>API</a:t>
+              <a:t>REVIEW WORKFLOW</a:t>
             </a:r>
             <a:endParaRPr lang="en-US" sz="750" dirty="0"/>
           </a:p>
@@ -4271,7 +4271,7 @@
                   <a:srgbClr val="4D7C5B"/>
                 </a:solidFill>
               </a:rPr>
-              <a:t>FastAPI</a:t>
+              <a:t>Human loop</a:t>
             </a:r>
             <a:endParaRPr lang="en-US" sz="2500" dirty="0"/>
           </a:p>
@@ -4309,7 +4309,7 @@
                   <a:srgbClr val="182322"/>
                 </a:solidFill>
               </a:rPr>
-              <a:t>Review endpoints for summary, meetings, retrieval examples, and human-review queue.</a:t>
+              <a:t>Route ambiguous or high-risk conversations to accountable owners.</a:t>
             </a:r>
             <a:endParaRPr lang="en-US" sz="1040" dirty="0"/>
           </a:p>
@@ -4401,7 +4401,7 @@
                   <a:srgbClr val="66716A"/>
                 </a:solidFill>
               </a:rPr>
-              <a:t>TESTS</a:t>
+              <a:t>QUALITY GUARDRAILS</a:t>
             </a:r>
             <a:endParaRPr lang="en-US" sz="750" dirty="0"/>
           </a:p>
@@ -4439,7 +4439,7 @@
                   <a:srgbClr val="C18A2E"/>
                 </a:solidFill>
               </a:rPr>
-              <a:t>6</a:t>
+              <a:t>Eval</a:t>
             </a:r>
             <a:endParaRPr lang="en-US" sz="2500" dirty="0"/>
           </a:p>
@@ -4477,7 +4477,7 @@
                   <a:srgbClr val="182322"/>
                 </a:solidFill>
               </a:rPr>
-              <a:t>Unit coverage for classifier, routing, gold eval, and vector similarity behavior.</a:t>
+              <a:t>Use gold labels and regression tests to monitor routing quality.</a:t>
             </a:r>
             <a:endParaRPr lang="en-US" sz="1040" dirty="0"/>
           </a:p>
@@ -4605,7 +4605,7 @@
                   <a:srgbClr val="182322"/>
                 </a:solidFill>
               </a:rPr>
-              <a:t>The repo remains easy to run locally, but the architecture now has clear production interfaces: swap TF-IDF retrieval for embeddings, expose review workflows through an API, and protect behavior with tests and gold-label regression checks.</a:t>
+              <a:t>This is the production operating model: evidence-grounded retrieval, confidence thresholds, human review for sensitive decisions, and continuous evaluation as new transcripts arrive.</a:t>
             </a:r>
             <a:endParaRPr lang="en-US" sz="1450" dirty="0"/>
           </a:p>
@@ -5795,7 +5795,7 @@
                 <a:ea typeface="Aptos Display" pitchFamily="34" charset="-122"/>
                 <a:cs typeface="Aptos Display" pitchFamily="34" charset="-120"/>
               </a:rPr>
-              <a:t>Recommended next build</a:t>
+              <a:t>Recommended executive decisions</a:t>
             </a:r>
             <a:endParaRPr lang="en-US" sz="2500" dirty="0"/>
           </a:p>
@@ -5830,7 +5830,7 @@
                   <a:srgbClr val="182322"/>
                 </a:solidFill>
               </a:rPr>
-              <a:t>Ship a theme and risk dashboard for Detect reliability first.</a:t>
+              <a:t>Prioritize Detect reliability as the first operating review because it carries the highest customer and commercial risk.</a:t>
             </a:r>
             <a:endParaRPr lang="en-US" sz="1800" dirty="0"/>
           </a:p>
@@ -5841,7 +5841,7 @@
                   <a:srgbClr val="182322"/>
                 </a:solidFill>
               </a:rPr>
-              <a:t>Add account-level revenue risk overlays for renewal and competitive calls.</a:t>
+              <a:t>Stand up account-level revenue risk signals for renewal and competitive calls.</a:t>
             </a:r>
             <a:endParaRPr lang="en-US" sz="1800" dirty="0"/>
           </a:p>
@@ -5852,7 +5852,7 @@
                   <a:srgbClr val="182322"/>
                 </a:solidFill>
               </a:rPr>
-              <a:t>Add owner extraction so action items become trackable workflow, not static notes.</a:t>
+              <a:t>Convert repeated product gaps into owner-ready roadmap items with transcript evidence.</a:t>
             </a:r>
             <a:endParaRPr lang="en-US" sz="1800" dirty="0"/>
           </a:p>
@@ -5863,7 +5863,7 @@
                   <a:srgbClr val="182322"/>
                 </a:solidFill>
               </a:rPr>
-              <a:t>Upgrade classifier with embeddings or LLM labels, keeping the rule layer as explainable QA.</a:t>
+              <a:t>Adopt a human-in-the-loop governance model before automating customer-impacting actions.</a:t>
             </a:r>
             <a:endParaRPr lang="en-US" sz="1800" dirty="0"/>
           </a:p>
@@ -5926,7 +5926,7 @@
                   <a:srgbClr val="182322"/>
                 </a:solidFill>
               </a:rPr>
-              <a:t>Demo path</a:t>
+              <a:t>Decision asks</a:t>
             </a:r>
             <a:endParaRPr lang="en-US" sz="1800" dirty="0"/>
           </a:p>
@@ -5964,7 +5964,7 @@
                   <a:srgbClr val="182322"/>
                 </a:solidFill>
               </a:rPr>
-              <a:t>1. Run src/analyze_transcripts.py</a:t>
+              <a:t>1. Assign an executive owner for Detect reliability signals</a:t>
             </a:r>
             <a:endParaRPr lang="en-US" sz="1500" dirty="0"/>
           </a:p>
@@ -5978,7 +5978,7 @@
                   <a:srgbClr val="182322"/>
                 </a:solidFill>
               </a:rPr>
-              <a:t>2. Open outputs/dashboard.html</a:t>
+              <a:t>2. Align Product, CS, and Engineering on risk thresholds</a:t>
             </a:r>
             <a:endParaRPr lang="en-US" sz="1500" dirty="0"/>
           </a:p>
@@ -5992,7 +5992,7 @@
                   <a:srgbClr val="182322"/>
                 </a:solidFill>
               </a:rPr>
-              <a:t>3. Review analysis_report.md</a:t>
+              <a:t>3. Expand gold-label evaluation before production routing</a:t>
             </a:r>
             <a:endParaRPr lang="en-US" sz="1500" dirty="0"/>
           </a:p>
@@ -6006,21 +6006,7 @@
                   <a:srgbClr val="182322"/>
                 </a:solidFill>
               </a:rPr>
-              <a:t>4. Walk through this deck</a:t>
-            </a:r>
-            <a:endParaRPr lang="en-US" sz="1500" dirty="0"/>
-          </a:p>
-          <a:p>
-            <a:pPr indent="0" marL="0">
-              <a:buNone/>
-            </a:pPr>
-            <a:r>
-              <a:rPr lang="en-US" sz="1500" dirty="0">
-                <a:solidFill>
-                  <a:srgbClr val="182322"/>
-                </a:solidFill>
-              </a:rPr>
-              <a:t>5. Show highest-risk CSV rows</a:t>
+              <a:t>4. Pilot retrieval-backed account reviews with CS leaders</a:t>
             </a:r>
             <a:endParaRPr lang="en-US" sz="1500" dirty="0"/>
           </a:p>
@@ -7229,7 +7215,7 @@
                 <a:ea typeface="Aptos Display" pitchFamily="34" charset="-122"/>
                 <a:cs typeface="Aptos Display" pitchFamily="34" charset="-120"/>
               </a:rPr>
-              <a:t>A transparent hybrid classifier is the right first system</a:t>
+              <a:t>A trusted insight workflow beats a black-box classifier</a:t>
             </a:r>
             <a:endParaRPr lang="en-US" sz="2500" dirty="0"/>
           </a:p>
@@ -7319,7 +7305,7 @@
                   <a:srgbClr val="236A70"/>
                 </a:solidFill>
               </a:rPr>
-              <a:t>Pipeline</a:t>
+              <a:t>Operating flow</a:t>
             </a:r>
             <a:endParaRPr lang="en-US" sz="1350" dirty="0"/>
           </a:p>
@@ -7357,7 +7343,7 @@
                   <a:srgbClr val="182322"/>
                 </a:solidFill>
               </a:rPr>
-              <a:t>Raw JSON folders -&gt; summaries/topics/key moments -&gt; rule-scored call type, theme, product surface, sentiment, risk -&gt; CSV/JSON/HTML/deck outputs</a:t>
+              <a:t>Transcript evidence -&gt; theme, sentiment, product, risk -&gt; leadership-ready account and product signals</a:t>
             </a:r>
             <a:endParaRPr lang="en-US" sz="1450" dirty="0"/>
           </a:p>
@@ -7392,7 +7378,7 @@
                   <a:srgbClr val="182322"/>
                 </a:solidFill>
               </a:rPr>
-              <a:t>Explainable enough for product and engineering Q&amp;A.</a:t>
+              <a:t>Transparent enough for Product, Engineering, CS, and GTM leaders to trust.</a:t>
             </a:r>
             <a:endParaRPr lang="en-US" sz="1600" dirty="0"/>
           </a:p>
@@ -7403,7 +7389,7 @@
                   <a:srgbClr val="182322"/>
                 </a:solidFill>
               </a:rPr>
-              <a:t>Repeatable with no external services or API keys.</a:t>
+              <a:t>Grounded in transcript evidence, not unsupported summaries.</a:t>
             </a:r>
             <a:endParaRPr lang="en-US" sz="1600" dirty="0"/>
           </a:p>
@@ -7414,7 +7400,7 @@
                   <a:srgbClr val="182322"/>
                 </a:solidFill>
               </a:rPr>
-              <a:t>Easy to replace theme rules with embeddings or LLM labels later while keeping audit guardrails.</a:t>
+              <a:t>Designed to scale into embeddings, LLM extraction, and human review without losing auditability.</a:t>
             </a:r>
             <a:endParaRPr lang="en-US" sz="1600" dirty="0"/>
           </a:p>
@@ -7456,7 +7442,7 @@
         <p:spPr>
           <a:xfrm>
             <a:off x="6720840" y="1847088"/>
-            <a:ext cx="2194560" cy="292608"/>
+            <a:ext cx="2560320" cy="292608"/>
           </a:xfrm>
           <a:prstGeom prst="rect">
             <a:avLst/>
@@ -7477,7 +7463,7 @@
                   <a:srgbClr val="182322"/>
                 </a:solidFill>
               </a:rPr>
-              <a:t>Core outputs</a:t>
+              <a:t>Leadership surfaces</a:t>
             </a:r>
             <a:endParaRPr lang="en-US" sz="1800" dirty="0"/>
           </a:p>
@@ -7515,7 +7501,7 @@
                   <a:srgbClr val="182322"/>
                 </a:solidFill>
               </a:rPr>
-              <a:t>meeting_analysis.csv</a:t>
+              <a:t>Theme and sentiment trends</a:t>
             </a:r>
             <a:endParaRPr lang="en-US" sz="1500" dirty="0"/>
           </a:p>
@@ -7529,7 +7515,7 @@
                   <a:srgbClr val="182322"/>
                 </a:solidFill>
               </a:rPr>
-              <a:t>summary_metrics.json</a:t>
+              <a:t>High-risk account evidence</a:t>
             </a:r>
             <a:endParaRPr lang="en-US" sz="1500" dirty="0"/>
           </a:p>
@@ -7543,7 +7529,7 @@
                   <a:srgbClr val="182322"/>
                 </a:solidFill>
               </a:rPr>
-              <a:t>analysis_report.md</a:t>
+              <a:t>Product surface risk</a:t>
             </a:r>
             <a:endParaRPr lang="en-US" sz="1500" dirty="0"/>
           </a:p>
@@ -7557,7 +7543,7 @@
                   <a:srgbClr val="182322"/>
                 </a:solidFill>
               </a:rPr>
-              <a:t>dashboard.html</a:t>
+              <a:t>Human-review queue</a:t>
             </a:r>
             <a:endParaRPr lang="en-US" sz="1500" dirty="0"/>
           </a:p>
@@ -7571,7 +7557,7 @@
                   <a:srgbClr val="182322"/>
                 </a:solidFill>
               </a:rPr>
-              <a:t>Transcript_Intelligence_Leadership_Deck.pptx</a:t>
+              <a:t>Gold-label quality checks</a:t>
             </a:r>
             <a:endParaRPr lang="en-US" sz="1500" dirty="0"/>
           </a:p>
@@ -11205,7 +11191,7 @@
                   <a:srgbClr val="182322"/>
                 </a:solidFill>
               </a:rPr>
-              <a:t>Use transcript intelligence as a product risk router: extract the affected product, evidence quote, account, sentiment, and action owner. Detect should be the first executive dashboard surface because outages, SIEM connectors, alert quality, and competitive gaps recur across call types.</a:t>
+              <a:t>Use transcript intelligence as a product risk router: extract the affected product, evidence quote, account, sentiment, and action owner. Detect should be the first leadership operating surface because outages, SIEM connectors, alert quality, and competitive gaps recur across call types.</a:t>
             </a:r>
             <a:endParaRPr lang="en-US" sz="1450" dirty="0"/>
           </a:p>
@@ -15081,7 +15067,7 @@
                   <a:srgbClr val="182322"/>
                 </a:solidFill>
               </a:rPr>
-              <a:t>The current repo uses dependency-free TF-IDF retrieval as a RAG-style prototype. In production, I would replace this with embedding search, LLM extraction constrained to retrieved transcript evidence, confidence thresholds, and human review for ambiguous or high-risk account conversations.</a:t>
+              <a:t>The current solution uses dependency-free TF-IDF retrieval as a RAG-style prototype. In production, I would replace this with embedding search, LLM extraction constrained to retrieved transcript evidence, confidence thresholds, and human review for ambiguous or high-risk account conversations.</a:t>
             </a:r>
             <a:endParaRPr lang="en-US" sz="1450" dirty="0"/>
           </a:p>

</xml_diff>

<commit_message>
Refine deck voice for senior AI presentation
</commit_message>
<xml_diff>
--- a/interview-assignment/deliverables/Transcript_Intelligence_Leadership_Deck.pptx
+++ b/interview-assignment/deliverables/Transcript_Intelligence_Leadership_Deck.pptx
@@ -4929,7 +4929,7 @@
                 <a:ea typeface="Aptos Display" pitchFamily="34" charset="-122"/>
                 <a:cs typeface="Aptos Display" pitchFamily="34" charset="-120"/>
               </a:rPr>
-              <a:t>Three insight products would make this valuable beyond analysis</a:t>
+              <a:t>I translated transcript analysis into three AI-enabled operating workflows</a:t>
             </a:r>
             <a:endParaRPr lang="en-US" sz="2500" dirty="0"/>
           </a:p>
@@ -5097,7 +5097,7 @@
                   <a:srgbClr val="182322"/>
                 </a:solidFill>
               </a:rPr>
-              <a:t>Revenue risk heatmap: renewal language + competitor mentions + negative sentiment.</a:t>
+              <a:t>Revenue risk signal: renewal language + competitor mentions + negative sentiment.</a:t>
             </a:r>
             <a:endParaRPr lang="en-US" sz="1040" dirty="0"/>
           </a:p>
@@ -5265,7 +5265,7 @@
                   <a:srgbClr val="182322"/>
                 </a:solidFill>
               </a:rPr>
-              <a:t>Product gap backlog: repeated pain points with quotes, accounts, and urgency.</a:t>
+              <a:t>Product gap backlog: repeated pain points with evidence, accounts, and urgency.</a:t>
             </a:r>
             <a:endParaRPr lang="en-US" sz="1040" dirty="0"/>
           </a:p>
@@ -5433,7 +5433,7 @@
                   <a:srgbClr val="182322"/>
                 </a:solidFill>
               </a:rPr>
-              <a:t>Incident learning loop: connect support pain to post-incident and sprint-planning follow-through.</a:t>
+              <a:t>Incident learning loop: connect support pain to post-incident and roadmap follow-through.</a:t>
             </a:r>
             <a:endParaRPr lang="en-US" sz="1040" dirty="0"/>
           </a:p>
@@ -5471,7 +5471,7 @@
                   <a:srgbClr val="182322"/>
                 </a:solidFill>
               </a:rPr>
-              <a:t>These are stakeholder workflows, not charts. The product should help each leader decide what to do next and where to look for evidence.</a:t>
+              <a:t>My design goal was to move beyond summarization: extract evidence, score risk, route the right owner, and create review loops that leaders can trust.</a:t>
             </a:r>
             <a:endParaRPr lang="en-US" sz="2200" dirty="0"/>
           </a:p>

</xml_diff>

<commit_message>
Fix deck decision asks layout
</commit_message>
<xml_diff>
--- a/interview-assignment/deliverables/Transcript_Intelligence_Leadership_Deck.pptx
+++ b/interview-assignment/deliverables/Transcript_Intelligence_Leadership_Deck.pptx
@@ -5877,12 +5877,12 @@
         </p:nvSpPr>
         <p:spPr>
           <a:xfrm>
-            <a:off x="7315200" y="1645920"/>
-            <a:ext cx="3291840" cy="3108960"/>
+            <a:off x="7086600" y="1572768"/>
+            <a:ext cx="3794760" cy="3703320"/>
           </a:xfrm>
           <a:prstGeom prst="roundRect">
             <a:avLst>
-              <a:gd name="adj" fmla="val 2353"/>
+              <a:gd name="adj" fmla="val 1975"/>
             </a:avLst>
           </a:prstGeom>
           <a:solidFill>
@@ -5904,8 +5904,8 @@
         </p:nvSpPr>
         <p:spPr>
           <a:xfrm>
-            <a:off x="7635240" y="1920240"/>
-            <a:ext cx="2011680" cy="274320"/>
+            <a:off x="7388352" y="1847088"/>
+            <a:ext cx="2788920" cy="310896"/>
           </a:xfrm>
           <a:prstGeom prst="rect">
             <a:avLst/>
@@ -5921,14 +5921,14 @@
               <a:buNone/>
             </a:pPr>
             <a:r>
-              <a:rPr lang="en-US" sz="1800" b="1" dirty="0">
+              <a:rPr lang="en-US" sz="1700" b="1" dirty="0">
                 <a:solidFill>
                   <a:srgbClr val="182322"/>
                 </a:solidFill>
               </a:rPr>
               <a:t>Decision asks</a:t>
             </a:r>
-            <a:endParaRPr lang="en-US" sz="1800" dirty="0"/>
+            <a:endParaRPr lang="en-US" sz="1700" dirty="0"/>
           </a:p>
         </p:txBody>
       </p:sp>
@@ -5940,8 +5940,8 @@
         </p:nvSpPr>
         <p:spPr>
           <a:xfrm>
-            <a:off x="7635240" y="2423160"/>
-            <a:ext cx="2560320" cy="1554480"/>
+            <a:off x="7388352" y="2487168"/>
+            <a:ext cx="3154680" cy="2057400"/>
           </a:xfrm>
           <a:prstGeom prst="rect">
             <a:avLst/>
@@ -5959,56 +5959,74 @@
               <a:buNone/>
             </a:pPr>
             <a:r>
-              <a:rPr lang="en-US" sz="1500" dirty="0">
+              <a:rPr lang="en-US" sz="1300" dirty="0">
                 <a:solidFill>
                   <a:srgbClr val="182322"/>
                 </a:solidFill>
               </a:rPr>
-              <a:t>1. Assign an executive owner for Detect reliability signals</a:t>
-            </a:r>
-            <a:endParaRPr lang="en-US" sz="1500" dirty="0"/>
-          </a:p>
-          <a:p>
-            <a:pPr indent="0" marL="0">
-              <a:buNone/>
-            </a:pPr>
-            <a:r>
-              <a:rPr lang="en-US" sz="1500" dirty="0">
+              <a:t>Owner: Detect reliability signal</a:t>
+            </a:r>
+            <a:endParaRPr lang="en-US" sz="1300" dirty="0"/>
+          </a:p>
+          <a:p>
+            <a:pPr indent="0" marL="0">
+              <a:buNone/>
+            </a:pPr>
+            <a:endParaRPr lang="en-US" sz="1300" dirty="0"/>
+          </a:p>
+          <a:p>
+            <a:pPr indent="0" marL="0">
+              <a:buNone/>
+            </a:pPr>
+            <a:r>
+              <a:rPr lang="en-US" sz="1300" dirty="0">
                 <a:solidFill>
                   <a:srgbClr val="182322"/>
                 </a:solidFill>
               </a:rPr>
-              <a:t>2. Align Product, CS, and Engineering on risk thresholds</a:t>
-            </a:r>
-            <a:endParaRPr lang="en-US" sz="1500" dirty="0"/>
-          </a:p>
-          <a:p>
-            <a:pPr indent="0" marL="0">
-              <a:buNone/>
-            </a:pPr>
-            <a:r>
-              <a:rPr lang="en-US" sz="1500" dirty="0">
+              <a:t>Thresholds: Product, CS, and Engineering</a:t>
+            </a:r>
+            <a:endParaRPr lang="en-US" sz="1300" dirty="0"/>
+          </a:p>
+          <a:p>
+            <a:pPr indent="0" marL="0">
+              <a:buNone/>
+            </a:pPr>
+            <a:endParaRPr lang="en-US" sz="1300" dirty="0"/>
+          </a:p>
+          <a:p>
+            <a:pPr indent="0" marL="0">
+              <a:buNone/>
+            </a:pPr>
+            <a:r>
+              <a:rPr lang="en-US" sz="1300" dirty="0">
                 <a:solidFill>
                   <a:srgbClr val="182322"/>
                 </a:solidFill>
               </a:rPr>
-              <a:t>3. Expand gold-label evaluation before production routing</a:t>
-            </a:r>
-            <a:endParaRPr lang="en-US" sz="1500" dirty="0"/>
-          </a:p>
-          <a:p>
-            <a:pPr indent="0" marL="0">
-              <a:buNone/>
-            </a:pPr>
-            <a:r>
-              <a:rPr lang="en-US" sz="1500" dirty="0">
+              <a:t>Eval: expand gold-label coverage</a:t>
+            </a:r>
+            <a:endParaRPr lang="en-US" sz="1300" dirty="0"/>
+          </a:p>
+          <a:p>
+            <a:pPr indent="0" marL="0">
+              <a:buNone/>
+            </a:pPr>
+            <a:endParaRPr lang="en-US" sz="1300" dirty="0"/>
+          </a:p>
+          <a:p>
+            <a:pPr indent="0" marL="0">
+              <a:buNone/>
+            </a:pPr>
+            <a:r>
+              <a:rPr lang="en-US" sz="1300" dirty="0">
                 <a:solidFill>
                   <a:srgbClr val="182322"/>
                 </a:solidFill>
               </a:rPr>
-              <a:t>4. Pilot retrieval-backed account reviews with CS leaders</a:t>
-            </a:r>
-            <a:endParaRPr lang="en-US" sz="1500" dirty="0"/>
+              <a:t>Pilot: retrieval-backed CS reviews</a:t>
+            </a:r>
+            <a:endParaRPr lang="en-US" sz="1300" dirty="0"/>
           </a:p>
         </p:txBody>
       </p:sp>

</xml_diff>

<commit_message>
Add presenter name to leadership deck
</commit_message>
<xml_diff>
--- a/interview-assignment/deliverables/Transcript_Intelligence_Leadership_Deck.pptx
+++ b/interview-assignment/deliverables/Transcript_Intelligence_Leadership_Deck.pptx
@@ -2145,7 +2145,43 @@
       </p:sp>
       <p:sp>
         <p:nvSpPr>
-          <p:cNvPr id="8" name="Shape 6"/>
+          <p:cNvPr id="8" name="Text 6"/>
+          <p:cNvSpPr/>
+          <p:nvPr/>
+        </p:nvSpPr>
+        <p:spPr>
+          <a:xfrm>
+            <a:off x="694944" y="2697480"/>
+            <a:ext cx="3017520" cy="256032"/>
+          </a:xfrm>
+          <a:prstGeom prst="rect">
+            <a:avLst/>
+          </a:prstGeom>
+          <a:noFill/>
+          <a:ln/>
+        </p:spPr>
+        <p:txBody>
+          <a:bodyPr wrap="square" lIns="0" tIns="0" rIns="0" bIns="0" rtlCol="0" anchor="ctr"/>
+          <a:lstStyle/>
+          <a:p>
+            <a:pPr indent="0" marL="0">
+              <a:buNone/>
+            </a:pPr>
+            <a:r>
+              <a:rPr lang="en-US" sz="1100" b="1" dirty="0">
+                <a:solidFill>
+                  <a:srgbClr val="C18A2E"/>
+                </a:solidFill>
+              </a:rPr>
+              <a:t>Prepared by Srikaveri Gude</a:t>
+            </a:r>
+            <a:endParaRPr lang="en-US" sz="1100" dirty="0"/>
+          </a:p>
+        </p:txBody>
+      </p:sp>
+      <p:sp>
+        <p:nvSpPr>
+          <p:cNvPr id="9" name="Shape 7"/>
           <p:cNvSpPr/>
           <p:nvPr/>
         </p:nvSpPr>
@@ -2176,7 +2212,7 @@
       </p:sp>
       <p:sp>
         <p:nvSpPr>
-          <p:cNvPr id="9" name="Text 7"/>
+          <p:cNvPr id="10" name="Text 8"/>
           <p:cNvSpPr/>
           <p:nvPr/>
         </p:nvSpPr>
@@ -2214,7 +2250,7 @@
       </p:sp>
       <p:sp>
         <p:nvSpPr>
-          <p:cNvPr id="10" name="Shape 8"/>
+          <p:cNvPr id="11" name="Shape 9"/>
           <p:cNvSpPr/>
           <p:nvPr/>
         </p:nvSpPr>
@@ -2245,7 +2281,7 @@
       </p:sp>
       <p:sp>
         <p:nvSpPr>
-          <p:cNvPr id="11" name="Text 9"/>
+          <p:cNvPr id="12" name="Text 10"/>
           <p:cNvSpPr/>
           <p:nvPr/>
         </p:nvSpPr>
@@ -2283,7 +2319,7 @@
       </p:sp>
       <p:sp>
         <p:nvSpPr>
-          <p:cNvPr id="12" name="Shape 10"/>
+          <p:cNvPr id="13" name="Shape 11"/>
           <p:cNvSpPr/>
           <p:nvPr/>
         </p:nvSpPr>
@@ -2314,7 +2350,7 @@
       </p:sp>
       <p:sp>
         <p:nvSpPr>
-          <p:cNvPr id="13" name="Text 11"/>
+          <p:cNvPr id="14" name="Text 12"/>
           <p:cNvSpPr/>
           <p:nvPr/>
         </p:nvSpPr>
@@ -2352,7 +2388,7 @@
       </p:sp>
       <p:sp>
         <p:nvSpPr>
-          <p:cNvPr id="14" name="Shape 12"/>
+          <p:cNvPr id="15" name="Shape 13"/>
           <p:cNvSpPr/>
           <p:nvPr/>
         </p:nvSpPr>
@@ -2379,7 +2415,7 @@
       </p:sp>
       <p:sp>
         <p:nvSpPr>
-          <p:cNvPr id="15" name="Shape 13"/>
+          <p:cNvPr id="16" name="Shape 14"/>
           <p:cNvSpPr/>
           <p:nvPr/>
         </p:nvSpPr>
@@ -2406,7 +2442,7 @@
       </p:sp>
       <p:sp>
         <p:nvSpPr>
-          <p:cNvPr id="16" name="Text 14"/>
+          <p:cNvPr id="17" name="Text 15"/>
           <p:cNvSpPr/>
           <p:nvPr/>
         </p:nvSpPr>
@@ -2444,7 +2480,7 @@
       </p:sp>
       <p:sp>
         <p:nvSpPr>
-          <p:cNvPr id="17" name="Text 15"/>
+          <p:cNvPr id="18" name="Text 16"/>
           <p:cNvSpPr/>
           <p:nvPr/>
         </p:nvSpPr>
@@ -2482,7 +2518,7 @@
       </p:sp>
       <p:sp>
         <p:nvSpPr>
-          <p:cNvPr id="18" name="Text 16"/>
+          <p:cNvPr id="19" name="Text 17"/>
           <p:cNvSpPr/>
           <p:nvPr/>
         </p:nvSpPr>
@@ -2520,7 +2556,7 @@
       </p:sp>
       <p:sp>
         <p:nvSpPr>
-          <p:cNvPr id="19" name="Shape 17"/>
+          <p:cNvPr id="20" name="Shape 18"/>
           <p:cNvSpPr/>
           <p:nvPr/>
         </p:nvSpPr>
@@ -2547,7 +2583,7 @@
       </p:sp>
       <p:sp>
         <p:nvSpPr>
-          <p:cNvPr id="20" name="Shape 18"/>
+          <p:cNvPr id="21" name="Shape 19"/>
           <p:cNvSpPr/>
           <p:nvPr/>
         </p:nvSpPr>
@@ -2574,7 +2610,7 @@
       </p:sp>
       <p:sp>
         <p:nvSpPr>
-          <p:cNvPr id="21" name="Text 19"/>
+          <p:cNvPr id="22" name="Text 20"/>
           <p:cNvSpPr/>
           <p:nvPr/>
         </p:nvSpPr>
@@ -2612,7 +2648,7 @@
       </p:sp>
       <p:sp>
         <p:nvSpPr>
-          <p:cNvPr id="22" name="Text 20"/>
+          <p:cNvPr id="23" name="Text 21"/>
           <p:cNvSpPr/>
           <p:nvPr/>
         </p:nvSpPr>
@@ -2650,7 +2686,7 @@
       </p:sp>
       <p:sp>
         <p:nvSpPr>
-          <p:cNvPr id="23" name="Text 21"/>
+          <p:cNvPr id="24" name="Text 22"/>
           <p:cNvSpPr/>
           <p:nvPr/>
         </p:nvSpPr>
@@ -2688,7 +2724,7 @@
       </p:sp>
       <p:sp>
         <p:nvSpPr>
-          <p:cNvPr id="24" name="Text 22"/>
+          <p:cNvPr id="25" name="Text 23"/>
           <p:cNvSpPr/>
           <p:nvPr/>
         </p:nvSpPr>
@@ -2724,7 +2760,7 @@
       </p:sp>
       <p:sp>
         <p:nvSpPr>
-          <p:cNvPr id="25" name="Text 23"/>
+          <p:cNvPr id="26" name="Text 24"/>
           <p:cNvSpPr/>
           <p:nvPr/>
         </p:nvSpPr>

</xml_diff>